<commit_message>
Deploying to gh-pages from @ lydiareiter/fh-creative-portfolio@76139cf17864ed97107098a0a62018d130184819 🚀
</commit_message>
<xml_diff>
--- a/zwischenpräsentation.pptx
+++ b/zwischenpräsentation.pptx
@@ -4,14 +4,15 @@
   <p:sldMasterIdLst>
     <p:sldMasterId id="2147483648" r:id="rId1"/>
   </p:sldMasterIdLst>
+  <p:notesMasterIdLst>
+    <p:notesMasterId r:id="rId7"/>
+  </p:notesMasterIdLst>
   <p:sldIdLst>
-    <p:sldId id="256" r:id="rId2"/>
-    <p:sldId id="257" r:id="rId3"/>
-    <p:sldId id="258" r:id="rId4"/>
-    <p:sldId id="262" r:id="rId5"/>
-    <p:sldId id="263" r:id="rId6"/>
-    <p:sldId id="264" r:id="rId7"/>
-    <p:sldId id="265" r:id="rId8"/>
+    <p:sldId id="262" r:id="rId2"/>
+    <p:sldId id="266" r:id="rId3"/>
+    <p:sldId id="263" r:id="rId4"/>
+    <p:sldId id="264" r:id="rId5"/>
+    <p:sldId id="265" r:id="rId6"/>
   </p:sldIdLst>
   <p:sldSz cx="12192000" cy="6858000"/>
   <p:notesSz cx="6858000" cy="9144000"/>
@@ -110,3003 +111,554 @@
       </a:defRPr>
     </a:lvl9pPr>
   </p:defaultTextStyle>
+  <p:extLst>
+    <p:ext uri="{EFAFB233-063F-42B5-8137-9DF3F51BA10A}">
+      <p15:sldGuideLst xmlns:p15="http://schemas.microsoft.com/office/powerpoint/2012/main"/>
+    </p:ext>
+  </p:extLst>
 </p:presentation>
 </file>
 
-<file path=ppt/diagrams/colors1.xml><?xml version="1.0" encoding="utf-8"?>
-<dgm:colorsDef xmlns:dgm="http://schemas.openxmlformats.org/drawingml/2006/diagram" xmlns:a="http://schemas.openxmlformats.org/drawingml/2006/main" uniqueId="urn:microsoft.com/office/officeart/2005/8/colors/accent1_2">
-  <dgm:title val=""/>
-  <dgm:desc val=""/>
-  <dgm:catLst>
-    <dgm:cat type="accent1" pri="11200"/>
-  </dgm:catLst>
-  <dgm:styleLbl name="node0">
-    <dgm:fillClrLst meth="repeat">
-      <a:schemeClr val="accent1"/>
-    </dgm:fillClrLst>
-    <dgm:linClrLst meth="repeat">
-      <a:schemeClr val="lt1"/>
-    </dgm:linClrLst>
-    <dgm:effectClrLst/>
-    <dgm:txLinClrLst/>
-    <dgm:txFillClrLst/>
-    <dgm:txEffectClrLst/>
-  </dgm:styleLbl>
-  <dgm:styleLbl name="alignNode1">
-    <dgm:fillClrLst meth="repeat">
-      <a:schemeClr val="accent1"/>
-    </dgm:fillClrLst>
-    <dgm:linClrLst meth="repeat">
-      <a:schemeClr val="accent1"/>
-    </dgm:linClrLst>
-    <dgm:effectClrLst/>
-    <dgm:txLinClrLst/>
-    <dgm:txFillClrLst/>
-    <dgm:txEffectClrLst/>
-  </dgm:styleLbl>
-  <dgm:styleLbl name="node1">
-    <dgm:fillClrLst meth="repeat">
-      <a:schemeClr val="accent1"/>
-    </dgm:fillClrLst>
-    <dgm:linClrLst meth="repeat">
-      <a:schemeClr val="lt1"/>
-    </dgm:linClrLst>
-    <dgm:effectClrLst/>
-    <dgm:txLinClrLst/>
-    <dgm:txFillClrLst/>
-    <dgm:txEffectClrLst/>
-  </dgm:styleLbl>
-  <dgm:styleLbl name="lnNode1">
-    <dgm:fillClrLst meth="repeat">
-      <a:schemeClr val="accent1"/>
-    </dgm:fillClrLst>
-    <dgm:linClrLst meth="repeat">
-      <a:schemeClr val="lt1"/>
-    </dgm:linClrLst>
-    <dgm:effectClrLst/>
-    <dgm:txLinClrLst/>
-    <dgm:txFillClrLst/>
-    <dgm:txEffectClrLst/>
-  </dgm:styleLbl>
-  <dgm:styleLbl name="vennNode1">
-    <dgm:fillClrLst meth="repeat">
-      <a:schemeClr val="accent1">
-        <a:alpha val="50000"/>
-      </a:schemeClr>
-    </dgm:fillClrLst>
-    <dgm:linClrLst meth="repeat">
-      <a:schemeClr val="lt1"/>
-    </dgm:linClrLst>
-    <dgm:effectClrLst/>
-    <dgm:txLinClrLst/>
-    <dgm:txFillClrLst/>
-    <dgm:txEffectClrLst/>
-  </dgm:styleLbl>
-  <dgm:styleLbl name="node2">
-    <dgm:fillClrLst meth="repeat">
-      <a:schemeClr val="accent1"/>
-    </dgm:fillClrLst>
-    <dgm:linClrLst meth="repeat">
-      <a:schemeClr val="lt1"/>
-    </dgm:linClrLst>
-    <dgm:effectClrLst/>
-    <dgm:txLinClrLst/>
-    <dgm:txFillClrLst/>
-    <dgm:txEffectClrLst/>
-  </dgm:styleLbl>
-  <dgm:styleLbl name="node3">
-    <dgm:fillClrLst meth="repeat">
-      <a:schemeClr val="accent1"/>
-    </dgm:fillClrLst>
-    <dgm:linClrLst meth="repeat">
-      <a:schemeClr val="lt1"/>
-    </dgm:linClrLst>
-    <dgm:effectClrLst/>
-    <dgm:txLinClrLst/>
-    <dgm:txFillClrLst/>
-    <dgm:txEffectClrLst/>
-  </dgm:styleLbl>
-  <dgm:styleLbl name="node4">
-    <dgm:fillClrLst meth="repeat">
-      <a:schemeClr val="accent1"/>
-    </dgm:fillClrLst>
-    <dgm:linClrLst meth="repeat">
-      <a:schemeClr val="lt1"/>
-    </dgm:linClrLst>
-    <dgm:effectClrLst/>
-    <dgm:txLinClrLst/>
-    <dgm:txFillClrLst/>
-    <dgm:txEffectClrLst/>
-  </dgm:styleLbl>
-  <dgm:styleLbl name="fgImgPlace1">
-    <dgm:fillClrLst meth="repeat">
-      <a:schemeClr val="accent1">
-        <a:tint val="50000"/>
-      </a:schemeClr>
-    </dgm:fillClrLst>
-    <dgm:linClrLst meth="repeat">
-      <a:schemeClr val="lt1"/>
-    </dgm:linClrLst>
-    <dgm:effectClrLst/>
-    <dgm:txLinClrLst/>
-    <dgm:txFillClrLst meth="repeat">
-      <a:schemeClr val="lt1"/>
-    </dgm:txFillClrLst>
-    <dgm:txEffectClrLst/>
-  </dgm:styleLbl>
-  <dgm:styleLbl name="alignImgPlace1">
-    <dgm:fillClrLst meth="repeat">
-      <a:schemeClr val="accent1">
-        <a:tint val="50000"/>
-      </a:schemeClr>
-    </dgm:fillClrLst>
-    <dgm:linClrLst meth="repeat">
-      <a:schemeClr val="lt1"/>
-    </dgm:linClrLst>
-    <dgm:effectClrLst/>
-    <dgm:txLinClrLst/>
-    <dgm:txFillClrLst meth="repeat">
-      <a:schemeClr val="lt1"/>
-    </dgm:txFillClrLst>
-    <dgm:txEffectClrLst/>
-  </dgm:styleLbl>
-  <dgm:styleLbl name="bgImgPlace1">
-    <dgm:fillClrLst meth="repeat">
-      <a:schemeClr val="accent1">
-        <a:tint val="50000"/>
-      </a:schemeClr>
-    </dgm:fillClrLst>
-    <dgm:linClrLst meth="repeat">
-      <a:schemeClr val="lt1"/>
-    </dgm:linClrLst>
-    <dgm:effectClrLst/>
-    <dgm:txLinClrLst/>
-    <dgm:txFillClrLst meth="repeat">
-      <a:schemeClr val="lt1"/>
-    </dgm:txFillClrLst>
-    <dgm:txEffectClrLst/>
-  </dgm:styleLbl>
-  <dgm:styleLbl name="sibTrans2D1">
-    <dgm:fillClrLst meth="repeat">
-      <a:schemeClr val="accent1">
-        <a:tint val="60000"/>
-      </a:schemeClr>
-    </dgm:fillClrLst>
-    <dgm:linClrLst meth="repeat">
-      <a:schemeClr val="accent1">
-        <a:tint val="60000"/>
-      </a:schemeClr>
-    </dgm:linClrLst>
-    <dgm:effectClrLst/>
-    <dgm:txLinClrLst/>
-    <dgm:txFillClrLst/>
-    <dgm:txEffectClrLst/>
-  </dgm:styleLbl>
-  <dgm:styleLbl name="fgSibTrans2D1">
-    <dgm:fillClrLst meth="repeat">
-      <a:schemeClr val="accent1">
-        <a:tint val="60000"/>
-      </a:schemeClr>
-    </dgm:fillClrLst>
-    <dgm:linClrLst meth="repeat">
-      <a:schemeClr val="accent1">
-        <a:tint val="60000"/>
-      </a:schemeClr>
-    </dgm:linClrLst>
-    <dgm:effectClrLst/>
-    <dgm:txLinClrLst/>
-    <dgm:txFillClrLst/>
-    <dgm:txEffectClrLst/>
-  </dgm:styleLbl>
-  <dgm:styleLbl name="bgSibTrans2D1">
-    <dgm:fillClrLst meth="repeat">
-      <a:schemeClr val="accent1">
-        <a:tint val="60000"/>
-      </a:schemeClr>
-    </dgm:fillClrLst>
-    <dgm:linClrLst meth="repeat">
-      <a:schemeClr val="accent1">
-        <a:tint val="60000"/>
-      </a:schemeClr>
-    </dgm:linClrLst>
-    <dgm:effectClrLst/>
-    <dgm:txLinClrLst/>
-    <dgm:txFillClrLst/>
-    <dgm:txEffectClrLst/>
-  </dgm:styleLbl>
-  <dgm:styleLbl name="sibTrans1D1">
-    <dgm:fillClrLst meth="repeat">
-      <a:schemeClr val="accent1"/>
-    </dgm:fillClrLst>
-    <dgm:linClrLst meth="repeat">
-      <a:schemeClr val="accent1"/>
-    </dgm:linClrLst>
-    <dgm:effectClrLst/>
-    <dgm:txLinClrLst/>
-    <dgm:txFillClrLst meth="repeat">
-      <a:schemeClr val="tx1"/>
-    </dgm:txFillClrLst>
-    <dgm:txEffectClrLst/>
-  </dgm:styleLbl>
-  <dgm:styleLbl name="callout">
-    <dgm:fillClrLst meth="repeat">
-      <a:schemeClr val="accent1"/>
-    </dgm:fillClrLst>
-    <dgm:linClrLst meth="repeat">
-      <a:schemeClr val="accent1">
-        <a:tint val="50000"/>
-      </a:schemeClr>
-    </dgm:linClrLst>
-    <dgm:effectClrLst/>
-    <dgm:txLinClrLst/>
-    <dgm:txFillClrLst meth="repeat">
-      <a:schemeClr val="tx1"/>
-    </dgm:txFillClrLst>
-    <dgm:txEffectClrLst/>
-  </dgm:styleLbl>
-  <dgm:styleLbl name="asst0">
-    <dgm:fillClrLst meth="repeat">
-      <a:schemeClr val="accent1"/>
-    </dgm:fillClrLst>
-    <dgm:linClrLst meth="repeat">
-      <a:schemeClr val="lt1"/>
-    </dgm:linClrLst>
-    <dgm:effectClrLst/>
-    <dgm:txLinClrLst/>
-    <dgm:txFillClrLst/>
-    <dgm:txEffectClrLst/>
-  </dgm:styleLbl>
-  <dgm:styleLbl name="asst1">
-    <dgm:fillClrLst meth="repeat">
-      <a:schemeClr val="accent1"/>
-    </dgm:fillClrLst>
-    <dgm:linClrLst meth="repeat">
-      <a:schemeClr val="lt1"/>
-    </dgm:linClrLst>
-    <dgm:effectClrLst/>
-    <dgm:txLinClrLst/>
-    <dgm:txFillClrLst/>
-    <dgm:txEffectClrLst/>
-  </dgm:styleLbl>
-  <dgm:styleLbl name="asst2">
-    <dgm:fillClrLst meth="repeat">
-      <a:schemeClr val="accent1"/>
-    </dgm:fillClrLst>
-    <dgm:linClrLst meth="repeat">
-      <a:schemeClr val="lt1"/>
-    </dgm:linClrLst>
-    <dgm:effectClrLst/>
-    <dgm:txLinClrLst/>
-    <dgm:txFillClrLst/>
-    <dgm:txEffectClrLst/>
-  </dgm:styleLbl>
-  <dgm:styleLbl name="asst3">
-    <dgm:fillClrLst meth="repeat">
-      <a:schemeClr val="accent1"/>
-    </dgm:fillClrLst>
-    <dgm:linClrLst meth="repeat">
-      <a:schemeClr val="lt1"/>
-    </dgm:linClrLst>
-    <dgm:effectClrLst/>
-    <dgm:txLinClrLst/>
-    <dgm:txFillClrLst/>
-    <dgm:txEffectClrLst/>
-  </dgm:styleLbl>
-  <dgm:styleLbl name="asst4">
-    <dgm:fillClrLst meth="repeat">
-      <a:schemeClr val="accent1"/>
-    </dgm:fillClrLst>
-    <dgm:linClrLst meth="repeat">
-      <a:schemeClr val="lt1"/>
-    </dgm:linClrLst>
-    <dgm:effectClrLst/>
-    <dgm:txLinClrLst/>
-    <dgm:txFillClrLst/>
-    <dgm:txEffectClrLst/>
-  </dgm:styleLbl>
-  <dgm:styleLbl name="parChTrans2D1">
-    <dgm:fillClrLst meth="repeat">
-      <a:schemeClr val="accent1">
-        <a:tint val="60000"/>
-      </a:schemeClr>
-    </dgm:fillClrLst>
-    <dgm:linClrLst meth="repeat">
-      <a:schemeClr val="accent1">
-        <a:tint val="60000"/>
-      </a:schemeClr>
-    </dgm:linClrLst>
-    <dgm:effectClrLst/>
-    <dgm:txLinClrLst/>
-    <dgm:txFillClrLst meth="repeat">
-      <a:schemeClr val="lt1"/>
-    </dgm:txFillClrLst>
-    <dgm:txEffectClrLst/>
-  </dgm:styleLbl>
-  <dgm:styleLbl name="parChTrans2D2">
-    <dgm:fillClrLst meth="repeat">
-      <a:schemeClr val="accent1"/>
-    </dgm:fillClrLst>
-    <dgm:linClrLst meth="repeat">
-      <a:schemeClr val="accent1"/>
-    </dgm:linClrLst>
-    <dgm:effectClrLst/>
-    <dgm:txLinClrLst/>
-    <dgm:txFillClrLst meth="repeat">
-      <a:schemeClr val="lt1"/>
-    </dgm:txFillClrLst>
-    <dgm:txEffectClrLst/>
-  </dgm:styleLbl>
-  <dgm:styleLbl name="parChTrans2D3">
-    <dgm:fillClrLst meth="repeat">
-      <a:schemeClr val="accent1"/>
-    </dgm:fillClrLst>
-    <dgm:linClrLst meth="repeat">
-      <a:schemeClr val="accent1"/>
-    </dgm:linClrLst>
-    <dgm:effectClrLst/>
-    <dgm:txLinClrLst/>
-    <dgm:txFillClrLst meth="repeat">
-      <a:schemeClr val="lt1"/>
-    </dgm:txFillClrLst>
-    <dgm:txEffectClrLst/>
-  </dgm:styleLbl>
-  <dgm:styleLbl name="parChTrans2D4">
-    <dgm:fillClrLst meth="repeat">
-      <a:schemeClr val="accent1"/>
-    </dgm:fillClrLst>
-    <dgm:linClrLst meth="repeat">
-      <a:schemeClr val="accent1"/>
-    </dgm:linClrLst>
-    <dgm:effectClrLst/>
-    <dgm:txLinClrLst/>
-    <dgm:txFillClrLst meth="repeat">
-      <a:schemeClr val="lt1"/>
-    </dgm:txFillClrLst>
-    <dgm:txEffectClrLst/>
-  </dgm:styleLbl>
-  <dgm:styleLbl name="parChTrans1D1">
-    <dgm:fillClrLst meth="repeat">
-      <a:schemeClr val="accent1"/>
-    </dgm:fillClrLst>
-    <dgm:linClrLst meth="repeat">
-      <a:schemeClr val="accent1">
-        <a:shade val="60000"/>
-      </a:schemeClr>
-    </dgm:linClrLst>
-    <dgm:effectClrLst/>
-    <dgm:txLinClrLst/>
-    <dgm:txFillClrLst meth="repeat">
-      <a:schemeClr val="tx1"/>
-    </dgm:txFillClrLst>
-    <dgm:txEffectClrLst/>
-  </dgm:styleLbl>
-  <dgm:styleLbl name="parChTrans1D2">
-    <dgm:fillClrLst meth="repeat">
-      <a:schemeClr val="accent1"/>
-    </dgm:fillClrLst>
-    <dgm:linClrLst meth="repeat">
-      <a:schemeClr val="accent1">
-        <a:shade val="60000"/>
-      </a:schemeClr>
-    </dgm:linClrLst>
-    <dgm:effectClrLst/>
-    <dgm:txLinClrLst/>
-    <dgm:txFillClrLst meth="repeat">
-      <a:schemeClr val="tx1"/>
-    </dgm:txFillClrLst>
-    <dgm:txEffectClrLst/>
-  </dgm:styleLbl>
-  <dgm:styleLbl name="parChTrans1D3">
-    <dgm:fillClrLst meth="repeat">
-      <a:schemeClr val="accent1"/>
-    </dgm:fillClrLst>
-    <dgm:linClrLst meth="repeat">
-      <a:schemeClr val="accent1">
-        <a:shade val="80000"/>
-      </a:schemeClr>
-    </dgm:linClrLst>
-    <dgm:effectClrLst/>
-    <dgm:txLinClrLst/>
-    <dgm:txFillClrLst meth="repeat">
-      <a:schemeClr val="tx1"/>
-    </dgm:txFillClrLst>
-    <dgm:txEffectClrLst/>
-  </dgm:styleLbl>
-  <dgm:styleLbl name="parChTrans1D4">
-    <dgm:fillClrLst meth="repeat">
-      <a:schemeClr val="accent1"/>
-    </dgm:fillClrLst>
-    <dgm:linClrLst meth="repeat">
-      <a:schemeClr val="accent1">
-        <a:shade val="80000"/>
-      </a:schemeClr>
-    </dgm:linClrLst>
-    <dgm:effectClrLst/>
-    <dgm:txLinClrLst/>
-    <dgm:txFillClrLst meth="repeat">
-      <a:schemeClr val="tx1"/>
-    </dgm:txFillClrLst>
-    <dgm:txEffectClrLst/>
-  </dgm:styleLbl>
-  <dgm:styleLbl name="fgAcc1">
-    <dgm:fillClrLst meth="repeat">
-      <a:schemeClr val="lt1">
-        <a:alpha val="90000"/>
-      </a:schemeClr>
-    </dgm:fillClrLst>
-    <dgm:linClrLst meth="repeat">
-      <a:schemeClr val="accent1"/>
-    </dgm:linClrLst>
-    <dgm:effectClrLst/>
-    <dgm:txLinClrLst/>
-    <dgm:txFillClrLst meth="repeat">
-      <a:schemeClr val="dk1"/>
-    </dgm:txFillClrLst>
-    <dgm:txEffectClrLst/>
-  </dgm:styleLbl>
-  <dgm:styleLbl name="conFgAcc1">
-    <dgm:fillClrLst meth="repeat">
-      <a:schemeClr val="lt1">
-        <a:alpha val="90000"/>
-      </a:schemeClr>
-    </dgm:fillClrLst>
-    <dgm:linClrLst meth="repeat">
-      <a:schemeClr val="accent1"/>
-    </dgm:linClrLst>
-    <dgm:effectClrLst/>
-    <dgm:txLinClrLst/>
-    <dgm:txFillClrLst meth="repeat">
-      <a:schemeClr val="dk1"/>
-    </dgm:txFillClrLst>
-    <dgm:txEffectClrLst/>
-  </dgm:styleLbl>
-  <dgm:styleLbl name="alignAcc1">
-    <dgm:fillClrLst meth="repeat">
-      <a:schemeClr val="lt1">
-        <a:alpha val="90000"/>
-      </a:schemeClr>
-    </dgm:fillClrLst>
-    <dgm:linClrLst meth="repeat">
-      <a:schemeClr val="accent1"/>
-    </dgm:linClrLst>
-    <dgm:effectClrLst/>
-    <dgm:txLinClrLst/>
-    <dgm:txFillClrLst meth="repeat">
-      <a:schemeClr val="dk1"/>
-    </dgm:txFillClrLst>
-    <dgm:txEffectClrLst/>
-  </dgm:styleLbl>
-  <dgm:styleLbl name="trAlignAcc1">
-    <dgm:fillClrLst meth="repeat">
-      <a:schemeClr val="lt1">
-        <a:alpha val="40000"/>
-      </a:schemeClr>
-    </dgm:fillClrLst>
-    <dgm:linClrLst meth="repeat">
-      <a:schemeClr val="accent1"/>
-    </dgm:linClrLst>
-    <dgm:effectClrLst/>
-    <dgm:txLinClrLst/>
-    <dgm:txFillClrLst meth="repeat">
-      <a:schemeClr val="dk1"/>
-    </dgm:txFillClrLst>
-    <dgm:txEffectClrLst/>
-  </dgm:styleLbl>
-  <dgm:styleLbl name="bgAcc1">
-    <dgm:fillClrLst meth="repeat">
-      <a:schemeClr val="lt1">
-        <a:alpha val="90000"/>
-      </a:schemeClr>
-    </dgm:fillClrLst>
-    <dgm:linClrLst meth="repeat">
-      <a:schemeClr val="accent1"/>
-    </dgm:linClrLst>
-    <dgm:effectClrLst/>
-    <dgm:txLinClrLst/>
-    <dgm:txFillClrLst meth="repeat">
-      <a:schemeClr val="dk1"/>
-    </dgm:txFillClrLst>
-    <dgm:txEffectClrLst/>
-  </dgm:styleLbl>
-  <dgm:styleLbl name="solidFgAcc1">
-    <dgm:fillClrLst meth="repeat">
-      <a:schemeClr val="lt1"/>
-    </dgm:fillClrLst>
-    <dgm:linClrLst meth="repeat">
-      <a:schemeClr val="accent1"/>
-    </dgm:linClrLst>
-    <dgm:effectClrLst/>
-    <dgm:txLinClrLst/>
-    <dgm:txFillClrLst meth="repeat">
-      <a:schemeClr val="dk1"/>
-    </dgm:txFillClrLst>
-    <dgm:txEffectClrLst/>
-  </dgm:styleLbl>
-  <dgm:styleLbl name="solidAlignAcc1">
-    <dgm:fillClrLst meth="repeat">
-      <a:schemeClr val="lt1"/>
-    </dgm:fillClrLst>
-    <dgm:linClrLst meth="repeat">
-      <a:schemeClr val="accent1"/>
-    </dgm:linClrLst>
-    <dgm:effectClrLst/>
-    <dgm:txLinClrLst/>
-    <dgm:txFillClrLst meth="repeat">
-      <a:schemeClr val="dk1"/>
-    </dgm:txFillClrLst>
-    <dgm:txEffectClrLst/>
-  </dgm:styleLbl>
-  <dgm:styleLbl name="solidBgAcc1">
-    <dgm:fillClrLst meth="repeat">
-      <a:schemeClr val="lt1"/>
-    </dgm:fillClrLst>
-    <dgm:linClrLst meth="repeat">
-      <a:schemeClr val="accent1"/>
-    </dgm:linClrLst>
-    <dgm:effectClrLst/>
-    <dgm:txLinClrLst/>
-    <dgm:txFillClrLst meth="repeat">
-      <a:schemeClr val="dk1"/>
-    </dgm:txFillClrLst>
-    <dgm:txEffectClrLst/>
-  </dgm:styleLbl>
-  <dgm:styleLbl name="fgAccFollowNode1">
-    <dgm:fillClrLst meth="repeat">
-      <a:schemeClr val="accent1">
-        <a:alpha val="90000"/>
-        <a:tint val="40000"/>
-      </a:schemeClr>
-    </dgm:fillClrLst>
-    <dgm:linClrLst meth="repeat">
-      <a:schemeClr val="accent1">
-        <a:alpha val="90000"/>
-        <a:tint val="40000"/>
-      </a:schemeClr>
-    </dgm:linClrLst>
-    <dgm:effectClrLst/>
-    <dgm:txLinClrLst/>
-    <dgm:txFillClrLst meth="repeat">
-      <a:schemeClr val="dk1"/>
-    </dgm:txFillClrLst>
-    <dgm:txEffectClrLst/>
-  </dgm:styleLbl>
-  <dgm:styleLbl name="alignAccFollowNode1">
-    <dgm:fillClrLst meth="repeat">
-      <a:schemeClr val="accent1">
-        <a:alpha val="90000"/>
-        <a:tint val="40000"/>
-      </a:schemeClr>
-    </dgm:fillClrLst>
-    <dgm:linClrLst meth="repeat">
-      <a:schemeClr val="accent1">
-        <a:alpha val="90000"/>
-        <a:tint val="40000"/>
-      </a:schemeClr>
-    </dgm:linClrLst>
-    <dgm:effectClrLst/>
-    <dgm:txLinClrLst/>
-    <dgm:txFillClrLst meth="repeat">
-      <a:schemeClr val="dk1"/>
-    </dgm:txFillClrLst>
-    <dgm:txEffectClrLst/>
-  </dgm:styleLbl>
-  <dgm:styleLbl name="bgAccFollowNode1">
-    <dgm:fillClrLst meth="repeat">
-      <a:schemeClr val="accent1">
-        <a:alpha val="90000"/>
-        <a:tint val="40000"/>
-      </a:schemeClr>
-    </dgm:fillClrLst>
-    <dgm:linClrLst meth="repeat">
-      <a:schemeClr val="accent1">
-        <a:alpha val="90000"/>
-        <a:tint val="40000"/>
-      </a:schemeClr>
-    </dgm:linClrLst>
-    <dgm:effectClrLst/>
-    <dgm:txLinClrLst/>
-    <dgm:txFillClrLst meth="repeat">
-      <a:schemeClr val="dk1"/>
-    </dgm:txFillClrLst>
-    <dgm:txEffectClrLst/>
-  </dgm:styleLbl>
-  <dgm:styleLbl name="fgAcc0">
-    <dgm:fillClrLst meth="repeat">
-      <a:schemeClr val="lt1">
-        <a:alpha val="90000"/>
-      </a:schemeClr>
-    </dgm:fillClrLst>
-    <dgm:linClrLst meth="repeat">
-      <a:schemeClr val="accent1"/>
-    </dgm:linClrLst>
-    <dgm:effectClrLst/>
-    <dgm:txLinClrLst/>
-    <dgm:txFillClrLst meth="repeat">
-      <a:schemeClr val="dk1"/>
-    </dgm:txFillClrLst>
-    <dgm:txEffectClrLst/>
-  </dgm:styleLbl>
-  <dgm:styleLbl name="fgAcc2">
-    <dgm:fillClrLst meth="repeat">
-      <a:schemeClr val="lt1">
-        <a:alpha val="90000"/>
-      </a:schemeClr>
-    </dgm:fillClrLst>
-    <dgm:linClrLst meth="repeat">
-      <a:schemeClr val="accent1"/>
-    </dgm:linClrLst>
-    <dgm:effectClrLst/>
-    <dgm:txLinClrLst/>
-    <dgm:txFillClrLst meth="repeat">
-      <a:schemeClr val="dk1"/>
-    </dgm:txFillClrLst>
-    <dgm:txEffectClrLst/>
-  </dgm:styleLbl>
-  <dgm:styleLbl name="fgAcc3">
-    <dgm:fillClrLst meth="repeat">
-      <a:schemeClr val="lt1">
-        <a:alpha val="90000"/>
-      </a:schemeClr>
-    </dgm:fillClrLst>
-    <dgm:linClrLst meth="repeat">
-      <a:schemeClr val="accent1"/>
-    </dgm:linClrLst>
-    <dgm:effectClrLst/>
-    <dgm:txLinClrLst/>
-    <dgm:txFillClrLst meth="repeat">
-      <a:schemeClr val="dk1"/>
-    </dgm:txFillClrLst>
-    <dgm:txEffectClrLst/>
-  </dgm:styleLbl>
-  <dgm:styleLbl name="fgAcc4">
-    <dgm:fillClrLst meth="repeat">
-      <a:schemeClr val="lt1">
-        <a:alpha val="90000"/>
-      </a:schemeClr>
-    </dgm:fillClrLst>
-    <dgm:linClrLst meth="repeat">
-      <a:schemeClr val="accent1"/>
-    </dgm:linClrLst>
-    <dgm:effectClrLst/>
-    <dgm:txLinClrLst/>
-    <dgm:txFillClrLst meth="repeat">
-      <a:schemeClr val="dk1"/>
-    </dgm:txFillClrLst>
-    <dgm:txEffectClrLst/>
-  </dgm:styleLbl>
-  <dgm:styleLbl name="bgShp">
-    <dgm:fillClrLst meth="repeat">
-      <a:schemeClr val="accent1">
-        <a:tint val="40000"/>
-      </a:schemeClr>
-    </dgm:fillClrLst>
-    <dgm:linClrLst meth="repeat">
-      <a:schemeClr val="accent1"/>
-    </dgm:linClrLst>
-    <dgm:effectClrLst/>
-    <dgm:txLinClrLst/>
-    <dgm:txFillClrLst meth="repeat">
-      <a:schemeClr val="dk1"/>
-    </dgm:txFillClrLst>
-    <dgm:txEffectClrLst/>
-  </dgm:styleLbl>
-  <dgm:styleLbl name="dkBgShp">
-    <dgm:fillClrLst meth="repeat">
-      <a:schemeClr val="accent1">
-        <a:shade val="80000"/>
-      </a:schemeClr>
-    </dgm:fillClrLst>
-    <dgm:linClrLst meth="repeat">
-      <a:schemeClr val="accent1"/>
-    </dgm:linClrLst>
-    <dgm:effectClrLst/>
-    <dgm:txLinClrLst/>
-    <dgm:txFillClrLst meth="repeat">
-      <a:schemeClr val="lt1"/>
-    </dgm:txFillClrLst>
-    <dgm:txEffectClrLst/>
-  </dgm:styleLbl>
-  <dgm:styleLbl name="trBgShp">
-    <dgm:fillClrLst meth="repeat">
-      <a:schemeClr val="accent1">
-        <a:tint val="50000"/>
-        <a:alpha val="40000"/>
-      </a:schemeClr>
-    </dgm:fillClrLst>
-    <dgm:linClrLst meth="repeat">
-      <a:schemeClr val="accent1"/>
-    </dgm:linClrLst>
-    <dgm:effectClrLst/>
-    <dgm:txLinClrLst/>
-    <dgm:txFillClrLst meth="repeat">
-      <a:schemeClr val="lt1"/>
-    </dgm:txFillClrLst>
-    <dgm:txEffectClrLst/>
-  </dgm:styleLbl>
-  <dgm:styleLbl name="fgShp">
-    <dgm:fillClrLst meth="repeat">
-      <a:schemeClr val="accent1">
-        <a:tint val="60000"/>
-      </a:schemeClr>
-    </dgm:fillClrLst>
-    <dgm:linClrLst meth="repeat">
-      <a:schemeClr val="lt1"/>
-    </dgm:linClrLst>
-    <dgm:effectClrLst/>
-    <dgm:txLinClrLst/>
-    <dgm:txFillClrLst meth="repeat">
-      <a:schemeClr val="dk1"/>
-    </dgm:txFillClrLst>
-    <dgm:txEffectClrLst/>
-  </dgm:styleLbl>
-  <dgm:styleLbl name="revTx">
-    <dgm:fillClrLst meth="repeat">
-      <a:schemeClr val="lt1">
-        <a:alpha val="0"/>
-      </a:schemeClr>
-    </dgm:fillClrLst>
-    <dgm:linClrLst meth="repeat">
-      <a:schemeClr val="dk1">
-        <a:alpha val="0"/>
-      </a:schemeClr>
-    </dgm:linClrLst>
-    <dgm:effectClrLst/>
-    <dgm:txLinClrLst/>
-    <dgm:txFillClrLst meth="repeat">
-      <a:schemeClr val="tx1"/>
-    </dgm:txFillClrLst>
-    <dgm:txEffectClrLst/>
-  </dgm:styleLbl>
-</dgm:colorsDef>
+<file path=ppt/notesMasters/notesMaster1.xml><?xml version="1.0" encoding="utf-8"?>
+<p:notesMaster xmlns:a="http://schemas.openxmlformats.org/drawingml/2006/main" xmlns:r="http://schemas.openxmlformats.org/officeDocument/2006/relationships" xmlns:p="http://schemas.openxmlformats.org/presentationml/2006/main">
+  <p:cSld>
+    <p:bg>
+      <p:bgRef idx="1001">
+        <a:schemeClr val="bg1"/>
+      </p:bgRef>
+    </p:bg>
+    <p:spTree>
+      <p:nvGrpSpPr>
+        <p:cNvPr id="1" name=""/>
+        <p:cNvGrpSpPr/>
+        <p:nvPr/>
+      </p:nvGrpSpPr>
+      <p:grpSpPr>
+        <a:xfrm>
+          <a:off x="0" y="0"/>
+          <a:ext cx="0" cy="0"/>
+          <a:chOff x="0" y="0"/>
+          <a:chExt cx="0" cy="0"/>
+        </a:xfrm>
+      </p:grpSpPr>
+      <p:sp>
+        <p:nvSpPr>
+          <p:cNvPr id="2" name="Kopfzeilenplatzhalter 1"/>
+          <p:cNvSpPr>
+            <a:spLocks noGrp="1"/>
+          </p:cNvSpPr>
+          <p:nvPr>
+            <p:ph type="hdr" sz="quarter"/>
+          </p:nvPr>
+        </p:nvSpPr>
+        <p:spPr>
+          <a:xfrm>
+            <a:off x="0" y="0"/>
+            <a:ext cx="2971800" cy="458788"/>
+          </a:xfrm>
+          <a:prstGeom prst="rect">
+            <a:avLst/>
+          </a:prstGeom>
+        </p:spPr>
+        <p:txBody>
+          <a:bodyPr vert="horz" lIns="91440" tIns="45720" rIns="91440" bIns="45720" rtlCol="0"/>
+          <a:lstStyle>
+            <a:lvl1pPr algn="l">
+              <a:defRPr sz="1200"/>
+            </a:lvl1pPr>
+          </a:lstStyle>
+          <a:p>
+            <a:endParaRPr lang="de-AT"/>
+          </a:p>
+        </p:txBody>
+      </p:sp>
+      <p:sp>
+        <p:nvSpPr>
+          <p:cNvPr id="3" name="Datumsplatzhalter 2"/>
+          <p:cNvSpPr>
+            <a:spLocks noGrp="1"/>
+          </p:cNvSpPr>
+          <p:nvPr>
+            <p:ph type="dt" idx="1"/>
+          </p:nvPr>
+        </p:nvSpPr>
+        <p:spPr>
+          <a:xfrm>
+            <a:off x="3884613" y="0"/>
+            <a:ext cx="2971800" cy="458788"/>
+          </a:xfrm>
+          <a:prstGeom prst="rect">
+            <a:avLst/>
+          </a:prstGeom>
+        </p:spPr>
+        <p:txBody>
+          <a:bodyPr vert="horz" lIns="91440" tIns="45720" rIns="91440" bIns="45720" rtlCol="0"/>
+          <a:lstStyle>
+            <a:lvl1pPr algn="r">
+              <a:defRPr sz="1200"/>
+            </a:lvl1pPr>
+          </a:lstStyle>
+          <a:p>
+            <a:fld id="{AA90FDF6-3771-4E13-869C-FCEAEA4D360E}" type="datetimeFigureOut">
+              <a:rPr lang="de-AT" smtClean="0"/>
+              <a:t>13.01.2026</a:t>
+            </a:fld>
+            <a:endParaRPr lang="de-AT"/>
+          </a:p>
+        </p:txBody>
+      </p:sp>
+      <p:sp>
+        <p:nvSpPr>
+          <p:cNvPr id="4" name="Folienbildplatzhalter 3"/>
+          <p:cNvSpPr>
+            <a:spLocks noGrp="1" noRot="1" noChangeAspect="1"/>
+          </p:cNvSpPr>
+          <p:nvPr>
+            <p:ph type="sldImg" idx="2"/>
+          </p:nvPr>
+        </p:nvSpPr>
+        <p:spPr>
+          <a:xfrm>
+            <a:off x="685800" y="1143000"/>
+            <a:ext cx="5486400" cy="3086100"/>
+          </a:xfrm>
+          <a:prstGeom prst="rect">
+            <a:avLst/>
+          </a:prstGeom>
+          <a:noFill/>
+          <a:ln w="12700">
+            <a:solidFill>
+              <a:prstClr val="black"/>
+            </a:solidFill>
+          </a:ln>
+        </p:spPr>
+        <p:txBody>
+          <a:bodyPr vert="horz" lIns="91440" tIns="45720" rIns="91440" bIns="45720" rtlCol="0" anchor="ctr"/>
+          <a:lstStyle/>
+          <a:p>
+            <a:endParaRPr lang="de-AT"/>
+          </a:p>
+        </p:txBody>
+      </p:sp>
+      <p:sp>
+        <p:nvSpPr>
+          <p:cNvPr id="5" name="Notizenplatzhalter 4"/>
+          <p:cNvSpPr>
+            <a:spLocks noGrp="1"/>
+          </p:cNvSpPr>
+          <p:nvPr>
+            <p:ph type="body" sz="quarter" idx="3"/>
+          </p:nvPr>
+        </p:nvSpPr>
+        <p:spPr>
+          <a:xfrm>
+            <a:off x="685800" y="4400550"/>
+            <a:ext cx="5486400" cy="3600450"/>
+          </a:xfrm>
+          <a:prstGeom prst="rect">
+            <a:avLst/>
+          </a:prstGeom>
+        </p:spPr>
+        <p:txBody>
+          <a:bodyPr vert="horz" lIns="91440" tIns="45720" rIns="91440" bIns="45720" rtlCol="0"/>
+          <a:lstStyle/>
+          <a:p>
+            <a:pPr lvl="0"/>
+            <a:r>
+              <a:rPr lang="de-DE"/>
+              <a:t>Mastertextformat bearbeiten</a:t>
+            </a:r>
+          </a:p>
+          <a:p>
+            <a:pPr lvl="1"/>
+            <a:r>
+              <a:rPr lang="de-DE"/>
+              <a:t>Zweite Ebene</a:t>
+            </a:r>
+          </a:p>
+          <a:p>
+            <a:pPr lvl="2"/>
+            <a:r>
+              <a:rPr lang="de-DE"/>
+              <a:t>Dritte Ebene</a:t>
+            </a:r>
+          </a:p>
+          <a:p>
+            <a:pPr lvl="3"/>
+            <a:r>
+              <a:rPr lang="de-DE"/>
+              <a:t>Vierte Ebene</a:t>
+            </a:r>
+          </a:p>
+          <a:p>
+            <a:pPr lvl="4"/>
+            <a:r>
+              <a:rPr lang="de-DE"/>
+              <a:t>Fünfte Ebene</a:t>
+            </a:r>
+            <a:endParaRPr lang="de-AT"/>
+          </a:p>
+        </p:txBody>
+      </p:sp>
+      <p:sp>
+        <p:nvSpPr>
+          <p:cNvPr id="6" name="Fußzeilenplatzhalter 5"/>
+          <p:cNvSpPr>
+            <a:spLocks noGrp="1"/>
+          </p:cNvSpPr>
+          <p:nvPr>
+            <p:ph type="ftr" sz="quarter" idx="4"/>
+          </p:nvPr>
+        </p:nvSpPr>
+        <p:spPr>
+          <a:xfrm>
+            <a:off x="0" y="8685213"/>
+            <a:ext cx="2971800" cy="458787"/>
+          </a:xfrm>
+          <a:prstGeom prst="rect">
+            <a:avLst/>
+          </a:prstGeom>
+        </p:spPr>
+        <p:txBody>
+          <a:bodyPr vert="horz" lIns="91440" tIns="45720" rIns="91440" bIns="45720" rtlCol="0" anchor="b"/>
+          <a:lstStyle>
+            <a:lvl1pPr algn="l">
+              <a:defRPr sz="1200"/>
+            </a:lvl1pPr>
+          </a:lstStyle>
+          <a:p>
+            <a:endParaRPr lang="de-AT"/>
+          </a:p>
+        </p:txBody>
+      </p:sp>
+      <p:sp>
+        <p:nvSpPr>
+          <p:cNvPr id="7" name="Foliennummernplatzhalter 6"/>
+          <p:cNvSpPr>
+            <a:spLocks noGrp="1"/>
+          </p:cNvSpPr>
+          <p:nvPr>
+            <p:ph type="sldNum" sz="quarter" idx="5"/>
+          </p:nvPr>
+        </p:nvSpPr>
+        <p:spPr>
+          <a:xfrm>
+            <a:off x="3884613" y="8685213"/>
+            <a:ext cx="2971800" cy="458787"/>
+          </a:xfrm>
+          <a:prstGeom prst="rect">
+            <a:avLst/>
+          </a:prstGeom>
+        </p:spPr>
+        <p:txBody>
+          <a:bodyPr vert="horz" lIns="91440" tIns="45720" rIns="91440" bIns="45720" rtlCol="0" anchor="b"/>
+          <a:lstStyle>
+            <a:lvl1pPr algn="r">
+              <a:defRPr sz="1200"/>
+            </a:lvl1pPr>
+          </a:lstStyle>
+          <a:p>
+            <a:fld id="{9C90ADE1-F86E-471B-96D6-B88192C861AF}" type="slidenum">
+              <a:rPr lang="de-AT" smtClean="0"/>
+              <a:t>‹Nr.›</a:t>
+            </a:fld>
+            <a:endParaRPr lang="de-AT"/>
+          </a:p>
+        </p:txBody>
+      </p:sp>
+    </p:spTree>
+    <p:extLst>
+      <p:ext uri="{BB962C8B-B14F-4D97-AF65-F5344CB8AC3E}">
+        <p14:creationId xmlns:p14="http://schemas.microsoft.com/office/powerpoint/2010/main" val="4174960618"/>
+      </p:ext>
+    </p:extLst>
+  </p:cSld>
+  <p:clrMap bg1="lt1" tx1="dk1" bg2="lt2" tx2="dk2" accent1="accent1" accent2="accent2" accent3="accent3" accent4="accent4" accent5="accent5" accent6="accent6" hlink="hlink" folHlink="folHlink"/>
+  <p:notesStyle>
+    <a:lvl1pPr marL="0" algn="l" defTabSz="914400" rtl="0" eaLnBrk="1" latinLnBrk="0" hangingPunct="1">
+      <a:defRPr sz="1200" kern="1200">
+        <a:solidFill>
+          <a:schemeClr val="tx1"/>
+        </a:solidFill>
+        <a:latin typeface="+mn-lt"/>
+        <a:ea typeface="+mn-ea"/>
+        <a:cs typeface="+mn-cs"/>
+      </a:defRPr>
+    </a:lvl1pPr>
+    <a:lvl2pPr marL="457200" algn="l" defTabSz="914400" rtl="0" eaLnBrk="1" latinLnBrk="0" hangingPunct="1">
+      <a:defRPr sz="1200" kern="1200">
+        <a:solidFill>
+          <a:schemeClr val="tx1"/>
+        </a:solidFill>
+        <a:latin typeface="+mn-lt"/>
+        <a:ea typeface="+mn-ea"/>
+        <a:cs typeface="+mn-cs"/>
+      </a:defRPr>
+    </a:lvl2pPr>
+    <a:lvl3pPr marL="914400" algn="l" defTabSz="914400" rtl="0" eaLnBrk="1" latinLnBrk="0" hangingPunct="1">
+      <a:defRPr sz="1200" kern="1200">
+        <a:solidFill>
+          <a:schemeClr val="tx1"/>
+        </a:solidFill>
+        <a:latin typeface="+mn-lt"/>
+        <a:ea typeface="+mn-ea"/>
+        <a:cs typeface="+mn-cs"/>
+      </a:defRPr>
+    </a:lvl3pPr>
+    <a:lvl4pPr marL="1371600" algn="l" defTabSz="914400" rtl="0" eaLnBrk="1" latinLnBrk="0" hangingPunct="1">
+      <a:defRPr sz="1200" kern="1200">
+        <a:solidFill>
+          <a:schemeClr val="tx1"/>
+        </a:solidFill>
+        <a:latin typeface="+mn-lt"/>
+        <a:ea typeface="+mn-ea"/>
+        <a:cs typeface="+mn-cs"/>
+      </a:defRPr>
+    </a:lvl4pPr>
+    <a:lvl5pPr marL="1828800" algn="l" defTabSz="914400" rtl="0" eaLnBrk="1" latinLnBrk="0" hangingPunct="1">
+      <a:defRPr sz="1200" kern="1200">
+        <a:solidFill>
+          <a:schemeClr val="tx1"/>
+        </a:solidFill>
+        <a:latin typeface="+mn-lt"/>
+        <a:ea typeface="+mn-ea"/>
+        <a:cs typeface="+mn-cs"/>
+      </a:defRPr>
+    </a:lvl5pPr>
+    <a:lvl6pPr marL="2286000" algn="l" defTabSz="914400" rtl="0" eaLnBrk="1" latinLnBrk="0" hangingPunct="1">
+      <a:defRPr sz="1200" kern="1200">
+        <a:solidFill>
+          <a:schemeClr val="tx1"/>
+        </a:solidFill>
+        <a:latin typeface="+mn-lt"/>
+        <a:ea typeface="+mn-ea"/>
+        <a:cs typeface="+mn-cs"/>
+      </a:defRPr>
+    </a:lvl6pPr>
+    <a:lvl7pPr marL="2743200" algn="l" defTabSz="914400" rtl="0" eaLnBrk="1" latinLnBrk="0" hangingPunct="1">
+      <a:defRPr sz="1200" kern="1200">
+        <a:solidFill>
+          <a:schemeClr val="tx1"/>
+        </a:solidFill>
+        <a:latin typeface="+mn-lt"/>
+        <a:ea typeface="+mn-ea"/>
+        <a:cs typeface="+mn-cs"/>
+      </a:defRPr>
+    </a:lvl7pPr>
+    <a:lvl8pPr marL="3200400" algn="l" defTabSz="914400" rtl="0" eaLnBrk="1" latinLnBrk="0" hangingPunct="1">
+      <a:defRPr sz="1200" kern="1200">
+        <a:solidFill>
+          <a:schemeClr val="tx1"/>
+        </a:solidFill>
+        <a:latin typeface="+mn-lt"/>
+        <a:ea typeface="+mn-ea"/>
+        <a:cs typeface="+mn-cs"/>
+      </a:defRPr>
+    </a:lvl8pPr>
+    <a:lvl9pPr marL="3657600" algn="l" defTabSz="914400" rtl="0" eaLnBrk="1" latinLnBrk="0" hangingPunct="1">
+      <a:defRPr sz="1200" kern="1200">
+        <a:solidFill>
+          <a:schemeClr val="tx1"/>
+        </a:solidFill>
+        <a:latin typeface="+mn-lt"/>
+        <a:ea typeface="+mn-ea"/>
+        <a:cs typeface="+mn-cs"/>
+      </a:defRPr>
+    </a:lvl9pPr>
+  </p:notesStyle>
+</p:notesMaster>
 </file>
 
-<file path=ppt/diagrams/data1.xml><?xml version="1.0" encoding="utf-8"?>
-<dgm:dataModel xmlns:dgm="http://schemas.openxmlformats.org/drawingml/2006/diagram" xmlns:a="http://schemas.openxmlformats.org/drawingml/2006/main">
-  <dgm:ptLst>
-    <dgm:pt modelId="{7858CB19-2C29-4D43-894A-87C04F05DD9A}" type="doc">
-      <dgm:prSet loTypeId="urn:microsoft.com/office/officeart/2005/8/layout/chevron2" loCatId="process" qsTypeId="urn:microsoft.com/office/officeart/2005/8/quickstyle/simple1" qsCatId="simple" csTypeId="urn:microsoft.com/office/officeart/2005/8/colors/accent1_2" csCatId="accent1" phldr="1"/>
-      <dgm:spPr/>
-      <dgm:t>
-        <a:bodyPr/>
-        <a:lstStyle/>
-        <a:p>
-          <a:endParaRPr lang="de-AT"/>
-        </a:p>
-      </dgm:t>
-    </dgm:pt>
-    <dgm:pt modelId="{353D1A30-909A-4EEB-905A-729F4115AA5D}">
-      <dgm:prSet phldrT="[Text]"/>
-      <dgm:spPr/>
-      <dgm:t>
-        <a:bodyPr/>
-        <a:lstStyle/>
-        <a:p>
-          <a:r>
-            <a:rPr lang="de-AT" dirty="0"/>
-            <a:t>Awareness</a:t>
-          </a:r>
-        </a:p>
-      </dgm:t>
-    </dgm:pt>
-    <dgm:pt modelId="{FF292C6B-0192-4A9E-ADDF-574265DE0B16}" type="parTrans" cxnId="{CA3C422B-7F71-4D27-9612-837E630288F8}">
-      <dgm:prSet/>
-      <dgm:spPr/>
-      <dgm:t>
-        <a:bodyPr/>
-        <a:lstStyle/>
-        <a:p>
-          <a:endParaRPr lang="de-AT"/>
-        </a:p>
-      </dgm:t>
-    </dgm:pt>
-    <dgm:pt modelId="{E414067B-B3A5-4AA9-BFF9-F48BB24E188A}" type="sibTrans" cxnId="{CA3C422B-7F71-4D27-9612-837E630288F8}">
-      <dgm:prSet/>
-      <dgm:spPr/>
-      <dgm:t>
-        <a:bodyPr/>
-        <a:lstStyle/>
-        <a:p>
-          <a:endParaRPr lang="de-AT"/>
-        </a:p>
-      </dgm:t>
-    </dgm:pt>
-    <dgm:pt modelId="{1EC41F69-532C-4B21-BBCD-48BA0E98FE13}">
-      <dgm:prSet phldrT="[Text]" phldr="1"/>
-      <dgm:spPr/>
-      <dgm:t>
-        <a:bodyPr/>
-        <a:lstStyle/>
-        <a:p>
-          <a:endParaRPr lang="de-AT"/>
-        </a:p>
-      </dgm:t>
-    </dgm:pt>
-    <dgm:pt modelId="{E5CA7C5D-D29E-4BF0-A9CB-1BAE4863ACE7}" type="parTrans" cxnId="{9047A568-9CAB-4669-9BF6-C2C0C5ED3FEA}">
-      <dgm:prSet/>
-      <dgm:spPr/>
-      <dgm:t>
-        <a:bodyPr/>
-        <a:lstStyle/>
-        <a:p>
-          <a:endParaRPr lang="de-AT"/>
-        </a:p>
-      </dgm:t>
-    </dgm:pt>
-    <dgm:pt modelId="{0FFC74D7-0697-46B9-B724-0E2AC8858B30}" type="sibTrans" cxnId="{9047A568-9CAB-4669-9BF6-C2C0C5ED3FEA}">
-      <dgm:prSet/>
-      <dgm:spPr/>
-      <dgm:t>
-        <a:bodyPr/>
-        <a:lstStyle/>
-        <a:p>
-          <a:endParaRPr lang="de-AT"/>
-        </a:p>
-      </dgm:t>
-    </dgm:pt>
-    <dgm:pt modelId="{852BFE89-2430-41B3-A494-FC69372405CC}">
-      <dgm:prSet phldrT="[Text]" phldr="1"/>
-      <dgm:spPr/>
-      <dgm:t>
-        <a:bodyPr/>
-        <a:lstStyle/>
-        <a:p>
-          <a:endParaRPr lang="de-AT" dirty="0"/>
-        </a:p>
-      </dgm:t>
-    </dgm:pt>
-    <dgm:pt modelId="{FB5A6BBC-3E09-4651-B532-F8539F776A9B}" type="parTrans" cxnId="{82BA1784-F43F-4B0F-ADB4-20E9671C67F5}">
-      <dgm:prSet/>
-      <dgm:spPr/>
-      <dgm:t>
-        <a:bodyPr/>
-        <a:lstStyle/>
-        <a:p>
-          <a:endParaRPr lang="de-AT"/>
-        </a:p>
-      </dgm:t>
-    </dgm:pt>
-    <dgm:pt modelId="{9E2D985C-0178-49B8-89D8-AA5E1E43CA32}" type="sibTrans" cxnId="{82BA1784-F43F-4B0F-ADB4-20E9671C67F5}">
-      <dgm:prSet/>
-      <dgm:spPr/>
-      <dgm:t>
-        <a:bodyPr/>
-        <a:lstStyle/>
-        <a:p>
-          <a:endParaRPr lang="de-AT"/>
-        </a:p>
-      </dgm:t>
-    </dgm:pt>
-    <dgm:pt modelId="{A555E536-BAD2-40C7-A4AC-F35394692C25}">
-      <dgm:prSet phldrT="[Text]"/>
-      <dgm:spPr/>
-      <dgm:t>
-        <a:bodyPr/>
-        <a:lstStyle/>
-        <a:p>
-          <a:r>
-            <a:rPr lang="de-AT" dirty="0" err="1"/>
-            <a:t>Consideration</a:t>
-          </a:r>
-          <a:endParaRPr lang="de-AT" dirty="0"/>
-        </a:p>
-      </dgm:t>
-    </dgm:pt>
-    <dgm:pt modelId="{4DA26BF4-50D3-44EF-B368-40DC089228B5}" type="parTrans" cxnId="{39649AD7-EEED-4290-BB43-87D010CCDF67}">
-      <dgm:prSet/>
-      <dgm:spPr/>
-      <dgm:t>
-        <a:bodyPr/>
-        <a:lstStyle/>
-        <a:p>
-          <a:endParaRPr lang="de-AT"/>
-        </a:p>
-      </dgm:t>
-    </dgm:pt>
-    <dgm:pt modelId="{B5452E2D-02D0-4D5B-A824-48FFA9823618}" type="sibTrans" cxnId="{39649AD7-EEED-4290-BB43-87D010CCDF67}">
-      <dgm:prSet/>
-      <dgm:spPr/>
-      <dgm:t>
-        <a:bodyPr/>
-        <a:lstStyle/>
-        <a:p>
-          <a:endParaRPr lang="de-AT"/>
-        </a:p>
-      </dgm:t>
-    </dgm:pt>
-    <dgm:pt modelId="{DAFC6534-4A70-4679-B51F-01DF53962FD6}">
-      <dgm:prSet phldrT="[Text]" phldr="1"/>
-      <dgm:spPr/>
-      <dgm:t>
-        <a:bodyPr/>
-        <a:lstStyle/>
-        <a:p>
-          <a:endParaRPr lang="de-AT"/>
-        </a:p>
-      </dgm:t>
-    </dgm:pt>
-    <dgm:pt modelId="{EA967D29-A690-4AF8-A66E-646B38434B64}" type="parTrans" cxnId="{417765D9-293A-42AA-89C5-8C453A7A72C4}">
-      <dgm:prSet/>
-      <dgm:spPr/>
-      <dgm:t>
-        <a:bodyPr/>
-        <a:lstStyle/>
-        <a:p>
-          <a:endParaRPr lang="de-AT"/>
-        </a:p>
-      </dgm:t>
-    </dgm:pt>
-    <dgm:pt modelId="{248CE566-B665-4E8A-B62B-E1FD7365821B}" type="sibTrans" cxnId="{417765D9-293A-42AA-89C5-8C453A7A72C4}">
-      <dgm:prSet/>
-      <dgm:spPr/>
-      <dgm:t>
-        <a:bodyPr/>
-        <a:lstStyle/>
-        <a:p>
-          <a:endParaRPr lang="de-AT"/>
-        </a:p>
-      </dgm:t>
-    </dgm:pt>
-    <dgm:pt modelId="{493F9CE4-475F-439F-B976-CF6A3E43EE72}">
-      <dgm:prSet phldrT="[Text]" phldr="1"/>
-      <dgm:spPr/>
-      <dgm:t>
-        <a:bodyPr/>
-        <a:lstStyle/>
-        <a:p>
-          <a:endParaRPr lang="de-AT"/>
-        </a:p>
-      </dgm:t>
-    </dgm:pt>
-    <dgm:pt modelId="{24BDF8BE-1CAA-493F-BDA9-9EED6DD97742}" type="parTrans" cxnId="{A97B7327-AE48-472D-9446-0DAEFEE00DA3}">
-      <dgm:prSet/>
-      <dgm:spPr/>
-      <dgm:t>
-        <a:bodyPr/>
-        <a:lstStyle/>
-        <a:p>
-          <a:endParaRPr lang="de-AT"/>
-        </a:p>
-      </dgm:t>
-    </dgm:pt>
-    <dgm:pt modelId="{DB1582EA-ABCE-4071-8497-60F1A6ED8D12}" type="sibTrans" cxnId="{A97B7327-AE48-472D-9446-0DAEFEE00DA3}">
-      <dgm:prSet/>
-      <dgm:spPr/>
-      <dgm:t>
-        <a:bodyPr/>
-        <a:lstStyle/>
-        <a:p>
-          <a:endParaRPr lang="de-AT"/>
-        </a:p>
-      </dgm:t>
-    </dgm:pt>
-    <dgm:pt modelId="{02F0C495-9775-493E-B1F9-99A26897E895}">
-      <dgm:prSet phldrT="[Text]"/>
-      <dgm:spPr/>
-      <dgm:t>
-        <a:bodyPr/>
-        <a:lstStyle/>
-        <a:p>
-          <a:r>
-            <a:rPr lang="de-AT" dirty="0"/>
-            <a:t> Interest/Click</a:t>
-          </a:r>
-        </a:p>
-      </dgm:t>
-    </dgm:pt>
-    <dgm:pt modelId="{02007CEE-31D8-4487-9550-7DAEFCC1CE1C}" type="parTrans" cxnId="{45F0C948-DDB7-4D39-B185-70AB8874AACB}">
-      <dgm:prSet/>
-      <dgm:spPr/>
-      <dgm:t>
-        <a:bodyPr/>
-        <a:lstStyle/>
-        <a:p>
-          <a:endParaRPr lang="de-AT"/>
-        </a:p>
-      </dgm:t>
-    </dgm:pt>
-    <dgm:pt modelId="{A32F7DEA-C307-48AA-B832-8E0AD8D25BF4}" type="sibTrans" cxnId="{45F0C948-DDB7-4D39-B185-70AB8874AACB}">
-      <dgm:prSet/>
-      <dgm:spPr/>
-      <dgm:t>
-        <a:bodyPr/>
-        <a:lstStyle/>
-        <a:p>
-          <a:endParaRPr lang="de-AT"/>
-        </a:p>
-      </dgm:t>
-    </dgm:pt>
-    <dgm:pt modelId="{72215254-A5A9-4079-A0C6-7B54BB84CE1D}">
-      <dgm:prSet phldrT="[Text]" phldr="1"/>
-      <dgm:spPr/>
-      <dgm:t>
-        <a:bodyPr/>
-        <a:lstStyle/>
-        <a:p>
-          <a:endParaRPr lang="de-AT"/>
-        </a:p>
-      </dgm:t>
-    </dgm:pt>
-    <dgm:pt modelId="{3905F313-D14B-469E-912D-E19361555E38}" type="parTrans" cxnId="{A40D34CB-8B26-4157-8F2E-571851CC7A64}">
-      <dgm:prSet/>
-      <dgm:spPr/>
-      <dgm:t>
-        <a:bodyPr/>
-        <a:lstStyle/>
-        <a:p>
-          <a:endParaRPr lang="de-AT"/>
-        </a:p>
-      </dgm:t>
-    </dgm:pt>
-    <dgm:pt modelId="{55BBBF09-7297-400B-B340-4052C37228C9}" type="sibTrans" cxnId="{A40D34CB-8B26-4157-8F2E-571851CC7A64}">
-      <dgm:prSet/>
-      <dgm:spPr/>
-      <dgm:t>
-        <a:bodyPr/>
-        <a:lstStyle/>
-        <a:p>
-          <a:endParaRPr lang="de-AT"/>
-        </a:p>
-      </dgm:t>
-    </dgm:pt>
-    <dgm:pt modelId="{87B0E78C-C8B0-4231-84EF-356E931D5703}">
-      <dgm:prSet phldrT="[Text]" phldr="1"/>
-      <dgm:spPr/>
-      <dgm:t>
-        <a:bodyPr/>
-        <a:lstStyle/>
-        <a:p>
-          <a:endParaRPr lang="de-AT"/>
-        </a:p>
-      </dgm:t>
-    </dgm:pt>
-    <dgm:pt modelId="{BA71546C-245C-4A31-8572-34E68C69AC08}" type="parTrans" cxnId="{1D5BF3C0-829D-4996-A46B-D5D295E0D450}">
-      <dgm:prSet/>
-      <dgm:spPr/>
-      <dgm:t>
-        <a:bodyPr/>
-        <a:lstStyle/>
-        <a:p>
-          <a:endParaRPr lang="de-AT"/>
-        </a:p>
-      </dgm:t>
-    </dgm:pt>
-    <dgm:pt modelId="{1200F01B-4BB2-4241-8EFF-698A091FAC6C}" type="sibTrans" cxnId="{1D5BF3C0-829D-4996-A46B-D5D295E0D450}">
-      <dgm:prSet/>
-      <dgm:spPr/>
-      <dgm:t>
-        <a:bodyPr/>
-        <a:lstStyle/>
-        <a:p>
-          <a:endParaRPr lang="de-AT"/>
-        </a:p>
-      </dgm:t>
-    </dgm:pt>
-    <dgm:pt modelId="{193B1A42-D7ED-458A-9848-E6FA0B943A99}" type="pres">
-      <dgm:prSet presAssocID="{7858CB19-2C29-4D43-894A-87C04F05DD9A}" presName="linearFlow" presStyleCnt="0">
-        <dgm:presLayoutVars>
-          <dgm:dir/>
-          <dgm:animLvl val="lvl"/>
-          <dgm:resizeHandles val="exact"/>
-        </dgm:presLayoutVars>
-      </dgm:prSet>
-      <dgm:spPr/>
-    </dgm:pt>
-    <dgm:pt modelId="{2A2A44A7-FDC1-4483-830A-597A0374F35A}" type="pres">
-      <dgm:prSet presAssocID="{353D1A30-909A-4EEB-905A-729F4115AA5D}" presName="composite" presStyleCnt="0"/>
-      <dgm:spPr/>
-    </dgm:pt>
-    <dgm:pt modelId="{2AF1B5C7-FB12-44A8-BCF1-7DE8AE43FD05}" type="pres">
-      <dgm:prSet presAssocID="{353D1A30-909A-4EEB-905A-729F4115AA5D}" presName="parentText" presStyleLbl="alignNode1" presStyleIdx="0" presStyleCnt="3">
-        <dgm:presLayoutVars>
-          <dgm:chMax val="1"/>
-          <dgm:bulletEnabled val="1"/>
-        </dgm:presLayoutVars>
-      </dgm:prSet>
-      <dgm:spPr/>
-    </dgm:pt>
-    <dgm:pt modelId="{8C6E74E7-EADC-4E4F-ADE0-B90A1156DB8B}" type="pres">
-      <dgm:prSet presAssocID="{353D1A30-909A-4EEB-905A-729F4115AA5D}" presName="descendantText" presStyleLbl="alignAcc1" presStyleIdx="0" presStyleCnt="3">
-        <dgm:presLayoutVars>
-          <dgm:bulletEnabled val="1"/>
-        </dgm:presLayoutVars>
-      </dgm:prSet>
-      <dgm:spPr/>
-    </dgm:pt>
-    <dgm:pt modelId="{0C3DED34-9564-4E9E-A216-61B6C5A12F04}" type="pres">
-      <dgm:prSet presAssocID="{E414067B-B3A5-4AA9-BFF9-F48BB24E188A}" presName="sp" presStyleCnt="0"/>
-      <dgm:spPr/>
-    </dgm:pt>
-    <dgm:pt modelId="{2839F16C-BE6D-44CE-BE3C-658D90180F6D}" type="pres">
-      <dgm:prSet presAssocID="{A555E536-BAD2-40C7-A4AC-F35394692C25}" presName="composite" presStyleCnt="0"/>
-      <dgm:spPr/>
-    </dgm:pt>
-    <dgm:pt modelId="{B459E718-A534-4025-90D9-2C9919CF9D35}" type="pres">
-      <dgm:prSet presAssocID="{A555E536-BAD2-40C7-A4AC-F35394692C25}" presName="parentText" presStyleLbl="alignNode1" presStyleIdx="1" presStyleCnt="3">
-        <dgm:presLayoutVars>
-          <dgm:chMax val="1"/>
-          <dgm:bulletEnabled val="1"/>
-        </dgm:presLayoutVars>
-      </dgm:prSet>
-      <dgm:spPr/>
-    </dgm:pt>
-    <dgm:pt modelId="{909871AE-39AA-41A9-9006-1046C1E84180}" type="pres">
-      <dgm:prSet presAssocID="{A555E536-BAD2-40C7-A4AC-F35394692C25}" presName="descendantText" presStyleLbl="alignAcc1" presStyleIdx="1" presStyleCnt="3">
-        <dgm:presLayoutVars>
-          <dgm:bulletEnabled val="1"/>
-        </dgm:presLayoutVars>
-      </dgm:prSet>
-      <dgm:spPr/>
-    </dgm:pt>
-    <dgm:pt modelId="{0821E941-5132-47BA-B273-1666C522BAB5}" type="pres">
-      <dgm:prSet presAssocID="{B5452E2D-02D0-4D5B-A824-48FFA9823618}" presName="sp" presStyleCnt="0"/>
-      <dgm:spPr/>
-    </dgm:pt>
-    <dgm:pt modelId="{34A9AFA0-1D75-4AC3-AB3B-C144F67049D7}" type="pres">
-      <dgm:prSet presAssocID="{02F0C495-9775-493E-B1F9-99A26897E895}" presName="composite" presStyleCnt="0"/>
-      <dgm:spPr/>
-    </dgm:pt>
-    <dgm:pt modelId="{63F6616A-84A2-4C74-AC51-351D713F9A28}" type="pres">
-      <dgm:prSet presAssocID="{02F0C495-9775-493E-B1F9-99A26897E895}" presName="parentText" presStyleLbl="alignNode1" presStyleIdx="2" presStyleCnt="3">
-        <dgm:presLayoutVars>
-          <dgm:chMax val="1"/>
-          <dgm:bulletEnabled val="1"/>
-        </dgm:presLayoutVars>
-      </dgm:prSet>
-      <dgm:spPr/>
-    </dgm:pt>
-    <dgm:pt modelId="{5C56B234-BE1E-48C9-B0BA-2A0E3F895A7E}" type="pres">
-      <dgm:prSet presAssocID="{02F0C495-9775-493E-B1F9-99A26897E895}" presName="descendantText" presStyleLbl="alignAcc1" presStyleIdx="2" presStyleCnt="3">
-        <dgm:presLayoutVars>
-          <dgm:bulletEnabled val="1"/>
-        </dgm:presLayoutVars>
-      </dgm:prSet>
-      <dgm:spPr/>
-    </dgm:pt>
-  </dgm:ptLst>
-  <dgm:cxnLst>
-    <dgm:cxn modelId="{A97B7327-AE48-472D-9446-0DAEFEE00DA3}" srcId="{A555E536-BAD2-40C7-A4AC-F35394692C25}" destId="{493F9CE4-475F-439F-B976-CF6A3E43EE72}" srcOrd="1" destOrd="0" parTransId="{24BDF8BE-1CAA-493F-BDA9-9EED6DD97742}" sibTransId="{DB1582EA-ABCE-4071-8497-60F1A6ED8D12}"/>
-    <dgm:cxn modelId="{CA3C422B-7F71-4D27-9612-837E630288F8}" srcId="{7858CB19-2C29-4D43-894A-87C04F05DD9A}" destId="{353D1A30-909A-4EEB-905A-729F4115AA5D}" srcOrd="0" destOrd="0" parTransId="{FF292C6B-0192-4A9E-ADDF-574265DE0B16}" sibTransId="{E414067B-B3A5-4AA9-BFF9-F48BB24E188A}"/>
-    <dgm:cxn modelId="{B4E4D82B-6BD0-4915-841D-8F6B4420551C}" type="presOf" srcId="{02F0C495-9775-493E-B1F9-99A26897E895}" destId="{63F6616A-84A2-4C74-AC51-351D713F9A28}" srcOrd="0" destOrd="0" presId="urn:microsoft.com/office/officeart/2005/8/layout/chevron2"/>
-    <dgm:cxn modelId="{53C8122E-C915-47F2-B783-7E0DB4823BD0}" type="presOf" srcId="{72215254-A5A9-4079-A0C6-7B54BB84CE1D}" destId="{5C56B234-BE1E-48C9-B0BA-2A0E3F895A7E}" srcOrd="0" destOrd="0" presId="urn:microsoft.com/office/officeart/2005/8/layout/chevron2"/>
-    <dgm:cxn modelId="{9047A568-9CAB-4669-9BF6-C2C0C5ED3FEA}" srcId="{353D1A30-909A-4EEB-905A-729F4115AA5D}" destId="{1EC41F69-532C-4B21-BBCD-48BA0E98FE13}" srcOrd="0" destOrd="0" parTransId="{E5CA7C5D-D29E-4BF0-A9CB-1BAE4863ACE7}" sibTransId="{0FFC74D7-0697-46B9-B724-0E2AC8858B30}"/>
-    <dgm:cxn modelId="{45F0C948-DDB7-4D39-B185-70AB8874AACB}" srcId="{7858CB19-2C29-4D43-894A-87C04F05DD9A}" destId="{02F0C495-9775-493E-B1F9-99A26897E895}" srcOrd="2" destOrd="0" parTransId="{02007CEE-31D8-4487-9550-7DAEFCC1CE1C}" sibTransId="{A32F7DEA-C307-48AA-B832-8E0AD8D25BF4}"/>
-    <dgm:cxn modelId="{6F6C157E-AD12-4FFE-85EB-C20220BD8667}" type="presOf" srcId="{87B0E78C-C8B0-4231-84EF-356E931D5703}" destId="{5C56B234-BE1E-48C9-B0BA-2A0E3F895A7E}" srcOrd="0" destOrd="1" presId="urn:microsoft.com/office/officeart/2005/8/layout/chevron2"/>
-    <dgm:cxn modelId="{82BA1784-F43F-4B0F-ADB4-20E9671C67F5}" srcId="{353D1A30-909A-4EEB-905A-729F4115AA5D}" destId="{852BFE89-2430-41B3-A494-FC69372405CC}" srcOrd="1" destOrd="0" parTransId="{FB5A6BBC-3E09-4651-B532-F8539F776A9B}" sibTransId="{9E2D985C-0178-49B8-89D8-AA5E1E43CA32}"/>
-    <dgm:cxn modelId="{425EB294-1D68-4A5B-879E-8DB14EF0851D}" type="presOf" srcId="{7858CB19-2C29-4D43-894A-87C04F05DD9A}" destId="{193B1A42-D7ED-458A-9848-E6FA0B943A99}" srcOrd="0" destOrd="0" presId="urn:microsoft.com/office/officeart/2005/8/layout/chevron2"/>
-    <dgm:cxn modelId="{5AA0E3B0-A88C-4866-92FA-C3841D885D54}" type="presOf" srcId="{353D1A30-909A-4EEB-905A-729F4115AA5D}" destId="{2AF1B5C7-FB12-44A8-BCF1-7DE8AE43FD05}" srcOrd="0" destOrd="0" presId="urn:microsoft.com/office/officeart/2005/8/layout/chevron2"/>
-    <dgm:cxn modelId="{88BC6DB4-AADA-4668-88F4-A776AD704291}" type="presOf" srcId="{852BFE89-2430-41B3-A494-FC69372405CC}" destId="{8C6E74E7-EADC-4E4F-ADE0-B90A1156DB8B}" srcOrd="0" destOrd="1" presId="urn:microsoft.com/office/officeart/2005/8/layout/chevron2"/>
-    <dgm:cxn modelId="{1D5BF3C0-829D-4996-A46B-D5D295E0D450}" srcId="{02F0C495-9775-493E-B1F9-99A26897E895}" destId="{87B0E78C-C8B0-4231-84EF-356E931D5703}" srcOrd="1" destOrd="0" parTransId="{BA71546C-245C-4A31-8572-34E68C69AC08}" sibTransId="{1200F01B-4BB2-4241-8EFF-698A091FAC6C}"/>
-    <dgm:cxn modelId="{8AFC7EC8-ED21-4D1D-997D-F627C16D1BBB}" type="presOf" srcId="{A555E536-BAD2-40C7-A4AC-F35394692C25}" destId="{B459E718-A534-4025-90D9-2C9919CF9D35}" srcOrd="0" destOrd="0" presId="urn:microsoft.com/office/officeart/2005/8/layout/chevron2"/>
-    <dgm:cxn modelId="{A40D34CB-8B26-4157-8F2E-571851CC7A64}" srcId="{02F0C495-9775-493E-B1F9-99A26897E895}" destId="{72215254-A5A9-4079-A0C6-7B54BB84CE1D}" srcOrd="0" destOrd="0" parTransId="{3905F313-D14B-469E-912D-E19361555E38}" sibTransId="{55BBBF09-7297-400B-B340-4052C37228C9}"/>
-    <dgm:cxn modelId="{17CBA2D1-33CA-452F-A4A3-892D8E526AFA}" type="presOf" srcId="{493F9CE4-475F-439F-B976-CF6A3E43EE72}" destId="{909871AE-39AA-41A9-9006-1046C1E84180}" srcOrd="0" destOrd="1" presId="urn:microsoft.com/office/officeart/2005/8/layout/chevron2"/>
-    <dgm:cxn modelId="{39649AD7-EEED-4290-BB43-87D010CCDF67}" srcId="{7858CB19-2C29-4D43-894A-87C04F05DD9A}" destId="{A555E536-BAD2-40C7-A4AC-F35394692C25}" srcOrd="1" destOrd="0" parTransId="{4DA26BF4-50D3-44EF-B368-40DC089228B5}" sibTransId="{B5452E2D-02D0-4D5B-A824-48FFA9823618}"/>
-    <dgm:cxn modelId="{417765D9-293A-42AA-89C5-8C453A7A72C4}" srcId="{A555E536-BAD2-40C7-A4AC-F35394692C25}" destId="{DAFC6534-4A70-4679-B51F-01DF53962FD6}" srcOrd="0" destOrd="0" parTransId="{EA967D29-A690-4AF8-A66E-646B38434B64}" sibTransId="{248CE566-B665-4E8A-B62B-E1FD7365821B}"/>
-    <dgm:cxn modelId="{FE8468E6-2D39-4281-9AB9-376D4726BA07}" type="presOf" srcId="{DAFC6534-4A70-4679-B51F-01DF53962FD6}" destId="{909871AE-39AA-41A9-9006-1046C1E84180}" srcOrd="0" destOrd="0" presId="urn:microsoft.com/office/officeart/2005/8/layout/chevron2"/>
-    <dgm:cxn modelId="{87E8DDF5-B107-4809-99C2-DBEA5CC70C69}" type="presOf" srcId="{1EC41F69-532C-4B21-BBCD-48BA0E98FE13}" destId="{8C6E74E7-EADC-4E4F-ADE0-B90A1156DB8B}" srcOrd="0" destOrd="0" presId="urn:microsoft.com/office/officeart/2005/8/layout/chevron2"/>
-    <dgm:cxn modelId="{0A3D1E98-B2CA-433D-BB32-CFA168297BAE}" type="presParOf" srcId="{193B1A42-D7ED-458A-9848-E6FA0B943A99}" destId="{2A2A44A7-FDC1-4483-830A-597A0374F35A}" srcOrd="0" destOrd="0" presId="urn:microsoft.com/office/officeart/2005/8/layout/chevron2"/>
-    <dgm:cxn modelId="{CC80658A-11FB-48C0-938C-51F697D36314}" type="presParOf" srcId="{2A2A44A7-FDC1-4483-830A-597A0374F35A}" destId="{2AF1B5C7-FB12-44A8-BCF1-7DE8AE43FD05}" srcOrd="0" destOrd="0" presId="urn:microsoft.com/office/officeart/2005/8/layout/chevron2"/>
-    <dgm:cxn modelId="{74974C7B-55AD-4725-B827-C954EAD04DF3}" type="presParOf" srcId="{2A2A44A7-FDC1-4483-830A-597A0374F35A}" destId="{8C6E74E7-EADC-4E4F-ADE0-B90A1156DB8B}" srcOrd="1" destOrd="0" presId="urn:microsoft.com/office/officeart/2005/8/layout/chevron2"/>
-    <dgm:cxn modelId="{13CB4933-7D78-4A21-97F9-9F43560A5879}" type="presParOf" srcId="{193B1A42-D7ED-458A-9848-E6FA0B943A99}" destId="{0C3DED34-9564-4E9E-A216-61B6C5A12F04}" srcOrd="1" destOrd="0" presId="urn:microsoft.com/office/officeart/2005/8/layout/chevron2"/>
-    <dgm:cxn modelId="{A1978D05-0452-43D1-91FE-AABD6E1AEE22}" type="presParOf" srcId="{193B1A42-D7ED-458A-9848-E6FA0B943A99}" destId="{2839F16C-BE6D-44CE-BE3C-658D90180F6D}" srcOrd="2" destOrd="0" presId="urn:microsoft.com/office/officeart/2005/8/layout/chevron2"/>
-    <dgm:cxn modelId="{94F87BB7-93E5-40C3-9BA6-FA12B8593469}" type="presParOf" srcId="{2839F16C-BE6D-44CE-BE3C-658D90180F6D}" destId="{B459E718-A534-4025-90D9-2C9919CF9D35}" srcOrd="0" destOrd="0" presId="urn:microsoft.com/office/officeart/2005/8/layout/chevron2"/>
-    <dgm:cxn modelId="{EAA7C199-62D8-46F0-826A-1FA50BD1EF24}" type="presParOf" srcId="{2839F16C-BE6D-44CE-BE3C-658D90180F6D}" destId="{909871AE-39AA-41A9-9006-1046C1E84180}" srcOrd="1" destOrd="0" presId="urn:microsoft.com/office/officeart/2005/8/layout/chevron2"/>
-    <dgm:cxn modelId="{BA24B9C4-3069-47CB-AF29-F4B67379B32D}" type="presParOf" srcId="{193B1A42-D7ED-458A-9848-E6FA0B943A99}" destId="{0821E941-5132-47BA-B273-1666C522BAB5}" srcOrd="3" destOrd="0" presId="urn:microsoft.com/office/officeart/2005/8/layout/chevron2"/>
-    <dgm:cxn modelId="{9ACBCEE9-38C2-4128-9329-A799BAA563CB}" type="presParOf" srcId="{193B1A42-D7ED-458A-9848-E6FA0B943A99}" destId="{34A9AFA0-1D75-4AC3-AB3B-C144F67049D7}" srcOrd="4" destOrd="0" presId="urn:microsoft.com/office/officeart/2005/8/layout/chevron2"/>
-    <dgm:cxn modelId="{4721C2C4-A3AC-462D-B04F-D732CDAD2CC7}" type="presParOf" srcId="{34A9AFA0-1D75-4AC3-AB3B-C144F67049D7}" destId="{63F6616A-84A2-4C74-AC51-351D713F9A28}" srcOrd="0" destOrd="0" presId="urn:microsoft.com/office/officeart/2005/8/layout/chevron2"/>
-    <dgm:cxn modelId="{DD0222DA-E9A1-4314-BC70-DFDB28AC33AB}" type="presParOf" srcId="{34A9AFA0-1D75-4AC3-AB3B-C144F67049D7}" destId="{5C56B234-BE1E-48C9-B0BA-2A0E3F895A7E}" srcOrd="1" destOrd="0" presId="urn:microsoft.com/office/officeart/2005/8/layout/chevron2"/>
-  </dgm:cxnLst>
-  <dgm:bg/>
-  <dgm:whole/>
-  <dgm:extLst>
-    <a:ext uri="http://schemas.microsoft.com/office/drawing/2008/diagram">
-      <dsp:dataModelExt xmlns:dsp="http://schemas.microsoft.com/office/drawing/2008/diagram" relId="rId6" minVer="http://schemas.openxmlformats.org/drawingml/2006/diagram"/>
-    </a:ext>
-  </dgm:extLst>
-</dgm:dataModel>
-</file>
-
-<file path=ppt/diagrams/drawing1.xml><?xml version="1.0" encoding="utf-8"?>
-<dsp:drawing xmlns:dgm="http://schemas.openxmlformats.org/drawingml/2006/diagram" xmlns:dsp="http://schemas.microsoft.com/office/drawing/2008/diagram" xmlns:a="http://schemas.openxmlformats.org/drawingml/2006/main">
-  <dsp:spTree>
-    <dsp:nvGrpSpPr>
-      <dsp:cNvPr id="0" name=""/>
-      <dsp:cNvGrpSpPr/>
-    </dsp:nvGrpSpPr>
-    <dsp:grpSpPr/>
-    <dsp:sp modelId="{2AF1B5C7-FB12-44A8-BCF1-7DE8AE43FD05}">
-      <dsp:nvSpPr>
-        <dsp:cNvPr id="0" name=""/>
-        <dsp:cNvSpPr/>
-      </dsp:nvSpPr>
-      <dsp:spPr>
-        <a:xfrm rot="5400000">
-          <a:off x="-289718" y="292805"/>
-          <a:ext cx="1931458" cy="1352020"/>
+<file path=ppt/notesSlides/notesSlide1.xml><?xml version="1.0" encoding="utf-8"?>
+<p:notes xmlns:a="http://schemas.openxmlformats.org/drawingml/2006/main" xmlns:r="http://schemas.openxmlformats.org/officeDocument/2006/relationships" xmlns:p="http://schemas.openxmlformats.org/presentationml/2006/main">
+  <p:cSld>
+    <p:spTree>
+      <p:nvGrpSpPr>
+        <p:cNvPr id="1" name=""/>
+        <p:cNvGrpSpPr/>
+        <p:nvPr/>
+      </p:nvGrpSpPr>
+      <p:grpSpPr>
+        <a:xfrm>
+          <a:off x="0" y="0"/>
+          <a:ext cx="0" cy="0"/>
+          <a:chOff x="0" y="0"/>
+          <a:chExt cx="0" cy="0"/>
         </a:xfrm>
-        <a:prstGeom prst="chevron">
-          <a:avLst/>
-        </a:prstGeom>
-        <a:solidFill>
-          <a:schemeClr val="accent1">
-            <a:hueOff val="0"/>
-            <a:satOff val="0"/>
-            <a:lumOff val="0"/>
-            <a:alphaOff val="0"/>
-          </a:schemeClr>
-        </a:solidFill>
-        <a:ln w="19050" cap="flat" cmpd="sng" algn="ctr">
-          <a:solidFill>
-            <a:schemeClr val="accent1">
-              <a:hueOff val="0"/>
-              <a:satOff val="0"/>
-              <a:lumOff val="0"/>
-              <a:alphaOff val="0"/>
-            </a:schemeClr>
-          </a:solidFill>
-          <a:prstDash val="solid"/>
-          <a:miter lim="800000"/>
-        </a:ln>
-        <a:effectLst/>
-      </dsp:spPr>
-      <dsp:style>
-        <a:lnRef idx="2">
-          <a:scrgbClr r="0" g="0" b="0"/>
-        </a:lnRef>
-        <a:fillRef idx="1">
-          <a:scrgbClr r="0" g="0" b="0"/>
-        </a:fillRef>
-        <a:effectRef idx="0">
-          <a:scrgbClr r="0" g="0" b="0"/>
-        </a:effectRef>
-        <a:fontRef idx="minor">
-          <a:schemeClr val="lt1"/>
-        </a:fontRef>
-      </dsp:style>
-      <dsp:txBody>
-        <a:bodyPr spcFirstLastPara="0" vert="horz" wrap="square" lIns="10795" tIns="10795" rIns="10795" bIns="10795" numCol="1" spcCol="1270" anchor="ctr" anchorCtr="0">
-          <a:noAutofit/>
-        </a:bodyPr>
-        <a:lstStyle/>
-        <a:p>
-          <a:pPr marL="0" lvl="0" indent="0" algn="ctr" defTabSz="755650">
-            <a:lnSpc>
-              <a:spcPct val="90000"/>
-            </a:lnSpc>
-            <a:spcBef>
-              <a:spcPct val="0"/>
-            </a:spcBef>
-            <a:spcAft>
-              <a:spcPct val="35000"/>
-            </a:spcAft>
-            <a:buNone/>
-          </a:pPr>
-          <a:r>
-            <a:rPr lang="de-AT" sz="1700" kern="1200" dirty="0"/>
-            <a:t>Awareness</a:t>
-          </a:r>
-        </a:p>
-      </dsp:txBody>
-      <dsp:txXfrm rot="-5400000">
-        <a:off x="1" y="679096"/>
-        <a:ext cx="1352020" cy="579438"/>
-      </dsp:txXfrm>
-    </dsp:sp>
-    <dsp:sp modelId="{8C6E74E7-EADC-4E4F-ADE0-B90A1156DB8B}">
-      <dsp:nvSpPr>
-        <dsp:cNvPr id="0" name=""/>
-        <dsp:cNvSpPr/>
-      </dsp:nvSpPr>
-      <dsp:spPr>
-        <a:xfrm rot="5400000">
-          <a:off x="4112286" y="-2757179"/>
-          <a:ext cx="1255447" cy="6775979"/>
-        </a:xfrm>
-        <a:prstGeom prst="round2SameRect">
-          <a:avLst/>
-        </a:prstGeom>
-        <a:solidFill>
-          <a:schemeClr val="lt1">
-            <a:alpha val="90000"/>
-            <a:hueOff val="0"/>
-            <a:satOff val="0"/>
-            <a:lumOff val="0"/>
-            <a:alphaOff val="0"/>
-          </a:schemeClr>
-        </a:solidFill>
-        <a:ln w="19050" cap="flat" cmpd="sng" algn="ctr">
-          <a:solidFill>
-            <a:schemeClr val="accent1">
-              <a:hueOff val="0"/>
-              <a:satOff val="0"/>
-              <a:lumOff val="0"/>
-              <a:alphaOff val="0"/>
-            </a:schemeClr>
-          </a:solidFill>
-          <a:prstDash val="solid"/>
-          <a:miter lim="800000"/>
-        </a:ln>
-        <a:effectLst/>
-      </dsp:spPr>
-      <dsp:style>
-        <a:lnRef idx="2">
-          <a:scrgbClr r="0" g="0" b="0"/>
-        </a:lnRef>
-        <a:fillRef idx="1">
-          <a:scrgbClr r="0" g="0" b="0"/>
-        </a:fillRef>
-        <a:effectRef idx="0">
-          <a:scrgbClr r="0" g="0" b="0"/>
-        </a:effectRef>
-        <a:fontRef idx="minor"/>
-      </dsp:style>
-      <dsp:txBody>
-        <a:bodyPr spcFirstLastPara="0" vert="horz" wrap="square" lIns="248920" tIns="22225" rIns="22225" bIns="22225" numCol="1" spcCol="1270" anchor="ctr" anchorCtr="0">
-          <a:noAutofit/>
-        </a:bodyPr>
-        <a:lstStyle/>
-        <a:p>
-          <a:pPr marL="285750" lvl="1" indent="-285750" algn="l" defTabSz="1555750">
-            <a:lnSpc>
-              <a:spcPct val="90000"/>
-            </a:lnSpc>
-            <a:spcBef>
-              <a:spcPct val="0"/>
-            </a:spcBef>
-            <a:spcAft>
-              <a:spcPct val="15000"/>
-            </a:spcAft>
-            <a:buChar char="•"/>
-          </a:pPr>
-          <a:endParaRPr lang="de-AT" sz="3500" kern="1200"/>
-        </a:p>
-        <a:p>
-          <a:pPr marL="285750" lvl="1" indent="-285750" algn="l" defTabSz="1555750">
-            <a:lnSpc>
-              <a:spcPct val="90000"/>
-            </a:lnSpc>
-            <a:spcBef>
-              <a:spcPct val="0"/>
-            </a:spcBef>
-            <a:spcAft>
-              <a:spcPct val="15000"/>
-            </a:spcAft>
-            <a:buChar char="•"/>
-          </a:pPr>
-          <a:endParaRPr lang="de-AT" sz="3500" kern="1200" dirty="0"/>
-        </a:p>
-      </dsp:txBody>
-      <dsp:txXfrm rot="-5400000">
-        <a:off x="1352020" y="64373"/>
-        <a:ext cx="6714693" cy="1132875"/>
-      </dsp:txXfrm>
-    </dsp:sp>
-    <dsp:sp modelId="{B459E718-A534-4025-90D9-2C9919CF9D35}">
-      <dsp:nvSpPr>
-        <dsp:cNvPr id="0" name=""/>
-        <dsp:cNvSpPr/>
-      </dsp:nvSpPr>
-      <dsp:spPr>
-        <a:xfrm rot="5400000">
-          <a:off x="-289718" y="2033323"/>
-          <a:ext cx="1931458" cy="1352020"/>
-        </a:xfrm>
-        <a:prstGeom prst="chevron">
-          <a:avLst/>
-        </a:prstGeom>
-        <a:solidFill>
-          <a:schemeClr val="accent1">
-            <a:hueOff val="0"/>
-            <a:satOff val="0"/>
-            <a:lumOff val="0"/>
-            <a:alphaOff val="0"/>
-          </a:schemeClr>
-        </a:solidFill>
-        <a:ln w="19050" cap="flat" cmpd="sng" algn="ctr">
-          <a:solidFill>
-            <a:schemeClr val="accent1">
-              <a:hueOff val="0"/>
-              <a:satOff val="0"/>
-              <a:lumOff val="0"/>
-              <a:alphaOff val="0"/>
-            </a:schemeClr>
-          </a:solidFill>
-          <a:prstDash val="solid"/>
-          <a:miter lim="800000"/>
-        </a:ln>
-        <a:effectLst/>
-      </dsp:spPr>
-      <dsp:style>
-        <a:lnRef idx="2">
-          <a:scrgbClr r="0" g="0" b="0"/>
-        </a:lnRef>
-        <a:fillRef idx="1">
-          <a:scrgbClr r="0" g="0" b="0"/>
-        </a:fillRef>
-        <a:effectRef idx="0">
-          <a:scrgbClr r="0" g="0" b="0"/>
-        </a:effectRef>
-        <a:fontRef idx="minor">
-          <a:schemeClr val="lt1"/>
-        </a:fontRef>
-      </dsp:style>
-      <dsp:txBody>
-        <a:bodyPr spcFirstLastPara="0" vert="horz" wrap="square" lIns="10795" tIns="10795" rIns="10795" bIns="10795" numCol="1" spcCol="1270" anchor="ctr" anchorCtr="0">
-          <a:noAutofit/>
-        </a:bodyPr>
-        <a:lstStyle/>
-        <a:p>
-          <a:pPr marL="0" lvl="0" indent="0" algn="ctr" defTabSz="755650">
-            <a:lnSpc>
-              <a:spcPct val="90000"/>
-            </a:lnSpc>
-            <a:spcBef>
-              <a:spcPct val="0"/>
-            </a:spcBef>
-            <a:spcAft>
-              <a:spcPct val="35000"/>
-            </a:spcAft>
-            <a:buNone/>
-          </a:pPr>
-          <a:r>
-            <a:rPr lang="de-AT" sz="1700" kern="1200" dirty="0" err="1"/>
-            <a:t>Consideration</a:t>
-          </a:r>
-          <a:endParaRPr lang="de-AT" sz="1700" kern="1200" dirty="0"/>
-        </a:p>
-      </dsp:txBody>
-      <dsp:txXfrm rot="-5400000">
-        <a:off x="1" y="2419614"/>
-        <a:ext cx="1352020" cy="579438"/>
-      </dsp:txXfrm>
-    </dsp:sp>
-    <dsp:sp modelId="{909871AE-39AA-41A9-9006-1046C1E84180}">
-      <dsp:nvSpPr>
-        <dsp:cNvPr id="0" name=""/>
-        <dsp:cNvSpPr/>
-      </dsp:nvSpPr>
-      <dsp:spPr>
-        <a:xfrm rot="5400000">
-          <a:off x="4112286" y="-1016661"/>
-          <a:ext cx="1255447" cy="6775979"/>
-        </a:xfrm>
-        <a:prstGeom prst="round2SameRect">
-          <a:avLst/>
-        </a:prstGeom>
-        <a:solidFill>
-          <a:schemeClr val="lt1">
-            <a:alpha val="90000"/>
-            <a:hueOff val="0"/>
-            <a:satOff val="0"/>
-            <a:lumOff val="0"/>
-            <a:alphaOff val="0"/>
-          </a:schemeClr>
-        </a:solidFill>
-        <a:ln w="19050" cap="flat" cmpd="sng" algn="ctr">
-          <a:solidFill>
-            <a:schemeClr val="accent1">
-              <a:hueOff val="0"/>
-              <a:satOff val="0"/>
-              <a:lumOff val="0"/>
-              <a:alphaOff val="0"/>
-            </a:schemeClr>
-          </a:solidFill>
-          <a:prstDash val="solid"/>
-          <a:miter lim="800000"/>
-        </a:ln>
-        <a:effectLst/>
-      </dsp:spPr>
-      <dsp:style>
-        <a:lnRef idx="2">
-          <a:scrgbClr r="0" g="0" b="0"/>
-        </a:lnRef>
-        <a:fillRef idx="1">
-          <a:scrgbClr r="0" g="0" b="0"/>
-        </a:fillRef>
-        <a:effectRef idx="0">
-          <a:scrgbClr r="0" g="0" b="0"/>
-        </a:effectRef>
-        <a:fontRef idx="minor"/>
-      </dsp:style>
-      <dsp:txBody>
-        <a:bodyPr spcFirstLastPara="0" vert="horz" wrap="square" lIns="248920" tIns="22225" rIns="22225" bIns="22225" numCol="1" spcCol="1270" anchor="ctr" anchorCtr="0">
-          <a:noAutofit/>
-        </a:bodyPr>
-        <a:lstStyle/>
-        <a:p>
-          <a:pPr marL="285750" lvl="1" indent="-285750" algn="l" defTabSz="1555750">
-            <a:lnSpc>
-              <a:spcPct val="90000"/>
-            </a:lnSpc>
-            <a:spcBef>
-              <a:spcPct val="0"/>
-            </a:spcBef>
-            <a:spcAft>
-              <a:spcPct val="15000"/>
-            </a:spcAft>
-            <a:buChar char="•"/>
-          </a:pPr>
-          <a:endParaRPr lang="de-AT" sz="3500" kern="1200"/>
-        </a:p>
-        <a:p>
-          <a:pPr marL="285750" lvl="1" indent="-285750" algn="l" defTabSz="1555750">
-            <a:lnSpc>
-              <a:spcPct val="90000"/>
-            </a:lnSpc>
-            <a:spcBef>
-              <a:spcPct val="0"/>
-            </a:spcBef>
-            <a:spcAft>
-              <a:spcPct val="15000"/>
-            </a:spcAft>
-            <a:buChar char="•"/>
-          </a:pPr>
-          <a:endParaRPr lang="de-AT" sz="3500" kern="1200"/>
-        </a:p>
-      </dsp:txBody>
-      <dsp:txXfrm rot="-5400000">
-        <a:off x="1352020" y="1804891"/>
-        <a:ext cx="6714693" cy="1132875"/>
-      </dsp:txXfrm>
-    </dsp:sp>
-    <dsp:sp modelId="{63F6616A-84A2-4C74-AC51-351D713F9A28}">
-      <dsp:nvSpPr>
-        <dsp:cNvPr id="0" name=""/>
-        <dsp:cNvSpPr/>
-      </dsp:nvSpPr>
-      <dsp:spPr>
-        <a:xfrm rot="5400000">
-          <a:off x="-289718" y="3773840"/>
-          <a:ext cx="1931458" cy="1352020"/>
-        </a:xfrm>
-        <a:prstGeom prst="chevron">
-          <a:avLst/>
-        </a:prstGeom>
-        <a:solidFill>
-          <a:schemeClr val="accent1">
-            <a:hueOff val="0"/>
-            <a:satOff val="0"/>
-            <a:lumOff val="0"/>
-            <a:alphaOff val="0"/>
-          </a:schemeClr>
-        </a:solidFill>
-        <a:ln w="19050" cap="flat" cmpd="sng" algn="ctr">
-          <a:solidFill>
-            <a:schemeClr val="accent1">
-              <a:hueOff val="0"/>
-              <a:satOff val="0"/>
-              <a:lumOff val="0"/>
-              <a:alphaOff val="0"/>
-            </a:schemeClr>
-          </a:solidFill>
-          <a:prstDash val="solid"/>
-          <a:miter lim="800000"/>
-        </a:ln>
-        <a:effectLst/>
-      </dsp:spPr>
-      <dsp:style>
-        <a:lnRef idx="2">
-          <a:scrgbClr r="0" g="0" b="0"/>
-        </a:lnRef>
-        <a:fillRef idx="1">
-          <a:scrgbClr r="0" g="0" b="0"/>
-        </a:fillRef>
-        <a:effectRef idx="0">
-          <a:scrgbClr r="0" g="0" b="0"/>
-        </a:effectRef>
-        <a:fontRef idx="minor">
-          <a:schemeClr val="lt1"/>
-        </a:fontRef>
-      </dsp:style>
-      <dsp:txBody>
-        <a:bodyPr spcFirstLastPara="0" vert="horz" wrap="square" lIns="10795" tIns="10795" rIns="10795" bIns="10795" numCol="1" spcCol="1270" anchor="ctr" anchorCtr="0">
-          <a:noAutofit/>
-        </a:bodyPr>
-        <a:lstStyle/>
-        <a:p>
-          <a:pPr marL="0" lvl="0" indent="0" algn="ctr" defTabSz="755650">
-            <a:lnSpc>
-              <a:spcPct val="90000"/>
-            </a:lnSpc>
-            <a:spcBef>
-              <a:spcPct val="0"/>
-            </a:spcBef>
-            <a:spcAft>
-              <a:spcPct val="35000"/>
-            </a:spcAft>
-            <a:buNone/>
-          </a:pPr>
-          <a:r>
-            <a:rPr lang="de-AT" sz="1700" kern="1200" dirty="0"/>
-            <a:t> Interest/Click</a:t>
-          </a:r>
-        </a:p>
-      </dsp:txBody>
-      <dsp:txXfrm rot="-5400000">
-        <a:off x="1" y="4160131"/>
-        <a:ext cx="1352020" cy="579438"/>
-      </dsp:txXfrm>
-    </dsp:sp>
-    <dsp:sp modelId="{5C56B234-BE1E-48C9-B0BA-2A0E3F895A7E}">
-      <dsp:nvSpPr>
-        <dsp:cNvPr id="0" name=""/>
-        <dsp:cNvSpPr/>
-      </dsp:nvSpPr>
-      <dsp:spPr>
-        <a:xfrm rot="5400000">
-          <a:off x="4112286" y="723856"/>
-          <a:ext cx="1255447" cy="6775979"/>
-        </a:xfrm>
-        <a:prstGeom prst="round2SameRect">
-          <a:avLst/>
-        </a:prstGeom>
-        <a:solidFill>
-          <a:schemeClr val="lt1">
-            <a:alpha val="90000"/>
-            <a:hueOff val="0"/>
-            <a:satOff val="0"/>
-            <a:lumOff val="0"/>
-            <a:alphaOff val="0"/>
-          </a:schemeClr>
-        </a:solidFill>
-        <a:ln w="19050" cap="flat" cmpd="sng" algn="ctr">
-          <a:solidFill>
-            <a:schemeClr val="accent1">
-              <a:hueOff val="0"/>
-              <a:satOff val="0"/>
-              <a:lumOff val="0"/>
-              <a:alphaOff val="0"/>
-            </a:schemeClr>
-          </a:solidFill>
-          <a:prstDash val="solid"/>
-          <a:miter lim="800000"/>
-        </a:ln>
-        <a:effectLst/>
-      </dsp:spPr>
-      <dsp:style>
-        <a:lnRef idx="2">
-          <a:scrgbClr r="0" g="0" b="0"/>
-        </a:lnRef>
-        <a:fillRef idx="1">
-          <a:scrgbClr r="0" g="0" b="0"/>
-        </a:fillRef>
-        <a:effectRef idx="0">
-          <a:scrgbClr r="0" g="0" b="0"/>
-        </a:effectRef>
-        <a:fontRef idx="minor"/>
-      </dsp:style>
-      <dsp:txBody>
-        <a:bodyPr spcFirstLastPara="0" vert="horz" wrap="square" lIns="248920" tIns="22225" rIns="22225" bIns="22225" numCol="1" spcCol="1270" anchor="ctr" anchorCtr="0">
-          <a:noAutofit/>
-        </a:bodyPr>
-        <a:lstStyle/>
-        <a:p>
-          <a:pPr marL="285750" lvl="1" indent="-285750" algn="l" defTabSz="1555750">
-            <a:lnSpc>
-              <a:spcPct val="90000"/>
-            </a:lnSpc>
-            <a:spcBef>
-              <a:spcPct val="0"/>
-            </a:spcBef>
-            <a:spcAft>
-              <a:spcPct val="15000"/>
-            </a:spcAft>
-            <a:buChar char="•"/>
-          </a:pPr>
-          <a:endParaRPr lang="de-AT" sz="3500" kern="1200"/>
-        </a:p>
-        <a:p>
-          <a:pPr marL="285750" lvl="1" indent="-285750" algn="l" defTabSz="1555750">
-            <a:lnSpc>
-              <a:spcPct val="90000"/>
-            </a:lnSpc>
-            <a:spcBef>
-              <a:spcPct val="0"/>
-            </a:spcBef>
-            <a:spcAft>
-              <a:spcPct val="15000"/>
-            </a:spcAft>
-            <a:buChar char="•"/>
-          </a:pPr>
-          <a:endParaRPr lang="de-AT" sz="3500" kern="1200"/>
-        </a:p>
-      </dsp:txBody>
-      <dsp:txXfrm rot="-5400000">
-        <a:off x="1352020" y="3545408"/>
-        <a:ext cx="6714693" cy="1132875"/>
-      </dsp:txXfrm>
-    </dsp:sp>
-  </dsp:spTree>
-</dsp:drawing>
-</file>
-
-<file path=ppt/diagrams/layout1.xml><?xml version="1.0" encoding="utf-8"?>
-<dgm:layoutDef xmlns:dgm="http://schemas.openxmlformats.org/drawingml/2006/diagram" xmlns:a="http://schemas.openxmlformats.org/drawingml/2006/main" uniqueId="urn:microsoft.com/office/officeart/2005/8/layout/chevron2">
-  <dgm:title val=""/>
-  <dgm:desc val=""/>
-  <dgm:catLst>
-    <dgm:cat type="process" pri="12000"/>
-    <dgm:cat type="list" pri="16000"/>
-    <dgm:cat type="convert" pri="11000"/>
-  </dgm:catLst>
-  <dgm:sampData>
-    <dgm:dataModel>
-      <dgm:ptLst>
-        <dgm:pt modelId="0" type="doc"/>
-        <dgm:pt modelId="1">
-          <dgm:prSet phldr="1"/>
-        </dgm:pt>
-        <dgm:pt modelId="11">
-          <dgm:prSet phldr="1"/>
-        </dgm:pt>
-        <dgm:pt modelId="12">
-          <dgm:prSet phldr="1"/>
-        </dgm:pt>
-        <dgm:pt modelId="2">
-          <dgm:prSet phldr="1"/>
-        </dgm:pt>
-        <dgm:pt modelId="21">
-          <dgm:prSet phldr="1"/>
-        </dgm:pt>
-        <dgm:pt modelId="22">
-          <dgm:prSet phldr="1"/>
-        </dgm:pt>
-        <dgm:pt modelId="3">
-          <dgm:prSet phldr="1"/>
-        </dgm:pt>
-        <dgm:pt modelId="31">
-          <dgm:prSet phldr="1"/>
-        </dgm:pt>
-        <dgm:pt modelId="32">
-          <dgm:prSet phldr="1"/>
-        </dgm:pt>
-      </dgm:ptLst>
-      <dgm:cxnLst>
-        <dgm:cxn modelId="4" srcId="0" destId="1" srcOrd="0" destOrd="0"/>
-        <dgm:cxn modelId="5" srcId="0" destId="2" srcOrd="1" destOrd="0"/>
-        <dgm:cxn modelId="6" srcId="0" destId="3" srcOrd="2" destOrd="0"/>
-        <dgm:cxn modelId="13" srcId="1" destId="11" srcOrd="0" destOrd="0"/>
-        <dgm:cxn modelId="14" srcId="1" destId="12" srcOrd="1" destOrd="0"/>
-        <dgm:cxn modelId="23" srcId="2" destId="21" srcOrd="0" destOrd="0"/>
-        <dgm:cxn modelId="24" srcId="2" destId="22" srcOrd="1" destOrd="0"/>
-        <dgm:cxn modelId="33" srcId="3" destId="31" srcOrd="0" destOrd="0"/>
-        <dgm:cxn modelId="34" srcId="3" destId="32" srcOrd="1" destOrd="0"/>
-      </dgm:cxnLst>
-      <dgm:bg/>
-      <dgm:whole/>
-    </dgm:dataModel>
-  </dgm:sampData>
-  <dgm:styleData>
-    <dgm:dataModel>
-      <dgm:ptLst>
-        <dgm:pt modelId="0" type="doc"/>
-        <dgm:pt modelId="1"/>
-      </dgm:ptLst>
-      <dgm:cxnLst>
-        <dgm:cxn modelId="4" srcId="0" destId="1" srcOrd="0" destOrd="0"/>
-      </dgm:cxnLst>
-      <dgm:bg/>
-      <dgm:whole/>
-    </dgm:dataModel>
-  </dgm:styleData>
-  <dgm:clrData>
-    <dgm:dataModel>
-      <dgm:ptLst>
-        <dgm:pt modelId="0" type="doc"/>
-        <dgm:pt modelId="1"/>
-        <dgm:pt modelId="11"/>
-        <dgm:pt modelId="2"/>
-        <dgm:pt modelId="21"/>
-        <dgm:pt modelId="3"/>
-        <dgm:pt modelId="31"/>
-        <dgm:pt modelId="4"/>
-        <dgm:pt modelId="41"/>
-      </dgm:ptLst>
-      <dgm:cxnLst>
-        <dgm:cxn modelId="5" srcId="0" destId="1" srcOrd="0" destOrd="0"/>
-        <dgm:cxn modelId="6" srcId="0" destId="2" srcOrd="1" destOrd="0"/>
-        <dgm:cxn modelId="7" srcId="0" destId="3" srcOrd="2" destOrd="0"/>
-        <dgm:cxn modelId="8" srcId="0" destId="4" srcOrd="3" destOrd="0"/>
-        <dgm:cxn modelId="13" srcId="1" destId="11" srcOrd="0" destOrd="0"/>
-        <dgm:cxn modelId="23" srcId="2" destId="21" srcOrd="0" destOrd="0"/>
-        <dgm:cxn modelId="33" srcId="3" destId="31" srcOrd="0" destOrd="0"/>
-        <dgm:cxn modelId="43" srcId="4" destId="41" srcOrd="0" destOrd="0"/>
-      </dgm:cxnLst>
-      <dgm:bg/>
-      <dgm:whole/>
-    </dgm:dataModel>
-  </dgm:clrData>
-  <dgm:layoutNode name="linearFlow">
-    <dgm:varLst>
-      <dgm:dir/>
-      <dgm:animLvl val="lvl"/>
-      <dgm:resizeHandles val="exact"/>
-    </dgm:varLst>
-    <dgm:alg type="lin">
-      <dgm:param type="linDir" val="fromT"/>
-      <dgm:param type="nodeHorzAlign" val="l"/>
-    </dgm:alg>
-    <dgm:shape xmlns:r="http://schemas.openxmlformats.org/officeDocument/2006/relationships" r:blip="">
-      <dgm:adjLst/>
-    </dgm:shape>
-    <dgm:presOf/>
-    <dgm:constrLst>
-      <dgm:constr type="h" for="ch" forName="composite" refType="h"/>
-      <dgm:constr type="w" for="ch" forName="composite" refType="w"/>
-      <dgm:constr type="h" for="des" forName="parentText" op="equ"/>
-      <dgm:constr type="h" for="ch" forName="sp" val="-14.88"/>
-      <dgm:constr type="h" for="ch" forName="sp" refType="w" refFor="des" refForName="parentText" op="gte" fact="-0.3"/>
-      <dgm:constr type="primFontSz" for="des" forName="parentText" op="equ" val="65"/>
-      <dgm:constr type="primFontSz" for="des" forName="descendantText" op="equ" val="65"/>
-    </dgm:constrLst>
-    <dgm:ruleLst/>
-    <dgm:forEach name="Name0" axis="ch" ptType="node">
-      <dgm:layoutNode name="composite">
-        <dgm:alg type="composite"/>
-        <dgm:shape xmlns:r="http://schemas.openxmlformats.org/officeDocument/2006/relationships" r:blip="">
-          <dgm:adjLst/>
-        </dgm:shape>
-        <dgm:presOf/>
-        <dgm:choose name="Name1">
-          <dgm:if name="Name2" func="var" arg="dir" op="equ" val="norm">
-            <dgm:constrLst>
-              <dgm:constr type="t" for="ch" forName="parentText"/>
-              <dgm:constr type="l" for="ch" forName="parentText"/>
-              <dgm:constr type="w" for="ch" forName="parentText" refType="w" fact="0.4"/>
-              <dgm:constr type="h" for="ch" forName="parentText" refType="h"/>
-              <dgm:constr type="w" for="ch" forName="parentText" refType="w" op="lte" fact="0.5"/>
-              <dgm:constr type="w" for="ch" forName="parentText" refType="h" refFor="ch" refForName="parentText" op="lte" fact="0.7"/>
-              <dgm:constr type="h" for="ch" forName="parentText" refType="w" refFor="ch" refForName="parentText" op="lte" fact="3"/>
-              <dgm:constr type="l" for="ch" forName="descendantText" refType="w" refFor="ch" refForName="parentText"/>
-              <dgm:constr type="w" for="ch" forName="descendantText" refType="w"/>
-              <dgm:constr type="wOff" for="ch" forName="descendantText" refType="w" refFor="ch" refForName="parentText" fact="-1"/>
-              <dgm:constr type="t" for="ch" forName="descendantText"/>
-              <dgm:constr type="b" for="ch" forName="descendantText" refType="h" refFor="ch" refForName="parentText"/>
-              <dgm:constr type="bOff" for="ch" forName="descendantText" refType="w" refFor="ch" refForName="parentText" fact="-0.5"/>
-            </dgm:constrLst>
-          </dgm:if>
-          <dgm:else name="Name3">
-            <dgm:constrLst>
-              <dgm:constr type="t" for="ch" forName="parentText"/>
-              <dgm:constr type="r" for="ch" forName="parentText" refType="w"/>
-              <dgm:constr type="w" for="ch" forName="parentText" refType="w" fact="0.4"/>
-              <dgm:constr type="h" for="ch" forName="parentText" refType="h"/>
-              <dgm:constr type="w" for="ch" forName="parentText" refType="w" op="lte" fact="0.5"/>
-              <dgm:constr type="w" for="ch" forName="parentText" refType="h" refFor="ch" refForName="parentText" op="lte" fact="0.7"/>
-              <dgm:constr type="h" for="ch" forName="parentText" refType="w" refFor="ch" refForName="parentText" op="lte" fact="3"/>
-              <dgm:constr type="l" for="ch" forName="descendantText"/>
-              <dgm:constr type="w" for="ch" forName="descendantText" refType="w"/>
-              <dgm:constr type="wOff" for="ch" forName="descendantText" refType="w" refFor="ch" refForName="parentText" fact="-1"/>
-              <dgm:constr type="t" for="ch" forName="descendantText"/>
-              <dgm:constr type="b" for="ch" forName="descendantText" refType="h" refFor="ch" refForName="parentText"/>
-              <dgm:constr type="bOff" for="ch" forName="descendantText" refType="w" refFor="ch" refForName="parentText" fact="-0.5"/>
-            </dgm:constrLst>
-          </dgm:else>
-        </dgm:choose>
-        <dgm:ruleLst/>
-        <dgm:layoutNode name="parentText" styleLbl="alignNode1">
-          <dgm:varLst>
-            <dgm:chMax val="1"/>
-            <dgm:bulletEnabled val="1"/>
-          </dgm:varLst>
-          <dgm:alg type="tx"/>
-          <dgm:shape xmlns:r="http://schemas.openxmlformats.org/officeDocument/2006/relationships" rot="90" type="chevron" r:blip="">
-            <dgm:adjLst/>
-          </dgm:shape>
-          <dgm:presOf axis="self" ptType="node"/>
-          <dgm:constrLst>
-            <dgm:constr type="lMarg" refType="primFontSz" fact="0.05"/>
-            <dgm:constr type="rMarg" refType="primFontSz" fact="0.05"/>
-            <dgm:constr type="tMarg" refType="primFontSz" fact="0.05"/>
-            <dgm:constr type="bMarg" refType="primFontSz" fact="0.05"/>
-          </dgm:constrLst>
-          <dgm:ruleLst>
-            <dgm:rule type="h" val="100" fact="NaN" max="NaN"/>
-            <dgm:rule type="primFontSz" val="24" fact="NaN" max="NaN"/>
-            <dgm:rule type="h" val="110" fact="NaN" max="NaN"/>
-            <dgm:rule type="primFontSz" val="18" fact="NaN" max="NaN"/>
-            <dgm:rule type="h" val="INF" fact="NaN" max="NaN"/>
-            <dgm:rule type="primFontSz" val="5" fact="NaN" max="NaN"/>
-          </dgm:ruleLst>
-        </dgm:layoutNode>
-        <dgm:layoutNode name="descendantText" styleLbl="alignAcc1">
-          <dgm:varLst>
-            <dgm:bulletEnabled val="1"/>
-          </dgm:varLst>
-          <dgm:choose name="Name4">
-            <dgm:if name="Name5" func="var" arg="dir" op="equ" val="norm">
-              <dgm:alg type="tx">
-                <dgm:param type="stBulletLvl" val="1"/>
-                <dgm:param type="txAnchorVertCh" val="mid"/>
-              </dgm:alg>
-              <dgm:shape xmlns:r="http://schemas.openxmlformats.org/officeDocument/2006/relationships" rot="90" type="round2SameRect" r:blip="">
-                <dgm:adjLst/>
-              </dgm:shape>
-            </dgm:if>
-            <dgm:else name="Name6">
-              <dgm:alg type="tx">
-                <dgm:param type="stBulletLvl" val="1"/>
-                <dgm:param type="txAnchorVertCh" val="mid"/>
-              </dgm:alg>
-              <dgm:shape xmlns:r="http://schemas.openxmlformats.org/officeDocument/2006/relationships" rot="-90" type="round2SameRect" r:blip="">
-                <dgm:adjLst/>
-              </dgm:shape>
-            </dgm:else>
-          </dgm:choose>
-          <dgm:presOf axis="des" ptType="node"/>
-          <dgm:choose name="Name7">
-            <dgm:if name="Name8" func="var" arg="dir" op="equ" val="norm">
-              <dgm:constrLst>
-                <dgm:constr type="secFontSz" refType="primFontSz"/>
-                <dgm:constr type="tMarg" refType="primFontSz" fact="0.05"/>
-                <dgm:constr type="bMarg" refType="primFontSz" fact="0.05"/>
-                <dgm:constr type="rMarg" refType="primFontSz" fact="0.05"/>
-              </dgm:constrLst>
-            </dgm:if>
-            <dgm:else name="Name9">
-              <dgm:constrLst>
-                <dgm:constr type="secFontSz" refType="primFontSz"/>
-                <dgm:constr type="tMarg" refType="primFontSz" fact="0.05"/>
-                <dgm:constr type="bMarg" refType="primFontSz" fact="0.05"/>
-                <dgm:constr type="lMarg" refType="primFontSz" fact="0.05"/>
-              </dgm:constrLst>
-            </dgm:else>
-          </dgm:choose>
-          <dgm:ruleLst>
-            <dgm:rule type="primFontSz" val="5" fact="NaN" max="NaN"/>
-          </dgm:ruleLst>
-        </dgm:layoutNode>
-      </dgm:layoutNode>
-      <dgm:forEach name="Name10" axis="followSib" ptType="sibTrans" cnt="1">
-        <dgm:layoutNode name="sp">
-          <dgm:alg type="sp"/>
-          <dgm:shape xmlns:r="http://schemas.openxmlformats.org/officeDocument/2006/relationships" r:blip="">
-            <dgm:adjLst/>
-          </dgm:shape>
-          <dgm:presOf axis="self"/>
-          <dgm:constrLst>
-            <dgm:constr type="w" val="1"/>
-            <dgm:constr type="h" val="37.5"/>
-          </dgm:constrLst>
-          <dgm:ruleLst/>
-        </dgm:layoutNode>
-      </dgm:forEach>
-    </dgm:forEach>
-  </dgm:layoutNode>
-</dgm:layoutDef>
-</file>
-
-<file path=ppt/diagrams/quickStyle1.xml><?xml version="1.0" encoding="utf-8"?>
-<dgm:styleDef xmlns:dgm="http://schemas.openxmlformats.org/drawingml/2006/diagram" xmlns:a="http://schemas.openxmlformats.org/drawingml/2006/main" uniqueId="urn:microsoft.com/office/officeart/2005/8/quickstyle/simple1">
-  <dgm:title val=""/>
-  <dgm:desc val=""/>
-  <dgm:catLst>
-    <dgm:cat type="simple" pri="10100"/>
-  </dgm:catLst>
-  <dgm:scene3d>
-    <a:camera prst="orthographicFront"/>
-    <a:lightRig rig="threePt" dir="t"/>
-  </dgm:scene3d>
-  <dgm:styleLbl name="node0">
-    <dgm:scene3d>
-      <a:camera prst="orthographicFront"/>
-      <a:lightRig rig="threePt" dir="t"/>
-    </dgm:scene3d>
-    <dgm:sp3d/>
-    <dgm:txPr/>
-    <dgm:style>
-      <a:lnRef idx="2">
-        <a:scrgbClr r="0" g="0" b="0"/>
-      </a:lnRef>
-      <a:fillRef idx="1">
-        <a:scrgbClr r="0" g="0" b="0"/>
-      </a:fillRef>
-      <a:effectRef idx="0">
-        <a:scrgbClr r="0" g="0" b="0"/>
-      </a:effectRef>
-      <a:fontRef idx="minor">
-        <a:schemeClr val="lt1"/>
-      </a:fontRef>
-    </dgm:style>
-  </dgm:styleLbl>
-  <dgm:styleLbl name="lnNode1">
-    <dgm:scene3d>
-      <a:camera prst="orthographicFront"/>
-      <a:lightRig rig="threePt" dir="t"/>
-    </dgm:scene3d>
-    <dgm:sp3d/>
-    <dgm:txPr/>
-    <dgm:style>
-      <a:lnRef idx="2">
-        <a:scrgbClr r="0" g="0" b="0"/>
-      </a:lnRef>
-      <a:fillRef idx="1">
-        <a:scrgbClr r="0" g="0" b="0"/>
-      </a:fillRef>
-      <a:effectRef idx="0">
-        <a:scrgbClr r="0" g="0" b="0"/>
-      </a:effectRef>
-      <a:fontRef idx="minor">
-        <a:schemeClr val="lt1"/>
-      </a:fontRef>
-    </dgm:style>
-  </dgm:styleLbl>
-  <dgm:styleLbl name="vennNode1">
-    <dgm:scene3d>
-      <a:camera prst="orthographicFront"/>
-      <a:lightRig rig="threePt" dir="t"/>
-    </dgm:scene3d>
-    <dgm:sp3d/>
-    <dgm:txPr/>
-    <dgm:style>
-      <a:lnRef idx="2">
-        <a:scrgbClr r="0" g="0" b="0"/>
-      </a:lnRef>
-      <a:fillRef idx="1">
-        <a:scrgbClr r="0" g="0" b="0"/>
-      </a:fillRef>
-      <a:effectRef idx="0">
-        <a:scrgbClr r="0" g="0" b="0"/>
-      </a:effectRef>
-      <a:fontRef idx="minor">
-        <a:schemeClr val="tx1"/>
-      </a:fontRef>
-    </dgm:style>
-  </dgm:styleLbl>
-  <dgm:styleLbl name="alignNode1">
-    <dgm:scene3d>
-      <a:camera prst="orthographicFront"/>
-      <a:lightRig rig="threePt" dir="t"/>
-    </dgm:scene3d>
-    <dgm:sp3d/>
-    <dgm:txPr/>
-    <dgm:style>
-      <a:lnRef idx="2">
-        <a:scrgbClr r="0" g="0" b="0"/>
-      </a:lnRef>
-      <a:fillRef idx="1">
-        <a:scrgbClr r="0" g="0" b="0"/>
-      </a:fillRef>
-      <a:effectRef idx="0">
-        <a:scrgbClr r="0" g="0" b="0"/>
-      </a:effectRef>
-      <a:fontRef idx="minor">
-        <a:schemeClr val="lt1"/>
-      </a:fontRef>
-    </dgm:style>
-  </dgm:styleLbl>
-  <dgm:styleLbl name="node1">
-    <dgm:scene3d>
-      <a:camera prst="orthographicFront"/>
-      <a:lightRig rig="threePt" dir="t"/>
-    </dgm:scene3d>
-    <dgm:sp3d/>
-    <dgm:txPr/>
-    <dgm:style>
-      <a:lnRef idx="2">
-        <a:scrgbClr r="0" g="0" b="0"/>
-      </a:lnRef>
-      <a:fillRef idx="1">
-        <a:scrgbClr r="0" g="0" b="0"/>
-      </a:fillRef>
-      <a:effectRef idx="0">
-        <a:scrgbClr r="0" g="0" b="0"/>
-      </a:effectRef>
-      <a:fontRef idx="minor">
-        <a:schemeClr val="lt1"/>
-      </a:fontRef>
-    </dgm:style>
-  </dgm:styleLbl>
-  <dgm:styleLbl name="node2">
-    <dgm:scene3d>
-      <a:camera prst="orthographicFront"/>
-      <a:lightRig rig="threePt" dir="t"/>
-    </dgm:scene3d>
-    <dgm:sp3d/>
-    <dgm:txPr/>
-    <dgm:style>
-      <a:lnRef idx="2">
-        <a:scrgbClr r="0" g="0" b="0"/>
-      </a:lnRef>
-      <a:fillRef idx="1">
-        <a:scrgbClr r="0" g="0" b="0"/>
-      </a:fillRef>
-      <a:effectRef idx="0">
-        <a:scrgbClr r="0" g="0" b="0"/>
-      </a:effectRef>
-      <a:fontRef idx="minor">
-        <a:schemeClr val="lt1"/>
-      </a:fontRef>
-    </dgm:style>
-  </dgm:styleLbl>
-  <dgm:styleLbl name="node3">
-    <dgm:scene3d>
-      <a:camera prst="orthographicFront"/>
-      <a:lightRig rig="threePt" dir="t"/>
-    </dgm:scene3d>
-    <dgm:sp3d/>
-    <dgm:txPr/>
-    <dgm:style>
-      <a:lnRef idx="2">
-        <a:scrgbClr r="0" g="0" b="0"/>
-      </a:lnRef>
-      <a:fillRef idx="1">
-        <a:scrgbClr r="0" g="0" b="0"/>
-      </a:fillRef>
-      <a:effectRef idx="0">
-        <a:scrgbClr r="0" g="0" b="0"/>
-      </a:effectRef>
-      <a:fontRef idx="minor">
-        <a:schemeClr val="lt1"/>
-      </a:fontRef>
-    </dgm:style>
-  </dgm:styleLbl>
-  <dgm:styleLbl name="node4">
-    <dgm:scene3d>
-      <a:camera prst="orthographicFront"/>
-      <a:lightRig rig="threePt" dir="t"/>
-    </dgm:scene3d>
-    <dgm:sp3d/>
-    <dgm:txPr/>
-    <dgm:style>
-      <a:lnRef idx="2">
-        <a:scrgbClr r="0" g="0" b="0"/>
-      </a:lnRef>
-      <a:fillRef idx="1">
-        <a:scrgbClr r="0" g="0" b="0"/>
-      </a:fillRef>
-      <a:effectRef idx="0">
-        <a:scrgbClr r="0" g="0" b="0"/>
-      </a:effectRef>
-      <a:fontRef idx="minor">
-        <a:schemeClr val="lt1"/>
-      </a:fontRef>
-    </dgm:style>
-  </dgm:styleLbl>
-  <dgm:styleLbl name="fgImgPlace1">
-    <dgm:scene3d>
-      <a:camera prst="orthographicFront"/>
-      <a:lightRig rig="threePt" dir="t"/>
-    </dgm:scene3d>
-    <dgm:sp3d/>
-    <dgm:txPr/>
-    <dgm:style>
-      <a:lnRef idx="2">
-        <a:scrgbClr r="0" g="0" b="0"/>
-      </a:lnRef>
-      <a:fillRef idx="1">
-        <a:scrgbClr r="0" g="0" b="0"/>
-      </a:fillRef>
-      <a:effectRef idx="0">
-        <a:scrgbClr r="0" g="0" b="0"/>
-      </a:effectRef>
-      <a:fontRef idx="minor"/>
-    </dgm:style>
-  </dgm:styleLbl>
-  <dgm:styleLbl name="alignImgPlace1">
-    <dgm:scene3d>
-      <a:camera prst="orthographicFront"/>
-      <a:lightRig rig="threePt" dir="t"/>
-    </dgm:scene3d>
-    <dgm:sp3d/>
-    <dgm:txPr/>
-    <dgm:style>
-      <a:lnRef idx="2">
-        <a:scrgbClr r="0" g="0" b="0"/>
-      </a:lnRef>
-      <a:fillRef idx="1">
-        <a:scrgbClr r="0" g="0" b="0"/>
-      </a:fillRef>
-      <a:effectRef idx="0">
-        <a:scrgbClr r="0" g="0" b="0"/>
-      </a:effectRef>
-      <a:fontRef idx="minor"/>
-    </dgm:style>
-  </dgm:styleLbl>
-  <dgm:styleLbl name="bgImgPlace1">
-    <dgm:scene3d>
-      <a:camera prst="orthographicFront"/>
-      <a:lightRig rig="threePt" dir="t"/>
-    </dgm:scene3d>
-    <dgm:sp3d/>
-    <dgm:txPr/>
-    <dgm:style>
-      <a:lnRef idx="2">
-        <a:scrgbClr r="0" g="0" b="0"/>
-      </a:lnRef>
-      <a:fillRef idx="1">
-        <a:scrgbClr r="0" g="0" b="0"/>
-      </a:fillRef>
-      <a:effectRef idx="0">
-        <a:scrgbClr r="0" g="0" b="0"/>
-      </a:effectRef>
-      <a:fontRef idx="minor"/>
-    </dgm:style>
-  </dgm:styleLbl>
-  <dgm:styleLbl name="sibTrans2D1">
-    <dgm:scene3d>
-      <a:camera prst="orthographicFront"/>
-      <a:lightRig rig="threePt" dir="t"/>
-    </dgm:scene3d>
-    <dgm:sp3d/>
-    <dgm:txPr/>
-    <dgm:style>
-      <a:lnRef idx="0">
-        <a:scrgbClr r="0" g="0" b="0"/>
-      </a:lnRef>
-      <a:fillRef idx="1">
-        <a:scrgbClr r="0" g="0" b="0"/>
-      </a:fillRef>
-      <a:effectRef idx="0">
-        <a:scrgbClr r="0" g="0" b="0"/>
-      </a:effectRef>
-      <a:fontRef idx="minor">
-        <a:schemeClr val="lt1"/>
-      </a:fontRef>
-    </dgm:style>
-  </dgm:styleLbl>
-  <dgm:styleLbl name="fgSibTrans2D1">
-    <dgm:scene3d>
-      <a:camera prst="orthographicFront"/>
-      <a:lightRig rig="threePt" dir="t"/>
-    </dgm:scene3d>
-    <dgm:sp3d/>
-    <dgm:txPr/>
-    <dgm:style>
-      <a:lnRef idx="0">
-        <a:scrgbClr r="0" g="0" b="0"/>
-      </a:lnRef>
-      <a:fillRef idx="1">
-        <a:scrgbClr r="0" g="0" b="0"/>
-      </a:fillRef>
-      <a:effectRef idx="0">
-        <a:scrgbClr r="0" g="0" b="0"/>
-      </a:effectRef>
-      <a:fontRef idx="minor">
-        <a:schemeClr val="lt1"/>
-      </a:fontRef>
-    </dgm:style>
-  </dgm:styleLbl>
-  <dgm:styleLbl name="bgSibTrans2D1">
-    <dgm:scene3d>
-      <a:camera prst="orthographicFront"/>
-      <a:lightRig rig="threePt" dir="t"/>
-    </dgm:scene3d>
-    <dgm:sp3d/>
-    <dgm:txPr/>
-    <dgm:style>
-      <a:lnRef idx="0">
-        <a:scrgbClr r="0" g="0" b="0"/>
-      </a:lnRef>
-      <a:fillRef idx="1">
-        <a:scrgbClr r="0" g="0" b="0"/>
-      </a:fillRef>
-      <a:effectRef idx="0">
-        <a:scrgbClr r="0" g="0" b="0"/>
-      </a:effectRef>
-      <a:fontRef idx="minor">
-        <a:schemeClr val="lt1"/>
-      </a:fontRef>
-    </dgm:style>
-  </dgm:styleLbl>
-  <dgm:styleLbl name="sibTrans1D1">
-    <dgm:scene3d>
-      <a:camera prst="orthographicFront"/>
-      <a:lightRig rig="threePt" dir="t"/>
-    </dgm:scene3d>
-    <dgm:sp3d/>
-    <dgm:txPr/>
-    <dgm:style>
-      <a:lnRef idx="1">
-        <a:scrgbClr r="0" g="0" b="0"/>
-      </a:lnRef>
-      <a:fillRef idx="0">
-        <a:scrgbClr r="0" g="0" b="0"/>
-      </a:fillRef>
-      <a:effectRef idx="0">
-        <a:scrgbClr r="0" g="0" b="0"/>
-      </a:effectRef>
-      <a:fontRef idx="minor"/>
-    </dgm:style>
-  </dgm:styleLbl>
-  <dgm:styleLbl name="callout">
-    <dgm:scene3d>
-      <a:camera prst="orthographicFront"/>
-      <a:lightRig rig="threePt" dir="t"/>
-    </dgm:scene3d>
-    <dgm:sp3d/>
-    <dgm:txPr/>
-    <dgm:style>
-      <a:lnRef idx="2">
-        <a:scrgbClr r="0" g="0" b="0"/>
-      </a:lnRef>
-      <a:fillRef idx="1">
-        <a:scrgbClr r="0" g="0" b="0"/>
-      </a:fillRef>
-      <a:effectRef idx="0">
-        <a:scrgbClr r="0" g="0" b="0"/>
-      </a:effectRef>
-      <a:fontRef idx="minor"/>
-    </dgm:style>
-  </dgm:styleLbl>
-  <dgm:styleLbl name="asst0">
-    <dgm:scene3d>
-      <a:camera prst="orthographicFront"/>
-      <a:lightRig rig="threePt" dir="t"/>
-    </dgm:scene3d>
-    <dgm:sp3d/>
-    <dgm:txPr/>
-    <dgm:style>
-      <a:lnRef idx="2">
-        <a:scrgbClr r="0" g="0" b="0"/>
-      </a:lnRef>
-      <a:fillRef idx="1">
-        <a:scrgbClr r="0" g="0" b="0"/>
-      </a:fillRef>
-      <a:effectRef idx="0">
-        <a:scrgbClr r="0" g="0" b="0"/>
-      </a:effectRef>
-      <a:fontRef idx="minor">
-        <a:schemeClr val="lt1"/>
-      </a:fontRef>
-    </dgm:style>
-  </dgm:styleLbl>
-  <dgm:styleLbl name="asst1">
-    <dgm:scene3d>
-      <a:camera prst="orthographicFront"/>
-      <a:lightRig rig="threePt" dir="t"/>
-    </dgm:scene3d>
-    <dgm:sp3d/>
-    <dgm:txPr/>
-    <dgm:style>
-      <a:lnRef idx="2">
-        <a:scrgbClr r="0" g="0" b="0"/>
-      </a:lnRef>
-      <a:fillRef idx="1">
-        <a:scrgbClr r="0" g="0" b="0"/>
-      </a:fillRef>
-      <a:effectRef idx="0">
-        <a:scrgbClr r="0" g="0" b="0"/>
-      </a:effectRef>
-      <a:fontRef idx="minor">
-        <a:schemeClr val="lt1"/>
-      </a:fontRef>
-    </dgm:style>
-  </dgm:styleLbl>
-  <dgm:styleLbl name="asst2">
-    <dgm:scene3d>
-      <a:camera prst="orthographicFront"/>
-      <a:lightRig rig="threePt" dir="t"/>
-    </dgm:scene3d>
-    <dgm:sp3d/>
-    <dgm:txPr/>
-    <dgm:style>
-      <a:lnRef idx="2">
-        <a:scrgbClr r="0" g="0" b="0"/>
-      </a:lnRef>
-      <a:fillRef idx="1">
-        <a:scrgbClr r="0" g="0" b="0"/>
-      </a:fillRef>
-      <a:effectRef idx="0">
-        <a:scrgbClr r="0" g="0" b="0"/>
-      </a:effectRef>
-      <a:fontRef idx="minor">
-        <a:schemeClr val="lt1"/>
-      </a:fontRef>
-    </dgm:style>
-  </dgm:styleLbl>
-  <dgm:styleLbl name="asst3">
-    <dgm:scene3d>
-      <a:camera prst="orthographicFront"/>
-      <a:lightRig rig="threePt" dir="t"/>
-    </dgm:scene3d>
-    <dgm:sp3d/>
-    <dgm:txPr/>
-    <dgm:style>
-      <a:lnRef idx="2">
-        <a:scrgbClr r="0" g="0" b="0"/>
-      </a:lnRef>
-      <a:fillRef idx="1">
-        <a:scrgbClr r="0" g="0" b="0"/>
-      </a:fillRef>
-      <a:effectRef idx="0">
-        <a:scrgbClr r="0" g="0" b="0"/>
-      </a:effectRef>
-      <a:fontRef idx="minor">
-        <a:schemeClr val="lt1"/>
-      </a:fontRef>
-    </dgm:style>
-  </dgm:styleLbl>
-  <dgm:styleLbl name="asst4">
-    <dgm:scene3d>
-      <a:camera prst="orthographicFront"/>
-      <a:lightRig rig="threePt" dir="t"/>
-    </dgm:scene3d>
-    <dgm:sp3d/>
-    <dgm:txPr/>
-    <dgm:style>
-      <a:lnRef idx="2">
-        <a:scrgbClr r="0" g="0" b="0"/>
-      </a:lnRef>
-      <a:fillRef idx="1">
-        <a:scrgbClr r="0" g="0" b="0"/>
-      </a:fillRef>
-      <a:effectRef idx="0">
-        <a:scrgbClr r="0" g="0" b="0"/>
-      </a:effectRef>
-      <a:fontRef idx="minor">
-        <a:schemeClr val="lt1"/>
-      </a:fontRef>
-    </dgm:style>
-  </dgm:styleLbl>
-  <dgm:styleLbl name="parChTrans2D1">
-    <dgm:scene3d>
-      <a:camera prst="orthographicFront"/>
-      <a:lightRig rig="threePt" dir="t"/>
-    </dgm:scene3d>
-    <dgm:sp3d/>
-    <dgm:txPr/>
-    <dgm:style>
-      <a:lnRef idx="2">
-        <a:scrgbClr r="0" g="0" b="0"/>
-      </a:lnRef>
-      <a:fillRef idx="1">
-        <a:scrgbClr r="0" g="0" b="0"/>
-      </a:fillRef>
-      <a:effectRef idx="0">
-        <a:scrgbClr r="0" g="0" b="0"/>
-      </a:effectRef>
-      <a:fontRef idx="minor">
-        <a:schemeClr val="lt1"/>
-      </a:fontRef>
-    </dgm:style>
-  </dgm:styleLbl>
-  <dgm:styleLbl name="parChTrans2D2">
-    <dgm:scene3d>
-      <a:camera prst="orthographicFront"/>
-      <a:lightRig rig="threePt" dir="t"/>
-    </dgm:scene3d>
-    <dgm:sp3d/>
-    <dgm:txPr/>
-    <dgm:style>
-      <a:lnRef idx="2">
-        <a:scrgbClr r="0" g="0" b="0"/>
-      </a:lnRef>
-      <a:fillRef idx="1">
-        <a:scrgbClr r="0" g="0" b="0"/>
-      </a:fillRef>
-      <a:effectRef idx="0">
-        <a:scrgbClr r="0" g="0" b="0"/>
-      </a:effectRef>
-      <a:fontRef idx="minor">
-        <a:schemeClr val="lt1"/>
-      </a:fontRef>
-    </dgm:style>
-  </dgm:styleLbl>
-  <dgm:styleLbl name="parChTrans2D3">
-    <dgm:scene3d>
-      <a:camera prst="orthographicFront"/>
-      <a:lightRig rig="threePt" dir="t"/>
-    </dgm:scene3d>
-    <dgm:sp3d/>
-    <dgm:txPr/>
-    <dgm:style>
-      <a:lnRef idx="2">
-        <a:scrgbClr r="0" g="0" b="0"/>
-      </a:lnRef>
-      <a:fillRef idx="1">
-        <a:scrgbClr r="0" g="0" b="0"/>
-      </a:fillRef>
-      <a:effectRef idx="0">
-        <a:scrgbClr r="0" g="0" b="0"/>
-      </a:effectRef>
-      <a:fontRef idx="minor">
-        <a:schemeClr val="lt1"/>
-      </a:fontRef>
-    </dgm:style>
-  </dgm:styleLbl>
-  <dgm:styleLbl name="parChTrans2D4">
-    <dgm:scene3d>
-      <a:camera prst="orthographicFront"/>
-      <a:lightRig rig="threePt" dir="t"/>
-    </dgm:scene3d>
-    <dgm:sp3d/>
-    <dgm:txPr/>
-    <dgm:style>
-      <a:lnRef idx="2">
-        <a:scrgbClr r="0" g="0" b="0"/>
-      </a:lnRef>
-      <a:fillRef idx="1">
-        <a:scrgbClr r="0" g="0" b="0"/>
-      </a:fillRef>
-      <a:effectRef idx="0">
-        <a:scrgbClr r="0" g="0" b="0"/>
-      </a:effectRef>
-      <a:fontRef idx="minor">
-        <a:schemeClr val="lt1"/>
-      </a:fontRef>
-    </dgm:style>
-  </dgm:styleLbl>
-  <dgm:styleLbl name="parChTrans1D1">
-    <dgm:scene3d>
-      <a:camera prst="orthographicFront"/>
-      <a:lightRig rig="threePt" dir="t"/>
-    </dgm:scene3d>
-    <dgm:sp3d/>
-    <dgm:txPr/>
-    <dgm:style>
-      <a:lnRef idx="2">
-        <a:scrgbClr r="0" g="0" b="0"/>
-      </a:lnRef>
-      <a:fillRef idx="0">
-        <a:scrgbClr r="0" g="0" b="0"/>
-      </a:fillRef>
-      <a:effectRef idx="0">
-        <a:scrgbClr r="0" g="0" b="0"/>
-      </a:effectRef>
-      <a:fontRef idx="minor"/>
-    </dgm:style>
-  </dgm:styleLbl>
-  <dgm:styleLbl name="parChTrans1D2">
-    <dgm:scene3d>
-      <a:camera prst="orthographicFront"/>
-      <a:lightRig rig="threePt" dir="t"/>
-    </dgm:scene3d>
-    <dgm:sp3d/>
-    <dgm:txPr/>
-    <dgm:style>
-      <a:lnRef idx="2">
-        <a:scrgbClr r="0" g="0" b="0"/>
-      </a:lnRef>
-      <a:fillRef idx="0">
-        <a:scrgbClr r="0" g="0" b="0"/>
-      </a:fillRef>
-      <a:effectRef idx="0">
-        <a:scrgbClr r="0" g="0" b="0"/>
-      </a:effectRef>
-      <a:fontRef idx="minor"/>
-    </dgm:style>
-  </dgm:styleLbl>
-  <dgm:styleLbl name="parChTrans1D3">
-    <dgm:scene3d>
-      <a:camera prst="orthographicFront"/>
-      <a:lightRig rig="threePt" dir="t"/>
-    </dgm:scene3d>
-    <dgm:sp3d/>
-    <dgm:txPr/>
-    <dgm:style>
-      <a:lnRef idx="2">
-        <a:scrgbClr r="0" g="0" b="0"/>
-      </a:lnRef>
-      <a:fillRef idx="0">
-        <a:scrgbClr r="0" g="0" b="0"/>
-      </a:fillRef>
-      <a:effectRef idx="0">
-        <a:scrgbClr r="0" g="0" b="0"/>
-      </a:effectRef>
-      <a:fontRef idx="minor"/>
-    </dgm:style>
-  </dgm:styleLbl>
-  <dgm:styleLbl name="parChTrans1D4">
-    <dgm:scene3d>
-      <a:camera prst="orthographicFront"/>
-      <a:lightRig rig="threePt" dir="t"/>
-    </dgm:scene3d>
-    <dgm:sp3d/>
-    <dgm:txPr/>
-    <dgm:style>
-      <a:lnRef idx="2">
-        <a:scrgbClr r="0" g="0" b="0"/>
-      </a:lnRef>
-      <a:fillRef idx="0">
-        <a:scrgbClr r="0" g="0" b="0"/>
-      </a:fillRef>
-      <a:effectRef idx="0">
-        <a:scrgbClr r="0" g="0" b="0"/>
-      </a:effectRef>
-      <a:fontRef idx="minor"/>
-    </dgm:style>
-  </dgm:styleLbl>
-  <dgm:styleLbl name="fgAcc1">
-    <dgm:scene3d>
-      <a:camera prst="orthographicFront"/>
-      <a:lightRig rig="threePt" dir="t"/>
-    </dgm:scene3d>
-    <dgm:sp3d/>
-    <dgm:txPr/>
-    <dgm:style>
-      <a:lnRef idx="2">
-        <a:scrgbClr r="0" g="0" b="0"/>
-      </a:lnRef>
-      <a:fillRef idx="1">
-        <a:scrgbClr r="0" g="0" b="0"/>
-      </a:fillRef>
-      <a:effectRef idx="0">
-        <a:scrgbClr r="0" g="0" b="0"/>
-      </a:effectRef>
-      <a:fontRef idx="minor"/>
-    </dgm:style>
-  </dgm:styleLbl>
-  <dgm:styleLbl name="conFgAcc1">
-    <dgm:scene3d>
-      <a:camera prst="orthographicFront"/>
-      <a:lightRig rig="threePt" dir="t"/>
-    </dgm:scene3d>
-    <dgm:sp3d/>
-    <dgm:txPr/>
-    <dgm:style>
-      <a:lnRef idx="2">
-        <a:scrgbClr r="0" g="0" b="0"/>
-      </a:lnRef>
-      <a:fillRef idx="1">
-        <a:scrgbClr r="0" g="0" b="0"/>
-      </a:fillRef>
-      <a:effectRef idx="0">
-        <a:scrgbClr r="0" g="0" b="0"/>
-      </a:effectRef>
-      <a:fontRef idx="minor"/>
-    </dgm:style>
-  </dgm:styleLbl>
-  <dgm:styleLbl name="alignAcc1">
-    <dgm:scene3d>
-      <a:camera prst="orthographicFront"/>
-      <a:lightRig rig="threePt" dir="t"/>
-    </dgm:scene3d>
-    <dgm:sp3d/>
-    <dgm:txPr/>
-    <dgm:style>
-      <a:lnRef idx="2">
-        <a:scrgbClr r="0" g="0" b="0"/>
-      </a:lnRef>
-      <a:fillRef idx="1">
-        <a:scrgbClr r="0" g="0" b="0"/>
-      </a:fillRef>
-      <a:effectRef idx="0">
-        <a:scrgbClr r="0" g="0" b="0"/>
-      </a:effectRef>
-      <a:fontRef idx="minor"/>
-    </dgm:style>
-  </dgm:styleLbl>
-  <dgm:styleLbl name="trAlignAcc1">
-    <dgm:scene3d>
-      <a:camera prst="orthographicFront"/>
-      <a:lightRig rig="threePt" dir="t"/>
-    </dgm:scene3d>
-    <dgm:sp3d/>
-    <dgm:txPr/>
-    <dgm:style>
-      <a:lnRef idx="1">
-        <a:scrgbClr r="0" g="0" b="0"/>
-      </a:lnRef>
-      <a:fillRef idx="1">
-        <a:scrgbClr r="0" g="0" b="0"/>
-      </a:fillRef>
-      <a:effectRef idx="0">
-        <a:scrgbClr r="0" g="0" b="0"/>
-      </a:effectRef>
-      <a:fontRef idx="minor"/>
-    </dgm:style>
-  </dgm:styleLbl>
-  <dgm:styleLbl name="bgAcc1">
-    <dgm:scene3d>
-      <a:camera prst="orthographicFront"/>
-      <a:lightRig rig="threePt" dir="t"/>
-    </dgm:scene3d>
-    <dgm:sp3d/>
-    <dgm:txPr/>
-    <dgm:style>
-      <a:lnRef idx="2">
-        <a:scrgbClr r="0" g="0" b="0"/>
-      </a:lnRef>
-      <a:fillRef idx="1">
-        <a:scrgbClr r="0" g="0" b="0"/>
-      </a:fillRef>
-      <a:effectRef idx="0">
-        <a:scrgbClr r="0" g="0" b="0"/>
-      </a:effectRef>
-      <a:fontRef idx="minor"/>
-    </dgm:style>
-  </dgm:styleLbl>
-  <dgm:styleLbl name="solidFgAcc1">
-    <dgm:scene3d>
-      <a:camera prst="orthographicFront"/>
-      <a:lightRig rig="threePt" dir="t"/>
-    </dgm:scene3d>
-    <dgm:sp3d/>
-    <dgm:txPr/>
-    <dgm:style>
-      <a:lnRef idx="2">
-        <a:scrgbClr r="0" g="0" b="0"/>
-      </a:lnRef>
-      <a:fillRef idx="1">
-        <a:scrgbClr r="0" g="0" b="0"/>
-      </a:fillRef>
-      <a:effectRef idx="0">
-        <a:scrgbClr r="0" g="0" b="0"/>
-      </a:effectRef>
-      <a:fontRef idx="minor"/>
-    </dgm:style>
-  </dgm:styleLbl>
-  <dgm:styleLbl name="solidAlignAcc1">
-    <dgm:scene3d>
-      <a:camera prst="orthographicFront"/>
-      <a:lightRig rig="threePt" dir="t"/>
-    </dgm:scene3d>
-    <dgm:sp3d/>
-    <dgm:txPr/>
-    <dgm:style>
-      <a:lnRef idx="2">
-        <a:scrgbClr r="0" g="0" b="0"/>
-      </a:lnRef>
-      <a:fillRef idx="1">
-        <a:scrgbClr r="0" g="0" b="0"/>
-      </a:fillRef>
-      <a:effectRef idx="0">
-        <a:scrgbClr r="0" g="0" b="0"/>
-      </a:effectRef>
-      <a:fontRef idx="minor"/>
-    </dgm:style>
-  </dgm:styleLbl>
-  <dgm:styleLbl name="solidBgAcc1">
-    <dgm:scene3d>
-      <a:camera prst="orthographicFront"/>
-      <a:lightRig rig="threePt" dir="t"/>
-    </dgm:scene3d>
-    <dgm:sp3d/>
-    <dgm:txPr/>
-    <dgm:style>
-      <a:lnRef idx="2">
-        <a:scrgbClr r="0" g="0" b="0"/>
-      </a:lnRef>
-      <a:fillRef idx="1">
-        <a:scrgbClr r="0" g="0" b="0"/>
-      </a:fillRef>
-      <a:effectRef idx="0">
-        <a:scrgbClr r="0" g="0" b="0"/>
-      </a:effectRef>
-      <a:fontRef idx="minor"/>
-    </dgm:style>
-  </dgm:styleLbl>
-  <dgm:styleLbl name="fgAccFollowNode1">
-    <dgm:scene3d>
-      <a:camera prst="orthographicFront"/>
-      <a:lightRig rig="threePt" dir="t"/>
-    </dgm:scene3d>
-    <dgm:sp3d/>
-    <dgm:txPr/>
-    <dgm:style>
-      <a:lnRef idx="2">
-        <a:scrgbClr r="0" g="0" b="0"/>
-      </a:lnRef>
-      <a:fillRef idx="1">
-        <a:scrgbClr r="0" g="0" b="0"/>
-      </a:fillRef>
-      <a:effectRef idx="0">
-        <a:scrgbClr r="0" g="0" b="0"/>
-      </a:effectRef>
-      <a:fontRef idx="minor"/>
-    </dgm:style>
-  </dgm:styleLbl>
-  <dgm:styleLbl name="alignAccFollowNode1">
-    <dgm:scene3d>
-      <a:camera prst="orthographicFront"/>
-      <a:lightRig rig="threePt" dir="t"/>
-    </dgm:scene3d>
-    <dgm:sp3d/>
-    <dgm:txPr/>
-    <dgm:style>
-      <a:lnRef idx="2">
-        <a:scrgbClr r="0" g="0" b="0"/>
-      </a:lnRef>
-      <a:fillRef idx="1">
-        <a:scrgbClr r="0" g="0" b="0"/>
-      </a:fillRef>
-      <a:effectRef idx="0">
-        <a:scrgbClr r="0" g="0" b="0"/>
-      </a:effectRef>
-      <a:fontRef idx="minor"/>
-    </dgm:style>
-  </dgm:styleLbl>
-  <dgm:styleLbl name="bgAccFollowNode1">
-    <dgm:scene3d>
-      <a:camera prst="orthographicFront"/>
-      <a:lightRig rig="threePt" dir="t"/>
-    </dgm:scene3d>
-    <dgm:sp3d/>
-    <dgm:txPr/>
-    <dgm:style>
-      <a:lnRef idx="2">
-        <a:scrgbClr r="0" g="0" b="0"/>
-      </a:lnRef>
-      <a:fillRef idx="1">
-        <a:scrgbClr r="0" g="0" b="0"/>
-      </a:fillRef>
-      <a:effectRef idx="0">
-        <a:scrgbClr r="0" g="0" b="0"/>
-      </a:effectRef>
-      <a:fontRef idx="minor"/>
-    </dgm:style>
-  </dgm:styleLbl>
-  <dgm:styleLbl name="fgAcc0">
-    <dgm:scene3d>
-      <a:camera prst="orthographicFront"/>
-      <a:lightRig rig="threePt" dir="t"/>
-    </dgm:scene3d>
-    <dgm:sp3d/>
-    <dgm:txPr/>
-    <dgm:style>
-      <a:lnRef idx="2">
-        <a:scrgbClr r="0" g="0" b="0"/>
-      </a:lnRef>
-      <a:fillRef idx="1">
-        <a:scrgbClr r="0" g="0" b="0"/>
-      </a:fillRef>
-      <a:effectRef idx="0">
-        <a:scrgbClr r="0" g="0" b="0"/>
-      </a:effectRef>
-      <a:fontRef idx="minor"/>
-    </dgm:style>
-  </dgm:styleLbl>
-  <dgm:styleLbl name="fgAcc2">
-    <dgm:scene3d>
-      <a:camera prst="orthographicFront"/>
-      <a:lightRig rig="threePt" dir="t"/>
-    </dgm:scene3d>
-    <dgm:sp3d/>
-    <dgm:txPr/>
-    <dgm:style>
-      <a:lnRef idx="2">
-        <a:scrgbClr r="0" g="0" b="0"/>
-      </a:lnRef>
-      <a:fillRef idx="1">
-        <a:scrgbClr r="0" g="0" b="0"/>
-      </a:fillRef>
-      <a:effectRef idx="0">
-        <a:scrgbClr r="0" g="0" b="0"/>
-      </a:effectRef>
-      <a:fontRef idx="minor"/>
-    </dgm:style>
-  </dgm:styleLbl>
-  <dgm:styleLbl name="fgAcc3">
-    <dgm:scene3d>
-      <a:camera prst="orthographicFront"/>
-      <a:lightRig rig="threePt" dir="t"/>
-    </dgm:scene3d>
-    <dgm:sp3d/>
-    <dgm:txPr/>
-    <dgm:style>
-      <a:lnRef idx="2">
-        <a:scrgbClr r="0" g="0" b="0"/>
-      </a:lnRef>
-      <a:fillRef idx="1">
-        <a:scrgbClr r="0" g="0" b="0"/>
-      </a:fillRef>
-      <a:effectRef idx="0">
-        <a:scrgbClr r="0" g="0" b="0"/>
-      </a:effectRef>
-      <a:fontRef idx="minor"/>
-    </dgm:style>
-  </dgm:styleLbl>
-  <dgm:styleLbl name="fgAcc4">
-    <dgm:scene3d>
-      <a:camera prst="orthographicFront"/>
-      <a:lightRig rig="threePt" dir="t"/>
-    </dgm:scene3d>
-    <dgm:sp3d/>
-    <dgm:txPr/>
-    <dgm:style>
-      <a:lnRef idx="2">
-        <a:scrgbClr r="0" g="0" b="0"/>
-      </a:lnRef>
-      <a:fillRef idx="1">
-        <a:scrgbClr r="0" g="0" b="0"/>
-      </a:fillRef>
-      <a:effectRef idx="0">
-        <a:scrgbClr r="0" g="0" b="0"/>
-      </a:effectRef>
-      <a:fontRef idx="minor"/>
-    </dgm:style>
-  </dgm:styleLbl>
-  <dgm:styleLbl name="bgShp">
-    <dgm:scene3d>
-      <a:camera prst="orthographicFront"/>
-      <a:lightRig rig="threePt" dir="t"/>
-    </dgm:scene3d>
-    <dgm:sp3d/>
-    <dgm:txPr/>
-    <dgm:style>
-      <a:lnRef idx="0">
-        <a:scrgbClr r="0" g="0" b="0"/>
-      </a:lnRef>
-      <a:fillRef idx="1">
-        <a:scrgbClr r="0" g="0" b="0"/>
-      </a:fillRef>
-      <a:effectRef idx="0">
-        <a:scrgbClr r="0" g="0" b="0"/>
-      </a:effectRef>
-      <a:fontRef idx="minor"/>
-    </dgm:style>
-  </dgm:styleLbl>
-  <dgm:styleLbl name="dkBgShp">
-    <dgm:scene3d>
-      <a:camera prst="orthographicFront"/>
-      <a:lightRig rig="threePt" dir="t"/>
-    </dgm:scene3d>
-    <dgm:sp3d/>
-    <dgm:txPr/>
-    <dgm:style>
-      <a:lnRef idx="0">
-        <a:scrgbClr r="0" g="0" b="0"/>
-      </a:lnRef>
-      <a:fillRef idx="1">
-        <a:scrgbClr r="0" g="0" b="0"/>
-      </a:fillRef>
-      <a:effectRef idx="0">
-        <a:scrgbClr r="0" g="0" b="0"/>
-      </a:effectRef>
-      <a:fontRef idx="minor"/>
-    </dgm:style>
-  </dgm:styleLbl>
-  <dgm:styleLbl name="trBgShp">
-    <dgm:scene3d>
-      <a:camera prst="orthographicFront"/>
-      <a:lightRig rig="threePt" dir="t"/>
-    </dgm:scene3d>
-    <dgm:sp3d/>
-    <dgm:txPr/>
-    <dgm:style>
-      <a:lnRef idx="0">
-        <a:scrgbClr r="0" g="0" b="0"/>
-      </a:lnRef>
-      <a:fillRef idx="1">
-        <a:scrgbClr r="0" g="0" b="0"/>
-      </a:fillRef>
-      <a:effectRef idx="0">
-        <a:scrgbClr r="0" g="0" b="0"/>
-      </a:effectRef>
-      <a:fontRef idx="minor"/>
-    </dgm:style>
-  </dgm:styleLbl>
-  <dgm:styleLbl name="fgShp">
-    <dgm:scene3d>
-      <a:camera prst="orthographicFront"/>
-      <a:lightRig rig="threePt" dir="t"/>
-    </dgm:scene3d>
-    <dgm:sp3d/>
-    <dgm:txPr/>
-    <dgm:style>
-      <a:lnRef idx="2">
-        <a:scrgbClr r="0" g="0" b="0"/>
-      </a:lnRef>
-      <a:fillRef idx="1">
-        <a:scrgbClr r="0" g="0" b="0"/>
-      </a:fillRef>
-      <a:effectRef idx="0">
-        <a:scrgbClr r="0" g="0" b="0"/>
-      </a:effectRef>
-      <a:fontRef idx="minor"/>
-    </dgm:style>
-  </dgm:styleLbl>
-  <dgm:styleLbl name="revTx">
-    <dgm:scene3d>
-      <a:camera prst="orthographicFront"/>
-      <a:lightRig rig="threePt" dir="t"/>
-    </dgm:scene3d>
-    <dgm:sp3d/>
-    <dgm:txPr/>
-    <dgm:style>
-      <a:lnRef idx="0">
-        <a:scrgbClr r="0" g="0" b="0"/>
-      </a:lnRef>
-      <a:fillRef idx="0">
-        <a:scrgbClr r="0" g="0" b="0"/>
-      </a:fillRef>
-      <a:effectRef idx="0">
-        <a:scrgbClr r="0" g="0" b="0"/>
-      </a:effectRef>
-      <a:fontRef idx="minor"/>
-    </dgm:style>
-  </dgm:styleLbl>
-</dgm:styleDef>
+      </p:grpSpPr>
+      <p:sp>
+        <p:nvSpPr>
+          <p:cNvPr id="2" name="Folienbildplatzhalter 1"/>
+          <p:cNvSpPr>
+            <a:spLocks noGrp="1" noRot="1" noChangeAspect="1"/>
+          </p:cNvSpPr>
+          <p:nvPr>
+            <p:ph type="sldImg"/>
+          </p:nvPr>
+        </p:nvSpPr>
+        <p:spPr/>
+      </p:sp>
+      <p:sp>
+        <p:nvSpPr>
+          <p:cNvPr id="3" name="Notizenplatzhalter 2"/>
+          <p:cNvSpPr>
+            <a:spLocks noGrp="1"/>
+          </p:cNvSpPr>
+          <p:nvPr>
+            <p:ph type="body" idx="1"/>
+          </p:nvPr>
+        </p:nvSpPr>
+        <p:spPr/>
+        <p:txBody>
+          <a:bodyPr/>
+          <a:lstStyle/>
+          <a:p>
+            <a:r>
+              <a:rPr lang="de-DE" dirty="0"/>
+              <a:t>Eine kurze Ergänzung zur Persona-Auswahl:</a:t>
+            </a:r>
+            <a:br>
+              <a:rPr lang="de-DE" dirty="0"/>
+            </a:br>
+            <a:r>
+              <a:rPr lang="de-DE" dirty="0"/>
+              <a:t>Da ich mittlerweile selbstständig bin, habe ich bewusst darüber nachgedacht, </a:t>
+            </a:r>
+            <a:r>
+              <a:rPr lang="de-DE" b="1" dirty="0"/>
+              <a:t>zusätzlich auch potenzielle </a:t>
+            </a:r>
+            <a:r>
+              <a:rPr lang="de-DE" b="1" dirty="0" err="1"/>
+              <a:t>Kund:innen</a:t>
+            </a:r>
+            <a:r>
+              <a:rPr lang="de-DE" b="1" dirty="0"/>
+              <a:t> als Persona aufzunehmen</a:t>
+            </a:r>
+            <a:r>
+              <a:rPr lang="de-DE" dirty="0"/>
+              <a:t>.</a:t>
+            </a:r>
+            <a:br>
+              <a:rPr lang="de-DE" dirty="0"/>
+            </a:br>
+            <a:r>
+              <a:rPr lang="de-DE" dirty="0"/>
+              <a:t>Ich habe mich dann </a:t>
+            </a:r>
+            <a:r>
+              <a:rPr lang="de-DE" b="1" dirty="0"/>
+              <a:t>aktiv dagegen entschieden</a:t>
+            </a:r>
+            <a:r>
+              <a:rPr lang="de-DE" dirty="0"/>
+              <a:t>, und zwar aus einem strategischen Grund:</a:t>
+            </a:r>
+            <a:br>
+              <a:rPr lang="de-DE" dirty="0"/>
+            </a:br>
+            <a:r>
+              <a:rPr lang="de-DE" b="1" dirty="0"/>
+              <a:t>Diese Journey </a:t>
+            </a:r>
+            <a:r>
+              <a:rPr lang="de-DE" b="1" dirty="0" err="1"/>
+              <a:t>Map</a:t>
+            </a:r>
+            <a:r>
+              <a:rPr lang="de-DE" b="1" dirty="0"/>
+              <a:t> fokussiert sich bewusst auf die </a:t>
+            </a:r>
+            <a:r>
+              <a:rPr lang="de-DE" b="1" dirty="0" err="1"/>
+              <a:t>Employer</a:t>
+            </a:r>
+            <a:r>
+              <a:rPr lang="de-DE" b="1" dirty="0"/>
+              <a:t>-Perspektive.</a:t>
+            </a:r>
+            <a:br>
+              <a:rPr lang="de-DE" dirty="0"/>
+            </a:br>
+            <a:r>
+              <a:rPr lang="de-DE" dirty="0"/>
+              <a:t>Die </a:t>
+            </a:r>
+            <a:r>
+              <a:rPr lang="de-DE" dirty="0" err="1"/>
+              <a:t>Kund:innen-Journey</a:t>
+            </a:r>
+            <a:r>
+              <a:rPr lang="de-DE" dirty="0"/>
+              <a:t> möchte ich getrennt betrachten und dafür </a:t>
+            </a:r>
+            <a:r>
+              <a:rPr lang="de-DE" b="1" dirty="0"/>
+              <a:t>eine eigene Website aufbauen</a:t>
+            </a:r>
+            <a:r>
+              <a:rPr lang="de-DE" dirty="0"/>
+              <a:t>, die explizit auf </a:t>
+            </a:r>
+            <a:r>
+              <a:rPr lang="de-DE" dirty="0" err="1"/>
+              <a:t>Kund:innenbedürfnisse</a:t>
+            </a:r>
+            <a:r>
+              <a:rPr lang="de-DE" dirty="0"/>
+              <a:t> optimiert ist.</a:t>
+            </a:r>
+            <a:br>
+              <a:rPr lang="de-DE" dirty="0"/>
+            </a:br>
+            <a:r>
+              <a:rPr lang="de-DE" dirty="0"/>
+              <a:t>So vermeide ich Vermischung und kann beide Zielgruppen klar und passgenau adressieren.</a:t>
+            </a:r>
+          </a:p>
+          <a:p>
+            <a:endParaRPr lang="de-DE" dirty="0"/>
+          </a:p>
+          <a:p>
+            <a:endParaRPr lang="de-AT" dirty="0"/>
+          </a:p>
+        </p:txBody>
+      </p:sp>
+      <p:sp>
+        <p:nvSpPr>
+          <p:cNvPr id="4" name="Foliennummernplatzhalter 3"/>
+          <p:cNvSpPr>
+            <a:spLocks noGrp="1"/>
+          </p:cNvSpPr>
+          <p:nvPr>
+            <p:ph type="sldNum" sz="quarter" idx="5"/>
+          </p:nvPr>
+        </p:nvSpPr>
+        <p:spPr/>
+        <p:txBody>
+          <a:bodyPr/>
+          <a:lstStyle/>
+          <a:p>
+            <a:fld id="{9C90ADE1-F86E-471B-96D6-B88192C861AF}" type="slidenum">
+              <a:rPr lang="de-AT" smtClean="0"/>
+              <a:t>1</a:t>
+            </a:fld>
+            <a:endParaRPr lang="de-AT"/>
+          </a:p>
+        </p:txBody>
+      </p:sp>
+    </p:spTree>
+    <p:extLst>
+      <p:ext uri="{BB962C8B-B14F-4D97-AF65-F5344CB8AC3E}">
+        <p14:creationId xmlns:p14="http://schemas.microsoft.com/office/powerpoint/2010/main" val="1399146071"/>
+      </p:ext>
+    </p:extLst>
+  </p:cSld>
+  <p:clrMapOvr>
+    <a:masterClrMapping/>
+  </p:clrMapOvr>
+</p:notes>
 </file>
 
 <file path=ppt/slideLayouts/slideLayout1.xml><?xml version="1.0" encoding="utf-8"?>
@@ -3258,7 +810,7 @@
           <a:p>
             <a:fld id="{56738E68-7B29-43EE-BDF3-C579FC3FA2DE}" type="datetimeFigureOut">
               <a:rPr lang="de-AT" smtClean="0"/>
-              <a:t>07.01.2026</a:t>
+              <a:t>13.01.2026</a:t>
             </a:fld>
             <a:endParaRPr lang="de-AT"/>
           </a:p>
@@ -3458,7 +1010,7 @@
           <a:p>
             <a:fld id="{56738E68-7B29-43EE-BDF3-C579FC3FA2DE}" type="datetimeFigureOut">
               <a:rPr lang="de-AT" smtClean="0"/>
-              <a:t>07.01.2026</a:t>
+              <a:t>13.01.2026</a:t>
             </a:fld>
             <a:endParaRPr lang="de-AT"/>
           </a:p>
@@ -3668,7 +1220,7 @@
           <a:p>
             <a:fld id="{56738E68-7B29-43EE-BDF3-C579FC3FA2DE}" type="datetimeFigureOut">
               <a:rPr lang="de-AT" smtClean="0"/>
-              <a:t>07.01.2026</a:t>
+              <a:t>13.01.2026</a:t>
             </a:fld>
             <a:endParaRPr lang="de-AT"/>
           </a:p>
@@ -3868,7 +1420,7 @@
           <a:p>
             <a:fld id="{56738E68-7B29-43EE-BDF3-C579FC3FA2DE}" type="datetimeFigureOut">
               <a:rPr lang="de-AT" smtClean="0"/>
-              <a:t>07.01.2026</a:t>
+              <a:t>13.01.2026</a:t>
             </a:fld>
             <a:endParaRPr lang="de-AT"/>
           </a:p>
@@ -4144,7 +1696,7 @@
           <a:p>
             <a:fld id="{56738E68-7B29-43EE-BDF3-C579FC3FA2DE}" type="datetimeFigureOut">
               <a:rPr lang="de-AT" smtClean="0"/>
-              <a:t>07.01.2026</a:t>
+              <a:t>13.01.2026</a:t>
             </a:fld>
             <a:endParaRPr lang="de-AT"/>
           </a:p>
@@ -4412,7 +1964,7 @@
           <a:p>
             <a:fld id="{56738E68-7B29-43EE-BDF3-C579FC3FA2DE}" type="datetimeFigureOut">
               <a:rPr lang="de-AT" smtClean="0"/>
-              <a:t>07.01.2026</a:t>
+              <a:t>13.01.2026</a:t>
             </a:fld>
             <a:endParaRPr lang="de-AT"/>
           </a:p>
@@ -4827,7 +2379,7 @@
           <a:p>
             <a:fld id="{56738E68-7B29-43EE-BDF3-C579FC3FA2DE}" type="datetimeFigureOut">
               <a:rPr lang="de-AT" smtClean="0"/>
-              <a:t>07.01.2026</a:t>
+              <a:t>13.01.2026</a:t>
             </a:fld>
             <a:endParaRPr lang="de-AT"/>
           </a:p>
@@ -4969,7 +2521,7 @@
           <a:p>
             <a:fld id="{56738E68-7B29-43EE-BDF3-C579FC3FA2DE}" type="datetimeFigureOut">
               <a:rPr lang="de-AT" smtClean="0"/>
-              <a:t>07.01.2026</a:t>
+              <a:t>13.01.2026</a:t>
             </a:fld>
             <a:endParaRPr lang="de-AT"/>
           </a:p>
@@ -5082,7 +2634,7 @@
           <a:p>
             <a:fld id="{56738E68-7B29-43EE-BDF3-C579FC3FA2DE}" type="datetimeFigureOut">
               <a:rPr lang="de-AT" smtClean="0"/>
-              <a:t>07.01.2026</a:t>
+              <a:t>13.01.2026</a:t>
             </a:fld>
             <a:endParaRPr lang="de-AT"/>
           </a:p>
@@ -5395,7 +2947,7 @@
           <a:p>
             <a:fld id="{56738E68-7B29-43EE-BDF3-C579FC3FA2DE}" type="datetimeFigureOut">
               <a:rPr lang="de-AT" smtClean="0"/>
-              <a:t>07.01.2026</a:t>
+              <a:t>13.01.2026</a:t>
             </a:fld>
             <a:endParaRPr lang="de-AT"/>
           </a:p>
@@ -5684,7 +3236,7 @@
           <a:p>
             <a:fld id="{56738E68-7B29-43EE-BDF3-C579FC3FA2DE}" type="datetimeFigureOut">
               <a:rPr lang="de-AT" smtClean="0"/>
-              <a:t>07.01.2026</a:t>
+              <a:t>13.01.2026</a:t>
             </a:fld>
             <a:endParaRPr lang="de-AT"/>
           </a:p>
@@ -5927,7 +3479,7 @@
           <a:p>
             <a:fld id="{56738E68-7B29-43EE-BDF3-C579FC3FA2DE}" type="datetimeFigureOut">
               <a:rPr lang="de-AT" smtClean="0"/>
-              <a:t>07.01.2026</a:t>
+              <a:t>13.01.2026</a:t>
             </a:fld>
             <a:endParaRPr lang="de-AT"/>
           </a:p>
@@ -6344,20 +3896,57 @@
           <a:chExt cx="0" cy="0"/>
         </a:xfrm>
       </p:grpSpPr>
+      <p:pic>
+        <p:nvPicPr>
+          <p:cNvPr id="3" name="Grafik 2" descr="Ein Bild, das Text, Screenshot, Schrift, Zahl enthält.&#10;&#10;KI-generierte Inhalte können fehlerhaft sein.">
+            <a:extLst>
+              <a:ext uri="{FF2B5EF4-FFF2-40B4-BE49-F238E27FC236}">
+                <a16:creationId xmlns:a16="http://schemas.microsoft.com/office/drawing/2014/main" id="{91B4996E-099D-B974-E310-AA8CDD347150}"/>
+              </a:ext>
+            </a:extLst>
+          </p:cNvPr>
+          <p:cNvPicPr>
+            <a:picLocks noChangeAspect="1"/>
+          </p:cNvPicPr>
+          <p:nvPr/>
+        </p:nvPicPr>
+        <p:blipFill>
+          <a:blip r:embed="rId3">
+            <a:extLst>
+              <a:ext uri="{28A0092B-C50C-407E-A947-70E740481C1C}">
+                <a14:useLocalDpi xmlns:a14="http://schemas.microsoft.com/office/drawing/2010/main" val="0"/>
+              </a:ext>
+            </a:extLst>
+          </a:blip>
+          <a:srcRect t="11868" b="28205"/>
+          <a:stretch>
+            <a:fillRect/>
+          </a:stretch>
+        </p:blipFill>
+        <p:spPr>
+          <a:xfrm>
+            <a:off x="952500" y="1690688"/>
+            <a:ext cx="10287000" cy="4109776"/>
+          </a:xfrm>
+          <a:prstGeom prst="rect">
+            <a:avLst/>
+          </a:prstGeom>
+        </p:spPr>
+      </p:pic>
       <p:sp>
         <p:nvSpPr>
           <p:cNvPr id="2" name="Titel 1">
             <a:extLst>
               <a:ext uri="{FF2B5EF4-FFF2-40B4-BE49-F238E27FC236}">
-                <a16:creationId xmlns:a16="http://schemas.microsoft.com/office/drawing/2014/main" id="{9DA51346-DCE1-36A2-212B-170EF4B9D66C}"/>
-              </a:ext>
-            </a:extLst>
-          </p:cNvPr>
-          <p:cNvSpPr>
-            <a:spLocks noGrp="1"/>
-          </p:cNvSpPr>
-          <p:nvPr>
-            <p:ph type="ctrTitle"/>
+                <a16:creationId xmlns:a16="http://schemas.microsoft.com/office/drawing/2014/main" id="{BCDF2627-7FFE-1BDC-59E4-2787184EF128}"/>
+              </a:ext>
+            </a:extLst>
+          </p:cNvPr>
+          <p:cNvSpPr>
+            <a:spLocks noGrp="1"/>
+          </p:cNvSpPr>
+          <p:nvPr>
+            <p:ph type="title"/>
           </p:nvPr>
         </p:nvSpPr>
         <p:spPr/>
@@ -6365,39 +3954,22 @@
           <a:bodyPr/>
           <a:lstStyle/>
           <a:p>
-            <a:endParaRPr lang="de-AT"/>
-          </a:p>
-        </p:txBody>
-      </p:sp>
-      <p:sp>
-        <p:nvSpPr>
-          <p:cNvPr id="3" name="Untertitel 2">
-            <a:extLst>
-              <a:ext uri="{FF2B5EF4-FFF2-40B4-BE49-F238E27FC236}">
-                <a16:creationId xmlns:a16="http://schemas.microsoft.com/office/drawing/2014/main" id="{66A2B18B-2A32-AD14-F3AF-F7E3327232A0}"/>
-              </a:ext>
-            </a:extLst>
-          </p:cNvPr>
-          <p:cNvSpPr>
-            <a:spLocks noGrp="1"/>
-          </p:cNvSpPr>
-          <p:nvPr>
-            <p:ph type="subTitle" idx="1"/>
-          </p:nvPr>
-        </p:nvSpPr>
-        <p:spPr/>
-        <p:txBody>
-          <a:bodyPr/>
-          <a:lstStyle/>
-          <a:p>
-            <a:endParaRPr lang="de-AT"/>
+            <a:r>
+              <a:rPr lang="de-DE" dirty="0" err="1"/>
+              <a:t>Employer</a:t>
+            </a:r>
+            <a:r>
+              <a:rPr lang="de-DE" dirty="0"/>
+              <a:t> Recruiting Journey</a:t>
+            </a:r>
+            <a:endParaRPr lang="de-AT" dirty="0"/>
           </a:p>
         </p:txBody>
       </p:sp>
     </p:spTree>
     <p:extLst>
       <p:ext uri="{BB962C8B-B14F-4D97-AF65-F5344CB8AC3E}">
-        <p14:creationId xmlns:p14="http://schemas.microsoft.com/office/powerpoint/2010/main" val="1817078277"/>
+        <p14:creationId xmlns:p14="http://schemas.microsoft.com/office/powerpoint/2010/main" val="2103718734"/>
       </p:ext>
     </p:extLst>
   </p:cSld>
@@ -6412,68 +3984,10 @@
   <p:cSld>
     <p:spTree>
       <p:nvGrpSpPr>
-        <p:cNvPr id="1" name=""/>
-        <p:cNvGrpSpPr/>
-        <p:nvPr/>
-      </p:nvGrpSpPr>
-      <p:grpSpPr>
-        <a:xfrm>
-          <a:off x="0" y="0"/>
-          <a:ext cx="0" cy="0"/>
-          <a:chOff x="0" y="0"/>
-          <a:chExt cx="0" cy="0"/>
-        </a:xfrm>
-      </p:grpSpPr>
-      <p:graphicFrame>
-        <p:nvGraphicFramePr>
-          <p:cNvPr id="2" name="Diagramm 1">
-            <a:extLst>
-              <a:ext uri="{FF2B5EF4-FFF2-40B4-BE49-F238E27FC236}">
-                <a16:creationId xmlns:a16="http://schemas.microsoft.com/office/drawing/2014/main" id="{AE36CC02-43A6-3222-B104-C7316456B6D3}"/>
-              </a:ext>
-            </a:extLst>
-          </p:cNvPr>
-          <p:cNvGraphicFramePr/>
-          <p:nvPr>
-            <p:extLst>
-              <p:ext uri="{D42A27DB-BD31-4B8C-83A1-F6EECF244321}">
-                <p14:modId xmlns:p14="http://schemas.microsoft.com/office/powerpoint/2010/main" val="51570714"/>
-              </p:ext>
-            </p:extLst>
-          </p:nvPr>
-        </p:nvGraphicFramePr>
-        <p:xfrm>
-          <a:off x="2032000" y="719666"/>
-          <a:ext cx="8128000" cy="5418667"/>
-        </p:xfrm>
-        <a:graphic>
-          <a:graphicData uri="http://schemas.openxmlformats.org/drawingml/2006/diagram">
-            <dgm:relIds xmlns:dgm="http://schemas.openxmlformats.org/drawingml/2006/diagram" xmlns:r="http://schemas.openxmlformats.org/officeDocument/2006/relationships" r:dm="rId2" r:lo="rId3" r:qs="rId4" r:cs="rId5"/>
-          </a:graphicData>
-        </a:graphic>
-      </p:graphicFrame>
-    </p:spTree>
-    <p:extLst>
-      <p:ext uri="{BB962C8B-B14F-4D97-AF65-F5344CB8AC3E}">
-        <p14:creationId xmlns:p14="http://schemas.microsoft.com/office/powerpoint/2010/main" val="2062604791"/>
-      </p:ext>
-    </p:extLst>
-  </p:cSld>
-  <p:clrMapOvr>
-    <a:masterClrMapping/>
-  </p:clrMapOvr>
-</p:sld>
-</file>
-
-<file path=ppt/slides/slide3.xml><?xml version="1.0" encoding="utf-8"?>
-<p:sld xmlns:a="http://schemas.openxmlformats.org/drawingml/2006/main" xmlns:r="http://schemas.openxmlformats.org/officeDocument/2006/relationships" xmlns:p="http://schemas.openxmlformats.org/presentationml/2006/main">
-  <p:cSld>
-    <p:spTree>
-      <p:nvGrpSpPr>
         <p:cNvPr id="1" name="">
           <a:extLst>
             <a:ext uri="{FF2B5EF4-FFF2-40B4-BE49-F238E27FC236}">
-              <a16:creationId xmlns:a16="http://schemas.microsoft.com/office/drawing/2014/main" id="{1D2F6DB4-B97E-7D37-8034-1F8300F08FBB}"/>
+              <a16:creationId xmlns:a16="http://schemas.microsoft.com/office/drawing/2014/main" id="{BDFCB46A-2146-0D29-2AC2-40343894AA42}"/>
             </a:ext>
           </a:extLst>
         </p:cNvPr>
@@ -6488,42 +4002,12 @@
           <a:chExt cx="0" cy="0"/>
         </a:xfrm>
       </p:grpSpPr>
-    </p:spTree>
-    <p:extLst>
-      <p:ext uri="{BB962C8B-B14F-4D97-AF65-F5344CB8AC3E}">
-        <p14:creationId xmlns:p14="http://schemas.microsoft.com/office/powerpoint/2010/main" val="2008109930"/>
-      </p:ext>
-    </p:extLst>
-  </p:cSld>
-  <p:clrMapOvr>
-    <a:masterClrMapping/>
-  </p:clrMapOvr>
-</p:sld>
-</file>
-
-<file path=ppt/slides/slide4.xml><?xml version="1.0" encoding="utf-8"?>
-<p:sld xmlns:a="http://schemas.openxmlformats.org/drawingml/2006/main" xmlns:r="http://schemas.openxmlformats.org/officeDocument/2006/relationships" xmlns:p="http://schemas.openxmlformats.org/presentationml/2006/main">
-  <p:cSld>
-    <p:spTree>
-      <p:nvGrpSpPr>
-        <p:cNvPr id="1" name=""/>
-        <p:cNvGrpSpPr/>
-        <p:nvPr/>
-      </p:nvGrpSpPr>
-      <p:grpSpPr>
-        <a:xfrm>
-          <a:off x="0" y="0"/>
-          <a:ext cx="0" cy="0"/>
-          <a:chOff x="0" y="0"/>
-          <a:chExt cx="0" cy="0"/>
-        </a:xfrm>
-      </p:grpSpPr>
       <p:sp>
         <p:nvSpPr>
           <p:cNvPr id="2" name="Titel 1">
             <a:extLst>
               <a:ext uri="{FF2B5EF4-FFF2-40B4-BE49-F238E27FC236}">
-                <a16:creationId xmlns:a16="http://schemas.microsoft.com/office/drawing/2014/main" id="{BCDF2627-7FFE-1BDC-59E4-2787184EF128}"/>
+                <a16:creationId xmlns:a16="http://schemas.microsoft.com/office/drawing/2014/main" id="{CB533872-1A33-C16F-785F-627944A6DA96}"/>
               </a:ext>
             </a:extLst>
           </p:cNvPr>
@@ -6552,7 +4036,7 @@
           <p:cNvPr id="9" name="Gruppieren 8">
             <a:extLst>
               <a:ext uri="{FF2B5EF4-FFF2-40B4-BE49-F238E27FC236}">
-                <a16:creationId xmlns:a16="http://schemas.microsoft.com/office/drawing/2014/main" id="{19EC45C4-DCD4-7458-DED6-8FD04094DC92}"/>
+                <a16:creationId xmlns:a16="http://schemas.microsoft.com/office/drawing/2014/main" id="{F516141F-EFF6-2838-5553-997401CD0517}"/>
               </a:ext>
             </a:extLst>
           </p:cNvPr>
@@ -6572,7 +4056,7 @@
             <p:cNvPr id="4" name="Ellipse 3">
               <a:extLst>
                 <a:ext uri="{FF2B5EF4-FFF2-40B4-BE49-F238E27FC236}">
-                  <a16:creationId xmlns:a16="http://schemas.microsoft.com/office/drawing/2014/main" id="{1E796E30-7ED4-811D-FE53-D1AB591060F0}"/>
+                  <a16:creationId xmlns:a16="http://schemas.microsoft.com/office/drawing/2014/main" id="{1B54918F-8E19-0A83-CF5C-F4252D021998}"/>
                 </a:ext>
               </a:extLst>
             </p:cNvPr>
@@ -6624,7 +4108,7 @@
             <p:cNvPr id="5" name="Ellipse 4">
               <a:extLst>
                 <a:ext uri="{FF2B5EF4-FFF2-40B4-BE49-F238E27FC236}">
-                  <a16:creationId xmlns:a16="http://schemas.microsoft.com/office/drawing/2014/main" id="{6F35247A-E68F-BD82-21E7-B4C9C4BAF9ED}"/>
+                  <a16:creationId xmlns:a16="http://schemas.microsoft.com/office/drawing/2014/main" id="{48E81293-466E-2A78-6669-295EEBC27383}"/>
                 </a:ext>
               </a:extLst>
             </p:cNvPr>
@@ -6676,7 +4160,7 @@
             <p:cNvPr id="6" name="Ellipse 5">
               <a:extLst>
                 <a:ext uri="{FF2B5EF4-FFF2-40B4-BE49-F238E27FC236}">
-                  <a16:creationId xmlns:a16="http://schemas.microsoft.com/office/drawing/2014/main" id="{29B52AAB-4107-84BD-FB82-7B937BE25744}"/>
+                  <a16:creationId xmlns:a16="http://schemas.microsoft.com/office/drawing/2014/main" id="{C2B3DA2B-1501-23FF-567B-E0A3D7DBDAE3}"/>
                 </a:ext>
               </a:extLst>
             </p:cNvPr>
@@ -6730,7 +4214,7 @@
             <p:cNvPr id="7" name="Ellipse 6">
               <a:extLst>
                 <a:ext uri="{FF2B5EF4-FFF2-40B4-BE49-F238E27FC236}">
-                  <a16:creationId xmlns:a16="http://schemas.microsoft.com/office/drawing/2014/main" id="{FB461292-AF5A-B4A9-7AB2-5CD3609DE2FA}"/>
+                  <a16:creationId xmlns:a16="http://schemas.microsoft.com/office/drawing/2014/main" id="{21B0C97C-2A25-2924-34B2-50848592E0F7}"/>
                 </a:ext>
               </a:extLst>
             </p:cNvPr>
@@ -6782,7 +4266,7 @@
             <p:cNvPr id="8" name="Ellipse 7">
               <a:extLst>
                 <a:ext uri="{FF2B5EF4-FFF2-40B4-BE49-F238E27FC236}">
-                  <a16:creationId xmlns:a16="http://schemas.microsoft.com/office/drawing/2014/main" id="{13176656-AD7B-1776-BEB8-982E3E65F6CA}"/>
+                  <a16:creationId xmlns:a16="http://schemas.microsoft.com/office/drawing/2014/main" id="{9060D828-1AB6-25BC-2FC6-9C300B680D73}"/>
                 </a:ext>
               </a:extLst>
             </p:cNvPr>
@@ -6833,7 +4317,7 @@
     </p:spTree>
     <p:extLst>
       <p:ext uri="{BB962C8B-B14F-4D97-AF65-F5344CB8AC3E}">
-        <p14:creationId xmlns:p14="http://schemas.microsoft.com/office/powerpoint/2010/main" val="2103718734"/>
+        <p14:creationId xmlns:p14="http://schemas.microsoft.com/office/powerpoint/2010/main" val="3697557313"/>
       </p:ext>
     </p:extLst>
   </p:cSld>
@@ -6843,7 +4327,7 @@
 </p:sld>
 </file>
 
-<file path=ppt/slides/slide5.xml><?xml version="1.0" encoding="utf-8"?>
+<file path=ppt/slides/slide3.xml><?xml version="1.0" encoding="utf-8"?>
 <p:sld xmlns:a="http://schemas.openxmlformats.org/drawingml/2006/main" xmlns:r="http://schemas.openxmlformats.org/officeDocument/2006/relationships" xmlns:p="http://schemas.openxmlformats.org/presentationml/2006/main">
   <p:cSld>
     <p:spTree>
@@ -6938,7 +4422,7 @@
 </p:sld>
 </file>
 
-<file path=ppt/slides/slide6.xml><?xml version="1.0" encoding="utf-8"?>
+<file path=ppt/slides/slide4.xml><?xml version="1.0" encoding="utf-8"?>
 <p:sld xmlns:a="http://schemas.openxmlformats.org/drawingml/2006/main" xmlns:r="http://schemas.openxmlformats.org/officeDocument/2006/relationships" xmlns:p="http://schemas.openxmlformats.org/presentationml/2006/main">
   <p:cSld>
     <p:spTree>
@@ -7067,7 +4551,7 @@
 </p:sld>
 </file>
 
-<file path=ppt/slides/slide7.xml><?xml version="1.0" encoding="utf-8"?>
+<file path=ppt/slides/slide5.xml><?xml version="1.0" encoding="utf-8"?>
 <p:sld xmlns:a="http://schemas.openxmlformats.org/drawingml/2006/main" xmlns:r="http://schemas.openxmlformats.org/officeDocument/2006/relationships" xmlns:p="http://schemas.openxmlformats.org/presentationml/2006/main">
   <p:cSld>
     <p:spTree>
@@ -7475,4 +4959,319 @@
     </a:ext>
   </a:extLst>
 </a:theme>
+</file>
+
+<file path=ppt/theme/theme2.xml><?xml version="1.0" encoding="utf-8"?>
+<a:theme xmlns:a="http://schemas.openxmlformats.org/drawingml/2006/main" name="Office">
+  <a:themeElements>
+    <a:clrScheme name="Office">
+      <a:dk1>
+        <a:sysClr val="windowText" lastClr="000000"/>
+      </a:dk1>
+      <a:lt1>
+        <a:sysClr val="window" lastClr="FFFFFF"/>
+      </a:lt1>
+      <a:dk2>
+        <a:srgbClr val="0E2841"/>
+      </a:dk2>
+      <a:lt2>
+        <a:srgbClr val="E8E8E8"/>
+      </a:lt2>
+      <a:accent1>
+        <a:srgbClr val="156082"/>
+      </a:accent1>
+      <a:accent2>
+        <a:srgbClr val="E97132"/>
+      </a:accent2>
+      <a:accent3>
+        <a:srgbClr val="196B24"/>
+      </a:accent3>
+      <a:accent4>
+        <a:srgbClr val="0F9ED5"/>
+      </a:accent4>
+      <a:accent5>
+        <a:srgbClr val="A02B93"/>
+      </a:accent5>
+      <a:accent6>
+        <a:srgbClr val="4EA72E"/>
+      </a:accent6>
+      <a:hlink>
+        <a:srgbClr val="467886"/>
+      </a:hlink>
+      <a:folHlink>
+        <a:srgbClr val="96607D"/>
+      </a:folHlink>
+    </a:clrScheme>
+    <a:fontScheme name="Office">
+      <a:majorFont>
+        <a:latin typeface="Aptos Display" panose="02110004020202020204"/>
+        <a:ea typeface=""/>
+        <a:cs typeface=""/>
+        <a:font script="Jpan" typeface="游ゴシック Light"/>
+        <a:font script="Hang" typeface="맑은 고딕"/>
+        <a:font script="Hans" typeface="等线 Light"/>
+        <a:font script="Hant" typeface="新細明體"/>
+        <a:font script="Arab" typeface="Times New Roman"/>
+        <a:font script="Hebr" typeface="Times New Roman"/>
+        <a:font script="Thai" typeface="Angsana New"/>
+        <a:font script="Ethi" typeface="Nyala"/>
+        <a:font script="Beng" typeface="Vrinda"/>
+        <a:font script="Gujr" typeface="Shruti"/>
+        <a:font script="Khmr" typeface="MoolBoran"/>
+        <a:font script="Knda" typeface="Tunga"/>
+        <a:font script="Guru" typeface="Raavi"/>
+        <a:font script="Cans" typeface="Euphemia"/>
+        <a:font script="Cher" typeface="Plantagenet Cherokee"/>
+        <a:font script="Yiii" typeface="Microsoft Yi Baiti"/>
+        <a:font script="Tibt" typeface="Microsoft Himalaya"/>
+        <a:font script="Thaa" typeface="MV Boli"/>
+        <a:font script="Deva" typeface="Mangal"/>
+        <a:font script="Telu" typeface="Gautami"/>
+        <a:font script="Taml" typeface="Latha"/>
+        <a:font script="Syrc" typeface="Estrangelo Edessa"/>
+        <a:font script="Orya" typeface="Kalinga"/>
+        <a:font script="Mlym" typeface="Kartika"/>
+        <a:font script="Laoo" typeface="DokChampa"/>
+        <a:font script="Sinh" typeface="Iskoola Pota"/>
+        <a:font script="Mong" typeface="Mongolian Baiti"/>
+        <a:font script="Viet" typeface="Times New Roman"/>
+        <a:font script="Uigh" typeface="Microsoft Uighur"/>
+        <a:font script="Geor" typeface="Sylfaen"/>
+        <a:font script="Armn" typeface="Arial"/>
+        <a:font script="Bugi" typeface="Leelawadee UI"/>
+        <a:font script="Bopo" typeface="Microsoft JhengHei"/>
+        <a:font script="Java" typeface="Javanese Text"/>
+        <a:font script="Lisu" typeface="Segoe UI"/>
+        <a:font script="Mymr" typeface="Myanmar Text"/>
+        <a:font script="Nkoo" typeface="Ebrima"/>
+        <a:font script="Olck" typeface="Nirmala UI"/>
+        <a:font script="Osma" typeface="Ebrima"/>
+        <a:font script="Phag" typeface="Phagspa"/>
+        <a:font script="Syrn" typeface="Estrangelo Edessa"/>
+        <a:font script="Syrj" typeface="Estrangelo Edessa"/>
+        <a:font script="Syre" typeface="Estrangelo Edessa"/>
+        <a:font script="Sora" typeface="Nirmala UI"/>
+        <a:font script="Tale" typeface="Microsoft Tai Le"/>
+        <a:font script="Talu" typeface="Microsoft New Tai Lue"/>
+        <a:font script="Tfng" typeface="Ebrima"/>
+      </a:majorFont>
+      <a:minorFont>
+        <a:latin typeface="Aptos" panose="02110004020202020204"/>
+        <a:ea typeface=""/>
+        <a:cs typeface=""/>
+        <a:font script="Jpan" typeface="游ゴシック"/>
+        <a:font script="Hang" typeface="맑은 고딕"/>
+        <a:font script="Hans" typeface="等线"/>
+        <a:font script="Hant" typeface="新細明體"/>
+        <a:font script="Arab" typeface="Arial"/>
+        <a:font script="Hebr" typeface="Arial"/>
+        <a:font script="Thai" typeface="Cordia New"/>
+        <a:font script="Ethi" typeface="Nyala"/>
+        <a:font script="Beng" typeface="Vrinda"/>
+        <a:font script="Gujr" typeface="Shruti"/>
+        <a:font script="Khmr" typeface="DaunPenh"/>
+        <a:font script="Knda" typeface="Tunga"/>
+        <a:font script="Guru" typeface="Raavi"/>
+        <a:font script="Cans" typeface="Euphemia"/>
+        <a:font script="Cher" typeface="Plantagenet Cherokee"/>
+        <a:font script="Yiii" typeface="Microsoft Yi Baiti"/>
+        <a:font script="Tibt" typeface="Microsoft Himalaya"/>
+        <a:font script="Thaa" typeface="MV Boli"/>
+        <a:font script="Deva" typeface="Mangal"/>
+        <a:font script="Telu" typeface="Gautami"/>
+        <a:font script="Taml" typeface="Latha"/>
+        <a:font script="Syrc" typeface="Estrangelo Edessa"/>
+        <a:font script="Orya" typeface="Kalinga"/>
+        <a:font script="Mlym" typeface="Kartika"/>
+        <a:font script="Laoo" typeface="DokChampa"/>
+        <a:font script="Sinh" typeface="Iskoola Pota"/>
+        <a:font script="Mong" typeface="Mongolian Baiti"/>
+        <a:font script="Viet" typeface="Arial"/>
+        <a:font script="Uigh" typeface="Microsoft Uighur"/>
+        <a:font script="Geor" typeface="Sylfaen"/>
+        <a:font script="Armn" typeface="Arial"/>
+        <a:font script="Bugi" typeface="Leelawadee UI"/>
+        <a:font script="Bopo" typeface="Microsoft JhengHei"/>
+        <a:font script="Java" typeface="Javanese Text"/>
+        <a:font script="Lisu" typeface="Segoe UI"/>
+        <a:font script="Mymr" typeface="Myanmar Text"/>
+        <a:font script="Nkoo" typeface="Ebrima"/>
+        <a:font script="Olck" typeface="Nirmala UI"/>
+        <a:font script="Osma" typeface="Ebrima"/>
+        <a:font script="Phag" typeface="Phagspa"/>
+        <a:font script="Syrn" typeface="Estrangelo Edessa"/>
+        <a:font script="Syrj" typeface="Estrangelo Edessa"/>
+        <a:font script="Syre" typeface="Estrangelo Edessa"/>
+        <a:font script="Sora" typeface="Nirmala UI"/>
+        <a:font script="Tale" typeface="Microsoft Tai Le"/>
+        <a:font script="Talu" typeface="Microsoft New Tai Lue"/>
+        <a:font script="Tfng" typeface="Ebrima"/>
+      </a:minorFont>
+    </a:fontScheme>
+    <a:fmtScheme name="Office">
+      <a:fillStyleLst>
+        <a:solidFill>
+          <a:schemeClr val="phClr"/>
+        </a:solidFill>
+        <a:gradFill rotWithShape="1">
+          <a:gsLst>
+            <a:gs pos="0">
+              <a:schemeClr val="phClr">
+                <a:lumMod val="110000"/>
+                <a:satMod val="105000"/>
+                <a:tint val="67000"/>
+              </a:schemeClr>
+            </a:gs>
+            <a:gs pos="50000">
+              <a:schemeClr val="phClr">
+                <a:lumMod val="105000"/>
+                <a:satMod val="103000"/>
+                <a:tint val="73000"/>
+              </a:schemeClr>
+            </a:gs>
+            <a:gs pos="100000">
+              <a:schemeClr val="phClr">
+                <a:lumMod val="105000"/>
+                <a:satMod val="109000"/>
+                <a:tint val="81000"/>
+              </a:schemeClr>
+            </a:gs>
+          </a:gsLst>
+          <a:lin ang="5400000" scaled="0"/>
+        </a:gradFill>
+        <a:gradFill rotWithShape="1">
+          <a:gsLst>
+            <a:gs pos="0">
+              <a:schemeClr val="phClr">
+                <a:satMod val="103000"/>
+                <a:lumMod val="102000"/>
+                <a:tint val="94000"/>
+              </a:schemeClr>
+            </a:gs>
+            <a:gs pos="50000">
+              <a:schemeClr val="phClr">
+                <a:satMod val="110000"/>
+                <a:lumMod val="100000"/>
+                <a:shade val="100000"/>
+              </a:schemeClr>
+            </a:gs>
+            <a:gs pos="100000">
+              <a:schemeClr val="phClr">
+                <a:lumMod val="99000"/>
+                <a:satMod val="120000"/>
+                <a:shade val="78000"/>
+              </a:schemeClr>
+            </a:gs>
+          </a:gsLst>
+          <a:lin ang="5400000" scaled="0"/>
+        </a:gradFill>
+      </a:fillStyleLst>
+      <a:lnStyleLst>
+        <a:ln w="12700" cap="flat" cmpd="sng" algn="ctr">
+          <a:solidFill>
+            <a:schemeClr val="phClr"/>
+          </a:solidFill>
+          <a:prstDash val="solid"/>
+          <a:miter lim="800000"/>
+        </a:ln>
+        <a:ln w="19050" cap="flat" cmpd="sng" algn="ctr">
+          <a:solidFill>
+            <a:schemeClr val="phClr"/>
+          </a:solidFill>
+          <a:prstDash val="solid"/>
+          <a:miter lim="800000"/>
+        </a:ln>
+        <a:ln w="25400" cap="flat" cmpd="sng" algn="ctr">
+          <a:solidFill>
+            <a:schemeClr val="phClr"/>
+          </a:solidFill>
+          <a:prstDash val="solid"/>
+          <a:miter lim="800000"/>
+        </a:ln>
+      </a:lnStyleLst>
+      <a:effectStyleLst>
+        <a:effectStyle>
+          <a:effectLst/>
+        </a:effectStyle>
+        <a:effectStyle>
+          <a:effectLst/>
+        </a:effectStyle>
+        <a:effectStyle>
+          <a:effectLst>
+            <a:outerShdw blurRad="57150" dist="19050" dir="5400000" algn="ctr" rotWithShape="0">
+              <a:srgbClr val="000000">
+                <a:alpha val="63000"/>
+              </a:srgbClr>
+            </a:outerShdw>
+          </a:effectLst>
+        </a:effectStyle>
+      </a:effectStyleLst>
+      <a:bgFillStyleLst>
+        <a:solidFill>
+          <a:schemeClr val="phClr"/>
+        </a:solidFill>
+        <a:solidFill>
+          <a:schemeClr val="phClr">
+            <a:tint val="95000"/>
+            <a:satMod val="170000"/>
+          </a:schemeClr>
+        </a:solidFill>
+        <a:gradFill rotWithShape="1">
+          <a:gsLst>
+            <a:gs pos="0">
+              <a:schemeClr val="phClr">
+                <a:tint val="93000"/>
+                <a:satMod val="150000"/>
+                <a:shade val="98000"/>
+                <a:lumMod val="102000"/>
+              </a:schemeClr>
+            </a:gs>
+            <a:gs pos="50000">
+              <a:schemeClr val="phClr">
+                <a:tint val="98000"/>
+                <a:satMod val="130000"/>
+                <a:shade val="90000"/>
+                <a:lumMod val="103000"/>
+              </a:schemeClr>
+            </a:gs>
+            <a:gs pos="100000">
+              <a:schemeClr val="phClr">
+                <a:shade val="63000"/>
+                <a:satMod val="120000"/>
+              </a:schemeClr>
+            </a:gs>
+          </a:gsLst>
+          <a:lin ang="5400000" scaled="0"/>
+        </a:gradFill>
+      </a:bgFillStyleLst>
+    </a:fmtScheme>
+  </a:themeElements>
+  <a:objectDefaults>
+    <a:lnDef>
+      <a:spPr/>
+      <a:bodyPr/>
+      <a:lstStyle/>
+      <a:style>
+        <a:lnRef idx="2">
+          <a:schemeClr val="accent1"/>
+        </a:lnRef>
+        <a:fillRef idx="0">
+          <a:schemeClr val="accent1"/>
+        </a:fillRef>
+        <a:effectRef idx="1">
+          <a:schemeClr val="accent1"/>
+        </a:effectRef>
+        <a:fontRef idx="minor">
+          <a:schemeClr val="tx1"/>
+        </a:fontRef>
+      </a:style>
+    </a:lnDef>
+  </a:objectDefaults>
+  <a:extraClrSchemeLst/>
+  <a:extLst>
+    <a:ext uri="{05A4C25C-085E-4340-85A3-A5531E510DB2}">
+      <thm15:themeFamily xmlns:thm15="http://schemas.microsoft.com/office/thememl/2012/main" name="Office Theme" id="{2E142A2C-CD16-42D6-873A-C26D2A0506FA}" vid="{1BDDFF52-6CD6-40A5-AB3C-68EB2F1E4D0A}"/>
+    </a:ext>
+  </a:extLst>
+</a:theme>
 </file>
</xml_diff>

<commit_message>
Deploying to gh-pages from @ lydiareiter/fh-creative-portfolio@4591468d4241cb51aa35beaebfaaa68ae904d76d 🚀
</commit_message>
<xml_diff>
--- a/zwischenpräsentation.pptx
+++ b/zwischenpräsentation.pptx
@@ -9,10 +9,10 @@
   </p:notesMasterIdLst>
   <p:sldIdLst>
     <p:sldId id="262" r:id="rId2"/>
-    <p:sldId id="266" r:id="rId3"/>
-    <p:sldId id="263" r:id="rId4"/>
-    <p:sldId id="264" r:id="rId5"/>
-    <p:sldId id="265" r:id="rId6"/>
+    <p:sldId id="265" r:id="rId3"/>
+    <p:sldId id="266" r:id="rId4"/>
+    <p:sldId id="263" r:id="rId5"/>
+    <p:sldId id="264" r:id="rId6"/>
   </p:sldIdLst>
   <p:sldSz cx="12192000" cy="6858000"/>
   <p:notesSz cx="6858000" cy="9144000"/>
@@ -3987,6 +3987,101 @@
         <p:cNvPr id="1" name="">
           <a:extLst>
             <a:ext uri="{FF2B5EF4-FFF2-40B4-BE49-F238E27FC236}">
+              <a16:creationId xmlns:a16="http://schemas.microsoft.com/office/drawing/2014/main" id="{21686174-3274-D7DD-F937-479992E832EE}"/>
+            </a:ext>
+          </a:extLst>
+        </p:cNvPr>
+        <p:cNvGrpSpPr/>
+        <p:nvPr/>
+      </p:nvGrpSpPr>
+      <p:grpSpPr>
+        <a:xfrm>
+          <a:off x="0" y="0"/>
+          <a:ext cx="0" cy="0"/>
+          <a:chOff x="0" y="0"/>
+          <a:chExt cx="0" cy="0"/>
+        </a:xfrm>
+      </p:grpSpPr>
+      <p:sp>
+        <p:nvSpPr>
+          <p:cNvPr id="2" name="Titel 1">
+            <a:extLst>
+              <a:ext uri="{FF2B5EF4-FFF2-40B4-BE49-F238E27FC236}">
+                <a16:creationId xmlns:a16="http://schemas.microsoft.com/office/drawing/2014/main" id="{B1219584-F538-155F-8385-DCCD6D406170}"/>
+              </a:ext>
+            </a:extLst>
+          </p:cNvPr>
+          <p:cNvSpPr>
+            <a:spLocks noGrp="1"/>
+          </p:cNvSpPr>
+          <p:nvPr>
+            <p:ph type="title"/>
+          </p:nvPr>
+        </p:nvSpPr>
+        <p:spPr/>
+        <p:txBody>
+          <a:bodyPr/>
+          <a:lstStyle/>
+          <a:p>
+            <a:r>
+              <a:rPr lang="de-DE" dirty="0"/>
+              <a:t>Kanban Board</a:t>
+            </a:r>
+            <a:endParaRPr lang="de-AT" dirty="0"/>
+          </a:p>
+        </p:txBody>
+      </p:sp>
+      <p:pic>
+        <p:nvPicPr>
+          <p:cNvPr id="10" name="Grafik 9" descr="Ein Bild, das Text, Screenshot, Software, Multimedia-Software enthält.&#10;&#10;KI-generierte Inhalte können fehlerhaft sein.">
+            <a:extLst>
+              <a:ext uri="{FF2B5EF4-FFF2-40B4-BE49-F238E27FC236}">
+                <a16:creationId xmlns:a16="http://schemas.microsoft.com/office/drawing/2014/main" id="{AFFBD959-0BAE-F501-89F5-EBAB879113D1}"/>
+              </a:ext>
+            </a:extLst>
+          </p:cNvPr>
+          <p:cNvPicPr>
+            <a:picLocks noChangeAspect="1"/>
+          </p:cNvPicPr>
+          <p:nvPr/>
+        </p:nvPicPr>
+        <p:blipFill>
+          <a:blip r:embed="rId2"/>
+          <a:stretch>
+            <a:fillRect/>
+          </a:stretch>
+        </p:blipFill>
+        <p:spPr>
+          <a:xfrm>
+            <a:off x="1803679" y="1687310"/>
+            <a:ext cx="8584642" cy="4805565"/>
+          </a:xfrm>
+          <a:prstGeom prst="rect">
+            <a:avLst/>
+          </a:prstGeom>
+        </p:spPr>
+      </p:pic>
+    </p:spTree>
+    <p:extLst>
+      <p:ext uri="{BB962C8B-B14F-4D97-AF65-F5344CB8AC3E}">
+        <p14:creationId xmlns:p14="http://schemas.microsoft.com/office/powerpoint/2010/main" val="3035803949"/>
+      </p:ext>
+    </p:extLst>
+  </p:cSld>
+  <p:clrMapOvr>
+    <a:masterClrMapping/>
+  </p:clrMapOvr>
+</p:sld>
+</file>
+
+<file path=ppt/slides/slide3.xml><?xml version="1.0" encoding="utf-8"?>
+<p:sld xmlns:a="http://schemas.openxmlformats.org/drawingml/2006/main" xmlns:r="http://schemas.openxmlformats.org/officeDocument/2006/relationships" xmlns:p="http://schemas.openxmlformats.org/presentationml/2006/main">
+  <p:cSld>
+    <p:spTree>
+      <p:nvGrpSpPr>
+        <p:cNvPr id="1" name="">
+          <a:extLst>
+            <a:ext uri="{FF2B5EF4-FFF2-40B4-BE49-F238E27FC236}">
               <a16:creationId xmlns:a16="http://schemas.microsoft.com/office/drawing/2014/main" id="{BDFCB46A-2146-0D29-2AC2-40343894AA42}"/>
             </a:ext>
           </a:extLst>
@@ -4327,7 +4422,7 @@
 </p:sld>
 </file>
 
-<file path=ppt/slides/slide3.xml><?xml version="1.0" encoding="utf-8"?>
+<file path=ppt/slides/slide4.xml><?xml version="1.0" encoding="utf-8"?>
 <p:sld xmlns:a="http://schemas.openxmlformats.org/drawingml/2006/main" xmlns:r="http://schemas.openxmlformats.org/officeDocument/2006/relationships" xmlns:p="http://schemas.openxmlformats.org/presentationml/2006/main">
   <p:cSld>
     <p:spTree>
@@ -4422,7 +4517,7 @@
 </p:sld>
 </file>
 
-<file path=ppt/slides/slide4.xml><?xml version="1.0" encoding="utf-8"?>
+<file path=ppt/slides/slide5.xml><?xml version="1.0" encoding="utf-8"?>
 <p:sld xmlns:a="http://schemas.openxmlformats.org/drawingml/2006/main" xmlns:r="http://schemas.openxmlformats.org/officeDocument/2006/relationships" xmlns:p="http://schemas.openxmlformats.org/presentationml/2006/main">
   <p:cSld>
     <p:spTree>
@@ -4542,101 +4637,6 @@
     <p:extLst>
       <p:ext uri="{BB962C8B-B14F-4D97-AF65-F5344CB8AC3E}">
         <p14:creationId xmlns:p14="http://schemas.microsoft.com/office/powerpoint/2010/main" val="2529109707"/>
-      </p:ext>
-    </p:extLst>
-  </p:cSld>
-  <p:clrMapOvr>
-    <a:masterClrMapping/>
-  </p:clrMapOvr>
-</p:sld>
-</file>
-
-<file path=ppt/slides/slide5.xml><?xml version="1.0" encoding="utf-8"?>
-<p:sld xmlns:a="http://schemas.openxmlformats.org/drawingml/2006/main" xmlns:r="http://schemas.openxmlformats.org/officeDocument/2006/relationships" xmlns:p="http://schemas.openxmlformats.org/presentationml/2006/main">
-  <p:cSld>
-    <p:spTree>
-      <p:nvGrpSpPr>
-        <p:cNvPr id="1" name="">
-          <a:extLst>
-            <a:ext uri="{FF2B5EF4-FFF2-40B4-BE49-F238E27FC236}">
-              <a16:creationId xmlns:a16="http://schemas.microsoft.com/office/drawing/2014/main" id="{21686174-3274-D7DD-F937-479992E832EE}"/>
-            </a:ext>
-          </a:extLst>
-        </p:cNvPr>
-        <p:cNvGrpSpPr/>
-        <p:nvPr/>
-      </p:nvGrpSpPr>
-      <p:grpSpPr>
-        <a:xfrm>
-          <a:off x="0" y="0"/>
-          <a:ext cx="0" cy="0"/>
-          <a:chOff x="0" y="0"/>
-          <a:chExt cx="0" cy="0"/>
-        </a:xfrm>
-      </p:grpSpPr>
-      <p:sp>
-        <p:nvSpPr>
-          <p:cNvPr id="2" name="Titel 1">
-            <a:extLst>
-              <a:ext uri="{FF2B5EF4-FFF2-40B4-BE49-F238E27FC236}">
-                <a16:creationId xmlns:a16="http://schemas.microsoft.com/office/drawing/2014/main" id="{B1219584-F538-155F-8385-DCCD6D406170}"/>
-              </a:ext>
-            </a:extLst>
-          </p:cNvPr>
-          <p:cNvSpPr>
-            <a:spLocks noGrp="1"/>
-          </p:cNvSpPr>
-          <p:nvPr>
-            <p:ph type="title"/>
-          </p:nvPr>
-        </p:nvSpPr>
-        <p:spPr/>
-        <p:txBody>
-          <a:bodyPr/>
-          <a:lstStyle/>
-          <a:p>
-            <a:r>
-              <a:rPr lang="de-DE" dirty="0"/>
-              <a:t>Kanban Board</a:t>
-            </a:r>
-            <a:endParaRPr lang="de-AT" dirty="0"/>
-          </a:p>
-        </p:txBody>
-      </p:sp>
-      <p:pic>
-        <p:nvPicPr>
-          <p:cNvPr id="10" name="Grafik 9" descr="Ein Bild, das Text, Screenshot, Software, Multimedia-Software enthält.&#10;&#10;KI-generierte Inhalte können fehlerhaft sein.">
-            <a:extLst>
-              <a:ext uri="{FF2B5EF4-FFF2-40B4-BE49-F238E27FC236}">
-                <a16:creationId xmlns:a16="http://schemas.microsoft.com/office/drawing/2014/main" id="{AFFBD959-0BAE-F501-89F5-EBAB879113D1}"/>
-              </a:ext>
-            </a:extLst>
-          </p:cNvPr>
-          <p:cNvPicPr>
-            <a:picLocks noChangeAspect="1"/>
-          </p:cNvPicPr>
-          <p:nvPr/>
-        </p:nvPicPr>
-        <p:blipFill>
-          <a:blip r:embed="rId2"/>
-          <a:stretch>
-            <a:fillRect/>
-          </a:stretch>
-        </p:blipFill>
-        <p:spPr>
-          <a:xfrm>
-            <a:off x="1803679" y="1687310"/>
-            <a:ext cx="8584642" cy="4805565"/>
-          </a:xfrm>
-          <a:prstGeom prst="rect">
-            <a:avLst/>
-          </a:prstGeom>
-        </p:spPr>
-      </p:pic>
-    </p:spTree>
-    <p:extLst>
-      <p:ext uri="{BB962C8B-B14F-4D97-AF65-F5344CB8AC3E}">
-        <p14:creationId xmlns:p14="http://schemas.microsoft.com/office/powerpoint/2010/main" val="3035803949"/>
       </p:ext>
     </p:extLst>
   </p:cSld>

</xml_diff>